<commit_message>
Add privacy-first AI subscription insights
</commit_message>
<xml_diff>
--- a/deliverables/subscription-cleaning-wanted-ai-championship-2026.pptx
+++ b/deliverables/subscription-cleaning-wanted-ai-championship-2026.pptx
@@ -2,19 +2,19 @@
 <file path=ppt/presentation.xml><?xml version="1.0" encoding="utf-8"?>
 <p:presentation xmlns:p="http://schemas.openxmlformats.org/presentationml/2006/main">
   <p:sldMasterIdLst>
-    <p:sldMasterId xmlns:r="http://schemas.openxmlformats.org/officeDocument/2006/relationships" id="2147483648" r:id="R0cb4705d77fa4522"/>
+    <p:sldMasterId xmlns:r="http://schemas.openxmlformats.org/officeDocument/2006/relationships" id="2147483648" r:id="Ref5f4989fe8b4f52"/>
   </p:sldMasterIdLst>
   <p:notesMasterIdLst>
-    <p:notesMasterId xmlns:r="http://schemas.openxmlformats.org/officeDocument/2006/relationships" r:id="Ra7fc98ed0a34410d"/>
+    <p:notesMasterId xmlns:r="http://schemas.openxmlformats.org/officeDocument/2006/relationships" r:id="R2e72d144afaa490c"/>
   </p:notesMasterIdLst>
   <p:sldIdLst>
-    <p:sldId xmlns:r="http://schemas.openxmlformats.org/officeDocument/2006/relationships" id="256" r:id="R4f8a32410f114473"/>
-    <p:sldId xmlns:r="http://schemas.openxmlformats.org/officeDocument/2006/relationships" id="257" r:id="R3be01427d75f48e3"/>
-    <p:sldId xmlns:r="http://schemas.openxmlformats.org/officeDocument/2006/relationships" id="258" r:id="Rb089388f4cf84cc0"/>
-    <p:sldId xmlns:r="http://schemas.openxmlformats.org/officeDocument/2006/relationships" id="259" r:id="R47a3f850177441f5"/>
-    <p:sldId xmlns:r="http://schemas.openxmlformats.org/officeDocument/2006/relationships" id="260" r:id="Rf5a8efdbb4a64e67"/>
-    <p:sldId xmlns:r="http://schemas.openxmlformats.org/officeDocument/2006/relationships" id="261" r:id="R6c8b852c59874e5e"/>
-    <p:sldId xmlns:r="http://schemas.openxmlformats.org/officeDocument/2006/relationships" id="262" r:id="R30be1c51cf9345a0"/>
+    <p:sldId xmlns:r="http://schemas.openxmlformats.org/officeDocument/2006/relationships" id="256" r:id="Rab77793f9dcf4e68"/>
+    <p:sldId xmlns:r="http://schemas.openxmlformats.org/officeDocument/2006/relationships" id="257" r:id="R4f4ac99af9464b68"/>
+    <p:sldId xmlns:r="http://schemas.openxmlformats.org/officeDocument/2006/relationships" id="258" r:id="R5fb894111c554e7f"/>
+    <p:sldId xmlns:r="http://schemas.openxmlformats.org/officeDocument/2006/relationships" id="259" r:id="R11eb0c7ee25b46e4"/>
+    <p:sldId xmlns:r="http://schemas.openxmlformats.org/officeDocument/2006/relationships" id="260" r:id="R886311ce9ca34679"/>
+    <p:sldId xmlns:r="http://schemas.openxmlformats.org/officeDocument/2006/relationships" id="261" r:id="Rc2ef5a8c82954334"/>
+    <p:sldId xmlns:r="http://schemas.openxmlformats.org/officeDocument/2006/relationships" id="262" r:id="R4e96d94f9b134ade"/>
   </p:sldIdLst>
   <p:sldSz cx="12192000" cy="6858000"/>
   <p:notesSz cx="6858000" cy="9144000"/>
@@ -718,7 +718,7 @@
           <a:lstStyle xmlns:a="http://schemas.openxmlformats.org/drawingml/2006/main"/>
           <a:p xmlns:a="http://schemas.openxmlformats.org/drawingml/2006/main">
             <a:r>
-              <a:t>시연 화면은 샘플 결제내역을 분석한 실제 로컬 실행 결과입니다. 14건에서 5개 후보가 생성되고, 후보 카드의 AI 설명 버튼을 누르면 설명 모달이 열립니다.</a:t>
+              <a:t>시연 화면은 샘플 결제내역을 분석한 실제 로컬 실행 결과입니다. 14건에서 5개 후보가 생성되고, 결제처가 통합·분류됩니다. 후보 카드의 AI 설명 버튼을 누르면 설명 모달이 열립니다.</a:t>
             </a:r>
           </a:p>
           <a:p xmlns:a="http://schemas.openxmlformats.org/drawingml/2006/main">
@@ -918,7 +918,7 @@
           <a:lstStyle xmlns:a="http://schemas.openxmlformats.org/drawingml/2006/main"/>
           <a:p xmlns:a="http://schemas.openxmlformats.org/drawingml/2006/main">
             <a:r>
-              <a:t>AI를 기능 시연으로 끝내지 않고, 사용자가 상태를 바꾸고 절약 목표를 확인하는 행동까지 연결합니다.</a:t>
+              <a:t>AI를 기능 시연으로 끝내지 않고, 결제처 통합과 분류 결과를 사용자의 상태 선택과 절약 목표 확인까지 연결합니다.</a:t>
             </a:r>
           </a:p>
           <a:p xmlns:a="http://schemas.openxmlformats.org/drawingml/2006/main">
@@ -1111,7 +1111,7 @@
   </p:cSld>
   <p:clrMap bg1="lt1" tx1="dk1" bg2="lt2" tx2="dk2" accent1="accent1" accent2="accent2" accent3="accent3" accent4="accent4" accent5="accent5" accent6="accent6" hlink="hlink" folHlink="folHlink"/>
   <p:sldLayoutIdLst>
-    <p:sldLayoutId xmlns:r="http://schemas.openxmlformats.org/officeDocument/2006/relationships" id="2147483649" r:id="R2f10fdee7e0347b7"/>
+    <p:sldLayoutId xmlns:r="http://schemas.openxmlformats.org/officeDocument/2006/relationships" id="2147483649" r:id="R90276e5f6415442d"/>
   </p:sldLayoutIdLst>
   <p:txStyles>
     <p:titleStyle>
@@ -1662,7 +1662,7 @@
           <p:cNvPr id="7" name="">
             <a:extLst xmlns:a="http://schemas.openxmlformats.org/drawingml/2006/main">
               <a:ext uri="{FF2B5EF4-FFF2-40B4-BE49-F238E27FC236}">
-                <a16:creationId xmlns:a16="http://schemas.microsoft.com/office/drawing/2014/main" id="{9B340BFE-CE42-4D92-BD80-7CDDB0642538}"/>
+                <a16:creationId xmlns:a16="http://schemas.microsoft.com/office/drawing/2014/main" id="{69D62F14-2184-40C1-83F8-530EC4B721D3}"/>
               </a:ext>
             </a:extLst>
           </p:cNvPr>
@@ -1695,7 +1695,7 @@
           <p:cNvPr id="2" name="">
             <a:extLst xmlns:a="http://schemas.openxmlformats.org/drawingml/2006/main">
               <a:ext uri="{FF2B5EF4-FFF2-40B4-BE49-F238E27FC236}">
-                <a16:creationId xmlns:a16="http://schemas.microsoft.com/office/drawing/2014/main" id="{F910EF2D-19BE-4451-887F-1B0DCE7CFC91}"/>
+                <a16:creationId xmlns:a16="http://schemas.microsoft.com/office/drawing/2014/main" id="{15C01A5B-AB5C-409F-81B7-7D2E927C2E85}"/>
               </a:ext>
             </a:extLst>
           </p:cNvPr>
@@ -1745,7 +1745,7 @@
           <p:cNvPr id="3" name="">
             <a:extLst xmlns:a="http://schemas.openxmlformats.org/drawingml/2006/main">
               <a:ext uri="{FF2B5EF4-FFF2-40B4-BE49-F238E27FC236}">
-                <a16:creationId xmlns:a16="http://schemas.microsoft.com/office/drawing/2014/main" id="{670C7ED6-C788-4B4F-9DAC-6805DA6E1291}"/>
+                <a16:creationId xmlns:a16="http://schemas.microsoft.com/office/drawing/2014/main" id="{1C92CB16-86AE-4D17-A77E-25B5A0112A14}"/>
               </a:ext>
             </a:extLst>
           </p:cNvPr>
@@ -1812,7 +1812,7 @@
           <p:cNvPr id="4" name="">
             <a:extLst xmlns:a="http://schemas.openxmlformats.org/drawingml/2006/main">
               <a:ext uri="{FF2B5EF4-FFF2-40B4-BE49-F238E27FC236}">
-                <a16:creationId xmlns:a16="http://schemas.microsoft.com/office/drawing/2014/main" id="{C5CE17CE-D183-4A81-BEE1-4748C0EB5DA2}"/>
+                <a16:creationId xmlns:a16="http://schemas.microsoft.com/office/drawing/2014/main" id="{C0E66F0B-7B29-452F-A253-4D0286232E86}"/>
               </a:ext>
             </a:extLst>
           </p:cNvPr>
@@ -1862,7 +1862,7 @@
           <p:cNvPr id="5" name="">
             <a:extLst xmlns:a="http://schemas.openxmlformats.org/drawingml/2006/main">
               <a:ext uri="{FF2B5EF4-FFF2-40B4-BE49-F238E27FC236}">
-                <a16:creationId xmlns:a16="http://schemas.microsoft.com/office/drawing/2014/main" id="{AF6B4CA4-09C4-4B3F-8712-4F3BD102A9C4}"/>
+                <a16:creationId xmlns:a16="http://schemas.microsoft.com/office/drawing/2014/main" id="{A7DCF206-DCC8-40EF-B40B-9C1DC0D79BCC}"/>
               </a:ext>
             </a:extLst>
           </p:cNvPr>
@@ -1901,7 +1901,7 @@
           <p:nvPr/>
         </p:nvPicPr>
         <p:blipFill>
-          <a:blip xmlns:r="http://schemas.openxmlformats.org/officeDocument/2006/relationships" xmlns:a="http://schemas.openxmlformats.org/drawingml/2006/main" r:embed="Ra68277ea22c24bf7"/>
+          <a:blip xmlns:r="http://schemas.openxmlformats.org/officeDocument/2006/relationships" xmlns:a="http://schemas.openxmlformats.org/drawingml/2006/main" r:embed="Rd2d16e3cc1d24366"/>
           <a:stretch xmlns:a="http://schemas.openxmlformats.org/drawingml/2006/main"/>
         </p:blipFill>
         <p:spPr>
@@ -1919,7 +1919,7 @@
     </p:spTree>
     <p:extLst>
       <p:ext uri="{BB962C8B-B14F-4D97-AF65-F5344CB8AC3E}">
-        <p14:creationId xmlns:p14="http://schemas.microsoft.com/office/powerpoint/2010/main" val="1991350253"/>
+        <p14:creationId xmlns:p14="http://schemas.microsoft.com/office/powerpoint/2010/main" val="817198352"/>
       </p:ext>
     </p:extLst>
   </p:cSld>
@@ -1950,7 +1950,7 @@
           <p:cNvPr id="15" name="">
             <a:extLst xmlns:a="http://schemas.openxmlformats.org/drawingml/2006/main">
               <a:ext uri="{FF2B5EF4-FFF2-40B4-BE49-F238E27FC236}">
-                <a16:creationId xmlns:a16="http://schemas.microsoft.com/office/drawing/2014/main" id="{0A98B134-EF07-4069-B890-AA720ECA0D0F}"/>
+                <a16:creationId xmlns:a16="http://schemas.microsoft.com/office/drawing/2014/main" id="{4D3E3438-D7DD-4B3C-ADB8-D3CD0E8C5A01}"/>
               </a:ext>
             </a:extLst>
           </p:cNvPr>
@@ -2000,7 +2000,7 @@
           <p:cNvPr id="2" name="">
             <a:extLst xmlns:a="http://schemas.openxmlformats.org/drawingml/2006/main">
               <a:ext uri="{FF2B5EF4-FFF2-40B4-BE49-F238E27FC236}">
-                <a16:creationId xmlns:a16="http://schemas.microsoft.com/office/drawing/2014/main" id="{C0A2905C-13C7-4AC1-9E7B-5647A95B5CB5}"/>
+                <a16:creationId xmlns:a16="http://schemas.microsoft.com/office/drawing/2014/main" id="{44B1741C-3915-4B18-8091-131902C85C50}"/>
               </a:ext>
             </a:extLst>
           </p:cNvPr>
@@ -2050,7 +2050,7 @@
           <p:cNvPr id="3" name="">
             <a:extLst xmlns:a="http://schemas.openxmlformats.org/drawingml/2006/main">
               <a:ext uri="{FF2B5EF4-FFF2-40B4-BE49-F238E27FC236}">
-                <a16:creationId xmlns:a16="http://schemas.microsoft.com/office/drawing/2014/main" id="{700387D7-ABDC-46C4-AC35-75EA8773A975}"/>
+                <a16:creationId xmlns:a16="http://schemas.microsoft.com/office/drawing/2014/main" id="{37BCE595-96C4-4ADC-88B4-299E518DD9BD}"/>
               </a:ext>
             </a:extLst>
           </p:cNvPr>
@@ -2100,7 +2100,7 @@
           <p:cNvPr id="4" name="">
             <a:extLst xmlns:a="http://schemas.openxmlformats.org/drawingml/2006/main">
               <a:ext uri="{FF2B5EF4-FFF2-40B4-BE49-F238E27FC236}">
-                <a16:creationId xmlns:a16="http://schemas.microsoft.com/office/drawing/2014/main" id="{D5BF6611-5045-4C6F-8782-85432B91A4AA}"/>
+                <a16:creationId xmlns:a16="http://schemas.microsoft.com/office/drawing/2014/main" id="{5AAFF541-EB30-4763-BD44-E65CA9046E78}"/>
               </a:ext>
             </a:extLst>
           </p:cNvPr>
@@ -2167,7 +2167,7 @@
           <p:cNvPr id="5" name="">
             <a:extLst xmlns:a="http://schemas.openxmlformats.org/drawingml/2006/main">
               <a:ext uri="{FF2B5EF4-FFF2-40B4-BE49-F238E27FC236}">
-                <a16:creationId xmlns:a16="http://schemas.microsoft.com/office/drawing/2014/main" id="{00AA5826-9859-41DD-95D6-263647A74DA3}"/>
+                <a16:creationId xmlns:a16="http://schemas.microsoft.com/office/drawing/2014/main" id="{22F4385E-6888-4A2B-9EE5-CFA8858D567A}"/>
               </a:ext>
             </a:extLst>
           </p:cNvPr>
@@ -2202,7 +2202,7 @@
           <p:cNvPr id="6" name="">
             <a:extLst xmlns:a="http://schemas.openxmlformats.org/drawingml/2006/main">
               <a:ext uri="{FF2B5EF4-FFF2-40B4-BE49-F238E27FC236}">
-                <a16:creationId xmlns:a16="http://schemas.microsoft.com/office/drawing/2014/main" id="{A42B6064-BA5A-4539-843A-ABD245B56A14}"/>
+                <a16:creationId xmlns:a16="http://schemas.microsoft.com/office/drawing/2014/main" id="{8BA57B0E-E0A6-4F74-8E4A-0453E996DA95}"/>
               </a:ext>
             </a:extLst>
           </p:cNvPr>
@@ -2252,7 +2252,7 @@
           <p:cNvPr id="7" name="">
             <a:extLst xmlns:a="http://schemas.openxmlformats.org/drawingml/2006/main">
               <a:ext uri="{FF2B5EF4-FFF2-40B4-BE49-F238E27FC236}">
-                <a16:creationId xmlns:a16="http://schemas.microsoft.com/office/drawing/2014/main" id="{F9D87090-07FE-4F02-845F-18D7511C6053}"/>
+                <a16:creationId xmlns:a16="http://schemas.microsoft.com/office/drawing/2014/main" id="{73072031-C413-4D47-A0FB-29C7D900309A}"/>
               </a:ext>
             </a:extLst>
           </p:cNvPr>
@@ -2336,7 +2336,7 @@
           <p:cNvPr id="8" name="">
             <a:extLst xmlns:a="http://schemas.openxmlformats.org/drawingml/2006/main">
               <a:ext uri="{FF2B5EF4-FFF2-40B4-BE49-F238E27FC236}">
-                <a16:creationId xmlns:a16="http://schemas.microsoft.com/office/drawing/2014/main" id="{9D605C8C-1898-48D7-92EC-51E9A7D3F9A6}"/>
+                <a16:creationId xmlns:a16="http://schemas.microsoft.com/office/drawing/2014/main" id="{1C98FA51-367D-44B6-A15B-A07DE293796F}"/>
               </a:ext>
             </a:extLst>
           </p:cNvPr>
@@ -2371,7 +2371,7 @@
           <p:cNvPr id="9" name="">
             <a:extLst xmlns:a="http://schemas.openxmlformats.org/drawingml/2006/main">
               <a:ext uri="{FF2B5EF4-FFF2-40B4-BE49-F238E27FC236}">
-                <a16:creationId xmlns:a16="http://schemas.microsoft.com/office/drawing/2014/main" id="{18A37B94-88DA-4059-82E5-75D037C30C57}"/>
+                <a16:creationId xmlns:a16="http://schemas.microsoft.com/office/drawing/2014/main" id="{FDC55029-6245-4965-90CD-8B0B572C65C6}"/>
               </a:ext>
             </a:extLst>
           </p:cNvPr>
@@ -2421,7 +2421,7 @@
           <p:cNvPr id="10" name="">
             <a:extLst xmlns:a="http://schemas.openxmlformats.org/drawingml/2006/main">
               <a:ext uri="{FF2B5EF4-FFF2-40B4-BE49-F238E27FC236}">
-                <a16:creationId xmlns:a16="http://schemas.microsoft.com/office/drawing/2014/main" id="{2F6C37E2-3291-430D-9500-5D5955A7BD63}"/>
+                <a16:creationId xmlns:a16="http://schemas.microsoft.com/office/drawing/2014/main" id="{DBE91B59-474B-480A-8D93-085530AFE9E0}"/>
               </a:ext>
             </a:extLst>
           </p:cNvPr>
@@ -2505,7 +2505,7 @@
           <p:cNvPr id="11" name="">
             <a:extLst xmlns:a="http://schemas.openxmlformats.org/drawingml/2006/main">
               <a:ext uri="{FF2B5EF4-FFF2-40B4-BE49-F238E27FC236}">
-                <a16:creationId xmlns:a16="http://schemas.microsoft.com/office/drawing/2014/main" id="{5EE454DF-FE75-4C61-A97E-2B7D325E1D9F}"/>
+                <a16:creationId xmlns:a16="http://schemas.microsoft.com/office/drawing/2014/main" id="{CB84D3E0-36FF-4DDA-B58C-0E87EA312C15}"/>
               </a:ext>
             </a:extLst>
           </p:cNvPr>
@@ -2540,7 +2540,7 @@
           <p:cNvPr id="12" name="">
             <a:extLst xmlns:a="http://schemas.openxmlformats.org/drawingml/2006/main">
               <a:ext uri="{FF2B5EF4-FFF2-40B4-BE49-F238E27FC236}">
-                <a16:creationId xmlns:a16="http://schemas.microsoft.com/office/drawing/2014/main" id="{58AA0DF3-B3AF-4A10-BF7C-D0835350C427}"/>
+                <a16:creationId xmlns:a16="http://schemas.microsoft.com/office/drawing/2014/main" id="{6CD7B78A-D402-4DA8-B73F-C70E030A0192}"/>
               </a:ext>
             </a:extLst>
           </p:cNvPr>
@@ -2590,7 +2590,7 @@
           <p:cNvPr id="13" name="">
             <a:extLst xmlns:a="http://schemas.openxmlformats.org/drawingml/2006/main">
               <a:ext uri="{FF2B5EF4-FFF2-40B4-BE49-F238E27FC236}">
-                <a16:creationId xmlns:a16="http://schemas.microsoft.com/office/drawing/2014/main" id="{3896EFD5-CE33-4B8C-A83F-49E481DBE200}"/>
+                <a16:creationId xmlns:a16="http://schemas.microsoft.com/office/drawing/2014/main" id="{D04CE191-7E12-4756-8C03-9905DD7D5A6F}"/>
               </a:ext>
             </a:extLst>
           </p:cNvPr>
@@ -2674,7 +2674,7 @@
           <p:cNvPr id="14" name="">
             <a:extLst xmlns:a="http://schemas.openxmlformats.org/drawingml/2006/main">
               <a:ext uri="{FF2B5EF4-FFF2-40B4-BE49-F238E27FC236}">
-                <a16:creationId xmlns:a16="http://schemas.microsoft.com/office/drawing/2014/main" id="{AD25A002-1156-4DFA-A892-C77EAA9EE09D}"/>
+                <a16:creationId xmlns:a16="http://schemas.microsoft.com/office/drawing/2014/main" id="{80076BFF-3D8F-48F8-89E4-54AE753EF690}"/>
               </a:ext>
             </a:extLst>
           </p:cNvPr>
@@ -2722,7 +2722,7 @@
     </p:spTree>
     <p:extLst>
       <p:ext uri="{BB962C8B-B14F-4D97-AF65-F5344CB8AC3E}">
-        <p14:creationId xmlns:p14="http://schemas.microsoft.com/office/powerpoint/2010/main" val="613538428"/>
+        <p14:creationId xmlns:p14="http://schemas.microsoft.com/office/powerpoint/2010/main" val="1343881525"/>
       </p:ext>
     </p:extLst>
   </p:cSld>
@@ -2753,7 +2753,7 @@
           <p:cNvPr id="25" name="">
             <a:extLst xmlns:a="http://schemas.openxmlformats.org/drawingml/2006/main">
               <a:ext uri="{FF2B5EF4-FFF2-40B4-BE49-F238E27FC236}">
-                <a16:creationId xmlns:a16="http://schemas.microsoft.com/office/drawing/2014/main" id="{DB080A0C-00B8-495C-A1AC-0AC9D2EEAAD6}"/>
+                <a16:creationId xmlns:a16="http://schemas.microsoft.com/office/drawing/2014/main" id="{844777FE-FAC2-4767-8F53-727C8FAABABE}"/>
               </a:ext>
             </a:extLst>
           </p:cNvPr>
@@ -2803,7 +2803,7 @@
           <p:cNvPr id="2" name="">
             <a:extLst xmlns:a="http://schemas.openxmlformats.org/drawingml/2006/main">
               <a:ext uri="{FF2B5EF4-FFF2-40B4-BE49-F238E27FC236}">
-                <a16:creationId xmlns:a16="http://schemas.microsoft.com/office/drawing/2014/main" id="{E668DD22-CD2C-4E3E-859B-F4489D3C3C5B}"/>
+                <a16:creationId xmlns:a16="http://schemas.microsoft.com/office/drawing/2014/main" id="{B944F5D3-155A-4D02-8350-84E67A2FC44F}"/>
               </a:ext>
             </a:extLst>
           </p:cNvPr>
@@ -2853,7 +2853,7 @@
           <p:cNvPr id="3" name="">
             <a:extLst xmlns:a="http://schemas.openxmlformats.org/drawingml/2006/main">
               <a:ext uri="{FF2B5EF4-FFF2-40B4-BE49-F238E27FC236}">
-                <a16:creationId xmlns:a16="http://schemas.microsoft.com/office/drawing/2014/main" id="{BAB16772-B0F1-4720-8848-3320BB9B1A2E}"/>
+                <a16:creationId xmlns:a16="http://schemas.microsoft.com/office/drawing/2014/main" id="{B2B74B35-3FF7-46D5-AB34-88096C986570}"/>
               </a:ext>
             </a:extLst>
           </p:cNvPr>
@@ -2903,7 +2903,7 @@
           <p:cNvPr id="4" name="">
             <a:extLst xmlns:a="http://schemas.openxmlformats.org/drawingml/2006/main">
               <a:ext uri="{FF2B5EF4-FFF2-40B4-BE49-F238E27FC236}">
-                <a16:creationId xmlns:a16="http://schemas.microsoft.com/office/drawing/2014/main" id="{CCEBCE50-C194-4688-A198-F24FF4AACE0A}"/>
+                <a16:creationId xmlns:a16="http://schemas.microsoft.com/office/drawing/2014/main" id="{18A1C20A-C8FB-4F1E-81D4-6F47653D6A14}"/>
               </a:ext>
             </a:extLst>
           </p:cNvPr>
@@ -2936,7 +2936,7 @@
           <p:cNvPr id="5" name="">
             <a:extLst xmlns:a="http://schemas.openxmlformats.org/drawingml/2006/main">
               <a:ext uri="{FF2B5EF4-FFF2-40B4-BE49-F238E27FC236}">
-                <a16:creationId xmlns:a16="http://schemas.microsoft.com/office/drawing/2014/main" id="{C57AA0BC-D58C-4B96-87C7-79D8C43C3D15}"/>
+                <a16:creationId xmlns:a16="http://schemas.microsoft.com/office/drawing/2014/main" id="{201DF532-890C-4072-876D-BD2C48BEFDAD}"/>
               </a:ext>
             </a:extLst>
           </p:cNvPr>
@@ -2971,7 +2971,7 @@
           <p:cNvPr id="6" name="">
             <a:extLst xmlns:a="http://schemas.openxmlformats.org/drawingml/2006/main">
               <a:ext uri="{FF2B5EF4-FFF2-40B4-BE49-F238E27FC236}">
-                <a16:creationId xmlns:a16="http://schemas.microsoft.com/office/drawing/2014/main" id="{606B6BB2-5B50-4F04-8B2B-BBDA3A968F23}"/>
+                <a16:creationId xmlns:a16="http://schemas.microsoft.com/office/drawing/2014/main" id="{0C7845CC-181B-4E29-869A-FC72D0B3F8AC}"/>
               </a:ext>
             </a:extLst>
           </p:cNvPr>
@@ -3021,7 +3021,7 @@
           <p:cNvPr id="7" name="">
             <a:extLst xmlns:a="http://schemas.openxmlformats.org/drawingml/2006/main">
               <a:ext uri="{FF2B5EF4-FFF2-40B4-BE49-F238E27FC236}">
-                <a16:creationId xmlns:a16="http://schemas.microsoft.com/office/drawing/2014/main" id="{85A4874A-A990-4B44-AF07-C5C657FCAB4A}"/>
+                <a16:creationId xmlns:a16="http://schemas.microsoft.com/office/drawing/2014/main" id="{091CC886-52C3-4F3A-A0A3-6613EE3434DF}"/>
               </a:ext>
             </a:extLst>
           </p:cNvPr>
@@ -3071,7 +3071,7 @@
           <p:cNvPr id="8" name="">
             <a:extLst xmlns:a="http://schemas.openxmlformats.org/drawingml/2006/main">
               <a:ext uri="{FF2B5EF4-FFF2-40B4-BE49-F238E27FC236}">
-                <a16:creationId xmlns:a16="http://schemas.microsoft.com/office/drawing/2014/main" id="{42F2A962-03B4-41DF-9E0B-A1E354FA4392}"/>
+                <a16:creationId xmlns:a16="http://schemas.microsoft.com/office/drawing/2014/main" id="{153CA9FD-C382-47D1-B8DC-9516304BAFF1}"/>
               </a:ext>
             </a:extLst>
           </p:cNvPr>
@@ -3121,7 +3121,7 @@
           <p:cNvPr id="9" name="">
             <a:extLst xmlns:a="http://schemas.openxmlformats.org/drawingml/2006/main">
               <a:ext uri="{FF2B5EF4-FFF2-40B4-BE49-F238E27FC236}">
-                <a16:creationId xmlns:a16="http://schemas.microsoft.com/office/drawing/2014/main" id="{AA1A610E-964B-4131-8AFB-9920ABE96C0B}"/>
+                <a16:creationId xmlns:a16="http://schemas.microsoft.com/office/drawing/2014/main" id="{EB24F09E-8D71-4CFA-8D26-876CD8E4F119}"/>
               </a:ext>
             </a:extLst>
           </p:cNvPr>
@@ -3154,7 +3154,7 @@
           <p:cNvPr id="10" name="">
             <a:extLst xmlns:a="http://schemas.openxmlformats.org/drawingml/2006/main">
               <a:ext uri="{FF2B5EF4-FFF2-40B4-BE49-F238E27FC236}">
-                <a16:creationId xmlns:a16="http://schemas.microsoft.com/office/drawing/2014/main" id="{73BD5B05-CABA-4EBA-943F-69BF4C2E85B7}"/>
+                <a16:creationId xmlns:a16="http://schemas.microsoft.com/office/drawing/2014/main" id="{AD6BB1B5-7B5B-4A5E-A59F-0CE6578BF12C}"/>
               </a:ext>
             </a:extLst>
           </p:cNvPr>
@@ -3189,7 +3189,7 @@
           <p:cNvPr id="11" name="">
             <a:extLst xmlns:a="http://schemas.openxmlformats.org/drawingml/2006/main">
               <a:ext uri="{FF2B5EF4-FFF2-40B4-BE49-F238E27FC236}">
-                <a16:creationId xmlns:a16="http://schemas.microsoft.com/office/drawing/2014/main" id="{C1899CC3-308F-4CBF-A98A-27942B27BFD2}"/>
+                <a16:creationId xmlns:a16="http://schemas.microsoft.com/office/drawing/2014/main" id="{0E7697B6-5EB0-4888-A506-C9DD07F6A090}"/>
               </a:ext>
             </a:extLst>
           </p:cNvPr>
@@ -3239,7 +3239,7 @@
           <p:cNvPr id="12" name="">
             <a:extLst xmlns:a="http://schemas.openxmlformats.org/drawingml/2006/main">
               <a:ext uri="{FF2B5EF4-FFF2-40B4-BE49-F238E27FC236}">
-                <a16:creationId xmlns:a16="http://schemas.microsoft.com/office/drawing/2014/main" id="{50DA0959-0F5A-4E26-8472-E64E3E4A179E}"/>
+                <a16:creationId xmlns:a16="http://schemas.microsoft.com/office/drawing/2014/main" id="{B69CE269-232C-4567-9193-3B160791801D}"/>
               </a:ext>
             </a:extLst>
           </p:cNvPr>
@@ -3279,7 +3279,7 @@
                   <a:srgbClr val="13251F"/>
                 </a:solidFill>
               </a:rPr>
-              <a:t>추출</a:t>
+              <a:t>통합</a:t>
             </a:r>
           </a:p>
         </p:txBody>
@@ -3289,7 +3289,7 @@
           <p:cNvPr id="13" name="">
             <a:extLst xmlns:a="http://schemas.openxmlformats.org/drawingml/2006/main">
               <a:ext uri="{FF2B5EF4-FFF2-40B4-BE49-F238E27FC236}">
-                <a16:creationId xmlns:a16="http://schemas.microsoft.com/office/drawing/2014/main" id="{4AE79DD8-E7D5-4585-A6D4-81A09779F37C}"/>
+                <a16:creationId xmlns:a16="http://schemas.microsoft.com/office/drawing/2014/main" id="{74AC0E54-7B53-47B8-88C2-D6C101FAA5B3}"/>
               </a:ext>
             </a:extLst>
           </p:cNvPr>
@@ -3329,7 +3329,7 @@
                   <a:srgbClr val="63756E"/>
                 </a:solidFill>
               </a:rPr>
-              <a:t>날짜·결제처·금액</a:t>
+              <a:t>APPLE.COM/BILL → Apple</a:t>
             </a:r>
           </a:p>
         </p:txBody>
@@ -3339,7 +3339,7 @@
           <p:cNvPr id="14" name="">
             <a:extLst xmlns:a="http://schemas.openxmlformats.org/drawingml/2006/main">
               <a:ext uri="{FF2B5EF4-FFF2-40B4-BE49-F238E27FC236}">
-                <a16:creationId xmlns:a16="http://schemas.microsoft.com/office/drawing/2014/main" id="{8AA079D8-2E61-47C0-8CB7-F8E3D35DBF56}"/>
+                <a16:creationId xmlns:a16="http://schemas.microsoft.com/office/drawing/2014/main" id="{13521985-29EA-4D27-BF43-83151ABFE9B8}"/>
               </a:ext>
             </a:extLst>
           </p:cNvPr>
@@ -3372,7 +3372,7 @@
           <p:cNvPr id="15" name="">
             <a:extLst xmlns:a="http://schemas.openxmlformats.org/drawingml/2006/main">
               <a:ext uri="{FF2B5EF4-FFF2-40B4-BE49-F238E27FC236}">
-                <a16:creationId xmlns:a16="http://schemas.microsoft.com/office/drawing/2014/main" id="{7A8CB26E-A8AD-4CB6-A7EB-F6C4593F1851}"/>
+                <a16:creationId xmlns:a16="http://schemas.microsoft.com/office/drawing/2014/main" id="{0073A1D7-50D3-46DD-9001-6845A9FF4C25}"/>
               </a:ext>
             </a:extLst>
           </p:cNvPr>
@@ -3407,7 +3407,7 @@
           <p:cNvPr id="16" name="">
             <a:extLst xmlns:a="http://schemas.openxmlformats.org/drawingml/2006/main">
               <a:ext uri="{FF2B5EF4-FFF2-40B4-BE49-F238E27FC236}">
-                <a16:creationId xmlns:a16="http://schemas.microsoft.com/office/drawing/2014/main" id="{0C9BBD7B-B4AE-4A18-B290-F441F004C991}"/>
+                <a16:creationId xmlns:a16="http://schemas.microsoft.com/office/drawing/2014/main" id="{CA75252A-F577-4CE2-B42A-2741349B025B}"/>
               </a:ext>
             </a:extLst>
           </p:cNvPr>
@@ -3457,7 +3457,7 @@
           <p:cNvPr id="17" name="">
             <a:extLst xmlns:a="http://schemas.openxmlformats.org/drawingml/2006/main">
               <a:ext uri="{FF2B5EF4-FFF2-40B4-BE49-F238E27FC236}">
-                <a16:creationId xmlns:a16="http://schemas.microsoft.com/office/drawing/2014/main" id="{5B2801A7-5B16-4482-9D0D-E5AE018EDC58}"/>
+                <a16:creationId xmlns:a16="http://schemas.microsoft.com/office/drawing/2014/main" id="{77933412-A320-4A15-9944-11DB31232CDC}"/>
               </a:ext>
             </a:extLst>
           </p:cNvPr>
@@ -3507,7 +3507,7 @@
           <p:cNvPr id="18" name="">
             <a:extLst xmlns:a="http://schemas.openxmlformats.org/drawingml/2006/main">
               <a:ext uri="{FF2B5EF4-FFF2-40B4-BE49-F238E27FC236}">
-                <a16:creationId xmlns:a16="http://schemas.microsoft.com/office/drawing/2014/main" id="{A2F40904-6993-473E-A235-54F16FBB2178}"/>
+                <a16:creationId xmlns:a16="http://schemas.microsoft.com/office/drawing/2014/main" id="{1EDC7914-3E9E-44DA-A506-A9910123F1D2}"/>
               </a:ext>
             </a:extLst>
           </p:cNvPr>
@@ -3547,7 +3547,7 @@
                   <a:srgbClr val="63756E"/>
                 </a:solidFill>
               </a:rPr>
-              <a:t>반복 주기·신뢰도</a:t>
+              <a:t>분류·주기·신뢰도</a:t>
             </a:r>
           </a:p>
         </p:txBody>
@@ -3557,7 +3557,7 @@
           <p:cNvPr id="19" name="">
             <a:extLst xmlns:a="http://schemas.openxmlformats.org/drawingml/2006/main">
               <a:ext uri="{FF2B5EF4-FFF2-40B4-BE49-F238E27FC236}">
-                <a16:creationId xmlns:a16="http://schemas.microsoft.com/office/drawing/2014/main" id="{063C5E54-B663-4067-99EA-D1E376747CD2}"/>
+                <a16:creationId xmlns:a16="http://schemas.microsoft.com/office/drawing/2014/main" id="{E3FEEFEC-8171-439C-AAB8-F864B0A8217D}"/>
               </a:ext>
             </a:extLst>
           </p:cNvPr>
@@ -3592,7 +3592,7 @@
           <p:cNvPr id="20" name="">
             <a:extLst xmlns:a="http://schemas.openxmlformats.org/drawingml/2006/main">
               <a:ext uri="{FF2B5EF4-FFF2-40B4-BE49-F238E27FC236}">
-                <a16:creationId xmlns:a16="http://schemas.microsoft.com/office/drawing/2014/main" id="{D40B26EC-D040-481B-BA0E-35B34F15DCA7}"/>
+                <a16:creationId xmlns:a16="http://schemas.microsoft.com/office/drawing/2014/main" id="{882F370D-5A35-485F-8138-17A1B09A7810}"/>
               </a:ext>
             </a:extLst>
           </p:cNvPr>
@@ -3642,7 +3642,7 @@
           <p:cNvPr id="21" name="">
             <a:extLst xmlns:a="http://schemas.openxmlformats.org/drawingml/2006/main">
               <a:ext uri="{FF2B5EF4-FFF2-40B4-BE49-F238E27FC236}">
-                <a16:creationId xmlns:a16="http://schemas.microsoft.com/office/drawing/2014/main" id="{8FA7F8F8-4C33-4480-A5B0-27944230B682}"/>
+                <a16:creationId xmlns:a16="http://schemas.microsoft.com/office/drawing/2014/main" id="{9183538B-57FA-49CE-A54F-360958C2AC65}"/>
               </a:ext>
             </a:extLst>
           </p:cNvPr>
@@ -3692,7 +3692,7 @@
           <p:cNvPr id="22" name="">
             <a:extLst xmlns:a="http://schemas.openxmlformats.org/drawingml/2006/main">
               <a:ext uri="{FF2B5EF4-FFF2-40B4-BE49-F238E27FC236}">
-                <a16:creationId xmlns:a16="http://schemas.microsoft.com/office/drawing/2014/main" id="{D0F3F6BC-772E-46BE-AF9A-7CA0E6103102}"/>
+                <a16:creationId xmlns:a16="http://schemas.microsoft.com/office/drawing/2014/main" id="{72710385-EDE0-4B60-ADE2-2E46A8E1233B}"/>
               </a:ext>
             </a:extLst>
           </p:cNvPr>
@@ -3732,7 +3732,7 @@
                   <a:srgbClr val="DFEEE7"/>
                 </a:solidFill>
               </a:rPr>
-              <a:t>유지·해지예정·모름</a:t>
+              <a:t>우선순위·절약액 확인</a:t>
             </a:r>
           </a:p>
         </p:txBody>
@@ -3742,7 +3742,7 @@
           <p:cNvPr id="23" name="">
             <a:extLst xmlns:a="http://schemas.openxmlformats.org/drawingml/2006/main">
               <a:ext uri="{FF2B5EF4-FFF2-40B4-BE49-F238E27FC236}">
-                <a16:creationId xmlns:a16="http://schemas.microsoft.com/office/drawing/2014/main" id="{EA3B90CD-09FB-4154-A18C-E95C660B3A3C}"/>
+                <a16:creationId xmlns:a16="http://schemas.microsoft.com/office/drawing/2014/main" id="{041E9A4E-E602-4BB7-858B-2AE786C5E5BA}"/>
               </a:ext>
             </a:extLst>
           </p:cNvPr>
@@ -3782,7 +3782,7 @@
                   <a:srgbClr val="63756E"/>
                 </a:solidFill>
               </a:rPr>
-              <a:t>기본 분석은 브라우저에서 실행되고, 사용자가 원할 때만 후보 요약값으로 AI 설명을 요청합니다.</a:t>
+              <a:t>기본 분석은 브라우저에서 실행되고, 사용자가 원할 때만 민감정보를 제거한 요약값으로 AI 설명을 요청합니다.</a:t>
             </a:r>
           </a:p>
         </p:txBody>
@@ -3792,7 +3792,7 @@
           <p:cNvPr id="24" name="">
             <a:extLst xmlns:a="http://schemas.openxmlformats.org/drawingml/2006/main">
               <a:ext uri="{FF2B5EF4-FFF2-40B4-BE49-F238E27FC236}">
-                <a16:creationId xmlns:a16="http://schemas.microsoft.com/office/drawing/2014/main" id="{E77C59BD-E876-46D9-AA8A-DF7410C2EE8B}"/>
+                <a16:creationId xmlns:a16="http://schemas.microsoft.com/office/drawing/2014/main" id="{843DE169-A339-4A28-87D7-235E5ED30696}"/>
               </a:ext>
             </a:extLst>
           </p:cNvPr>
@@ -3840,7 +3840,7 @@
     </p:spTree>
     <p:extLst>
       <p:ext uri="{BB962C8B-B14F-4D97-AF65-F5344CB8AC3E}">
-        <p14:creationId xmlns:p14="http://schemas.microsoft.com/office/powerpoint/2010/main" val="1983434311"/>
+        <p14:creationId xmlns:p14="http://schemas.microsoft.com/office/powerpoint/2010/main" val="114061516"/>
       </p:ext>
     </p:extLst>
   </p:cSld>
@@ -3871,7 +3871,7 @@
           <p:cNvPr id="13" name="">
             <a:extLst xmlns:a="http://schemas.openxmlformats.org/drawingml/2006/main">
               <a:ext uri="{FF2B5EF4-FFF2-40B4-BE49-F238E27FC236}">
-                <a16:creationId xmlns:a16="http://schemas.microsoft.com/office/drawing/2014/main" id="{E00B4562-4FE4-4124-B306-FF3DBA23D7E0}"/>
+                <a16:creationId xmlns:a16="http://schemas.microsoft.com/office/drawing/2014/main" id="{F8617849-A7E5-4368-BFA0-9FC65AE956F8}"/>
               </a:ext>
             </a:extLst>
           </p:cNvPr>
@@ -3921,7 +3921,7 @@
           <p:cNvPr id="2" name="">
             <a:extLst xmlns:a="http://schemas.openxmlformats.org/drawingml/2006/main">
               <a:ext uri="{FF2B5EF4-FFF2-40B4-BE49-F238E27FC236}">
-                <a16:creationId xmlns:a16="http://schemas.microsoft.com/office/drawing/2014/main" id="{9782B182-5BEA-454E-BC2C-907BBD509997}"/>
+                <a16:creationId xmlns:a16="http://schemas.microsoft.com/office/drawing/2014/main" id="{08F6DD2E-5CD0-44FA-8813-2047214B4070}"/>
               </a:ext>
             </a:extLst>
           </p:cNvPr>
@@ -3961,7 +3961,7 @@
                   <a:srgbClr val="13251F"/>
                 </a:solidFill>
               </a:rPr>
-              <a:t>14건의 결제내역이 5개 후보와 월 예상액으로 바뀝니다</a:t>
+              <a:t>14건의 결제내역이 5개 후보와 1년 예상액으로 바뀝니다</a:t>
             </a:r>
           </a:p>
         </p:txBody>
@@ -3971,7 +3971,7 @@
           <p:cNvPr id="3" name="">
             <a:extLst xmlns:a="http://schemas.openxmlformats.org/drawingml/2006/main">
               <a:ext uri="{FF2B5EF4-FFF2-40B4-BE49-F238E27FC236}">
-                <a16:creationId xmlns:a16="http://schemas.microsoft.com/office/drawing/2014/main" id="{5B24C0BA-2706-4049-BE70-1456CB3403D5}"/>
+                <a16:creationId xmlns:a16="http://schemas.microsoft.com/office/drawing/2014/main" id="{BCF6575C-63E2-4601-A611-7377EE06B1E3}"/>
               </a:ext>
             </a:extLst>
           </p:cNvPr>
@@ -4021,7 +4021,7 @@
           <p:cNvPr id="4" name="">
             <a:extLst xmlns:a="http://schemas.openxmlformats.org/drawingml/2006/main">
               <a:ext uri="{FF2B5EF4-FFF2-40B4-BE49-F238E27FC236}">
-                <a16:creationId xmlns:a16="http://schemas.microsoft.com/office/drawing/2014/main" id="{AA2D3AE8-D1AF-4F85-8F43-5344B6367187}"/>
+                <a16:creationId xmlns:a16="http://schemas.microsoft.com/office/drawing/2014/main" id="{CEDBA894-F8E0-436E-9ED5-20E6CB9227C4}"/>
               </a:ext>
             </a:extLst>
           </p:cNvPr>
@@ -4071,7 +4071,7 @@
           <p:cNvPr id="5" name="">
             <a:extLst xmlns:a="http://schemas.openxmlformats.org/drawingml/2006/main">
               <a:ext uri="{FF2B5EF4-FFF2-40B4-BE49-F238E27FC236}">
-                <a16:creationId xmlns:a16="http://schemas.microsoft.com/office/drawing/2014/main" id="{8CA33547-E875-4B38-AF10-CBB83CA96C8A}"/>
+                <a16:creationId xmlns:a16="http://schemas.microsoft.com/office/drawing/2014/main" id="{9693B954-5FC1-4C0D-9A51-63C644F9D5FB}"/>
               </a:ext>
             </a:extLst>
           </p:cNvPr>
@@ -4121,7 +4121,7 @@
           <p:cNvPr id="6" name="">
             <a:extLst xmlns:a="http://schemas.openxmlformats.org/drawingml/2006/main">
               <a:ext uri="{FF2B5EF4-FFF2-40B4-BE49-F238E27FC236}">
-                <a16:creationId xmlns:a16="http://schemas.microsoft.com/office/drawing/2014/main" id="{FE0F6B1F-06AB-4718-A73D-950BCF6ED2CC}"/>
+                <a16:creationId xmlns:a16="http://schemas.microsoft.com/office/drawing/2014/main" id="{8B488EF9-C453-4FF1-AFAB-69DFD1BF9E28}"/>
               </a:ext>
             </a:extLst>
           </p:cNvPr>
@@ -4188,7 +4188,7 @@
           <p:cNvPr id="7" name="">
             <a:extLst xmlns:a="http://schemas.openxmlformats.org/drawingml/2006/main">
               <a:ext uri="{FF2B5EF4-FFF2-40B4-BE49-F238E27FC236}">
-                <a16:creationId xmlns:a16="http://schemas.microsoft.com/office/drawing/2014/main" id="{C57CEE89-B5BD-45E3-9489-FD59F965FCB5}"/>
+                <a16:creationId xmlns:a16="http://schemas.microsoft.com/office/drawing/2014/main" id="{F45CF28E-09E9-449E-ABC7-A51FB87187F2}"/>
               </a:ext>
             </a:extLst>
           </p:cNvPr>
@@ -4223,7 +4223,7 @@
           <p:cNvPr id="8" name="">
             <a:extLst xmlns:a="http://schemas.openxmlformats.org/drawingml/2006/main">
               <a:ext uri="{FF2B5EF4-FFF2-40B4-BE49-F238E27FC236}">
-                <a16:creationId xmlns:a16="http://schemas.microsoft.com/office/drawing/2014/main" id="{0C150497-403A-4A95-A601-31831175F7DC}"/>
+                <a16:creationId xmlns:a16="http://schemas.microsoft.com/office/drawing/2014/main" id="{069B465F-8A26-4A66-ABF7-0BA363DF3F55}"/>
               </a:ext>
             </a:extLst>
           </p:cNvPr>
@@ -4273,7 +4273,7 @@
           <p:cNvPr id="9" name="">
             <a:extLst xmlns:a="http://schemas.openxmlformats.org/drawingml/2006/main">
               <a:ext uri="{FF2B5EF4-FFF2-40B4-BE49-F238E27FC236}">
-                <a16:creationId xmlns:a16="http://schemas.microsoft.com/office/drawing/2014/main" id="{F857CAA4-56C9-495E-9936-498524C4C244}"/>
+                <a16:creationId xmlns:a16="http://schemas.microsoft.com/office/drawing/2014/main" id="{B15BE5CF-10EF-4C75-8DC2-F8909C5C9A9E}"/>
               </a:ext>
             </a:extLst>
           </p:cNvPr>
@@ -4313,7 +4313,7 @@
                   <a:srgbClr val="DFEEE7"/>
                 </a:solidFill>
               </a:rPr>
-              <a:t>반복 주기와 다음 예상일을 함께 확인</a:t>
+              <a:t>연 765,480원  ·  반복 주기와 분류 확인</a:t>
             </a:r>
           </a:p>
         </p:txBody>
@@ -4323,7 +4323,7 @@
           <p:cNvPr id="10" name="">
             <a:extLst xmlns:a="http://schemas.openxmlformats.org/drawingml/2006/main">
               <a:ext uri="{FF2B5EF4-FFF2-40B4-BE49-F238E27FC236}">
-                <a16:creationId xmlns:a16="http://schemas.microsoft.com/office/drawing/2014/main" id="{121DFEB5-6750-4D96-83A9-635A3DB5DE57}"/>
+                <a16:creationId xmlns:a16="http://schemas.microsoft.com/office/drawing/2014/main" id="{0E520C96-0B0F-4E86-9669-CB6F37A31093}"/>
               </a:ext>
             </a:extLst>
           </p:cNvPr>
@@ -4362,13 +4362,13 @@
           <p:nvPr/>
         </p:nvPicPr>
         <p:blipFill>
-          <a:blip xmlns:r="http://schemas.openxmlformats.org/officeDocument/2006/relationships" xmlns:a="http://schemas.openxmlformats.org/drawingml/2006/main" r:embed="R6765acbfa8574870"/>
+          <a:blip xmlns:r="http://schemas.openxmlformats.org/officeDocument/2006/relationships" xmlns:a="http://schemas.openxmlformats.org/drawingml/2006/main" r:embed="Raf30da1509e64569"/>
           <a:stretch xmlns:a="http://schemas.openxmlformats.org/drawingml/2006/main"/>
         </p:blipFill>
         <p:spPr>
           <a:xfrm xmlns:a="http://schemas.openxmlformats.org/drawingml/2006/main">
-            <a:off x="5029200" y="2069042"/>
-            <a:ext cx="5562600" cy="3862917"/>
+            <a:off x="5029200" y="2044898"/>
+            <a:ext cx="5562600" cy="3911203"/>
           </a:xfrm>
           <a:prstGeom xmlns:a="http://schemas.openxmlformats.org/drawingml/2006/main" prst="roundRect">
             <a:avLst>
@@ -4382,7 +4382,7 @@
           <p:cNvPr id="12" name="">
             <a:extLst xmlns:a="http://schemas.openxmlformats.org/drawingml/2006/main">
               <a:ext uri="{FF2B5EF4-FFF2-40B4-BE49-F238E27FC236}">
-                <a16:creationId xmlns:a16="http://schemas.microsoft.com/office/drawing/2014/main" id="{E132F8DD-2CB6-4659-83AD-E95030206211}"/>
+                <a16:creationId xmlns:a16="http://schemas.microsoft.com/office/drawing/2014/main" id="{7EA09C3A-313D-42CF-981C-53DAC95B3597}"/>
               </a:ext>
             </a:extLst>
           </p:cNvPr>
@@ -4430,7 +4430,7 @@
     </p:spTree>
     <p:extLst>
       <p:ext uri="{BB962C8B-B14F-4D97-AF65-F5344CB8AC3E}">
-        <p14:creationId xmlns:p14="http://schemas.microsoft.com/office/powerpoint/2010/main" val="778642937"/>
+        <p14:creationId xmlns:p14="http://schemas.microsoft.com/office/powerpoint/2010/main" val="29486254"/>
       </p:ext>
     </p:extLst>
   </p:cSld>
@@ -4461,7 +4461,7 @@
           <p:cNvPr id="17" name="">
             <a:extLst xmlns:a="http://schemas.openxmlformats.org/drawingml/2006/main">
               <a:ext uri="{FF2B5EF4-FFF2-40B4-BE49-F238E27FC236}">
-                <a16:creationId xmlns:a16="http://schemas.microsoft.com/office/drawing/2014/main" id="{AA77AEE6-D10E-4870-A9DC-629E3E83525E}"/>
+                <a16:creationId xmlns:a16="http://schemas.microsoft.com/office/drawing/2014/main" id="{627349D1-1A42-401A-AAE7-D4F7FDD8C447}"/>
               </a:ext>
             </a:extLst>
           </p:cNvPr>
@@ -4511,7 +4511,7 @@
           <p:cNvPr id="2" name="">
             <a:extLst xmlns:a="http://schemas.openxmlformats.org/drawingml/2006/main">
               <a:ext uri="{FF2B5EF4-FFF2-40B4-BE49-F238E27FC236}">
-                <a16:creationId xmlns:a16="http://schemas.microsoft.com/office/drawing/2014/main" id="{6EFE604C-BBD4-44B5-9F1F-90BF887D51E7}"/>
+                <a16:creationId xmlns:a16="http://schemas.microsoft.com/office/drawing/2014/main" id="{52B38468-FAF9-4B6A-A189-DAC02FB955C8}"/>
               </a:ext>
             </a:extLst>
           </p:cNvPr>
@@ -4551,7 +4551,7 @@
                   <a:srgbClr val="13251F"/>
                 </a:solidFill>
               </a:rPr>
-              <a:t>AI는 결제 원문 대신 요약값만 읽습니다</a:t>
+              <a:t>필요한 요약만 읽고, 선택할 때 실행됩니다</a:t>
             </a:r>
           </a:p>
         </p:txBody>
@@ -4561,7 +4561,7 @@
           <p:cNvPr id="3" name="">
             <a:extLst xmlns:a="http://schemas.openxmlformats.org/drawingml/2006/main">
               <a:ext uri="{FF2B5EF4-FFF2-40B4-BE49-F238E27FC236}">
-                <a16:creationId xmlns:a16="http://schemas.microsoft.com/office/drawing/2014/main" id="{86D20DDC-2F37-438E-94D7-00E5A86AC45E}"/>
+                <a16:creationId xmlns:a16="http://schemas.microsoft.com/office/drawing/2014/main" id="{24CEB163-AFC3-48D2-9334-8EB605409F2A}"/>
               </a:ext>
             </a:extLst>
           </p:cNvPr>
@@ -4611,7 +4611,7 @@
           <p:cNvPr id="4" name="">
             <a:extLst xmlns:a="http://schemas.openxmlformats.org/drawingml/2006/main">
               <a:ext uri="{FF2B5EF4-FFF2-40B4-BE49-F238E27FC236}">
-                <a16:creationId xmlns:a16="http://schemas.microsoft.com/office/drawing/2014/main" id="{8A9BB906-8993-4784-952F-A1526A78345F}"/>
+                <a16:creationId xmlns:a16="http://schemas.microsoft.com/office/drawing/2014/main" id="{E68791DF-6EA6-477A-BE8D-A4375FBDEEFE}"/>
               </a:ext>
             </a:extLst>
           </p:cNvPr>
@@ -4646,7 +4646,7 @@
           <p:cNvPr id="5" name="">
             <a:extLst xmlns:a="http://schemas.openxmlformats.org/drawingml/2006/main">
               <a:ext uri="{FF2B5EF4-FFF2-40B4-BE49-F238E27FC236}">
-                <a16:creationId xmlns:a16="http://schemas.microsoft.com/office/drawing/2014/main" id="{00714002-4D98-4E3E-A16F-9BE37B0A615C}"/>
+                <a16:creationId xmlns:a16="http://schemas.microsoft.com/office/drawing/2014/main" id="{4D408B42-E618-4CAD-8348-8565A1F83CB8}"/>
               </a:ext>
             </a:extLst>
           </p:cNvPr>
@@ -4696,7 +4696,7 @@
           <p:cNvPr id="6" name="">
             <a:extLst xmlns:a="http://schemas.openxmlformats.org/drawingml/2006/main">
               <a:ext uri="{FF2B5EF4-FFF2-40B4-BE49-F238E27FC236}">
-                <a16:creationId xmlns:a16="http://schemas.microsoft.com/office/drawing/2014/main" id="{D1CEA730-E5EC-4EC4-9435-C81F8A195AA3}"/>
+                <a16:creationId xmlns:a16="http://schemas.microsoft.com/office/drawing/2014/main" id="{28D4C14E-1F21-4572-806E-3B82A18716F2}"/>
               </a:ext>
             </a:extLst>
           </p:cNvPr>
@@ -4736,7 +4736,7 @@
                   <a:srgbClr val="13251F"/>
                 </a:solidFill>
               </a:rPr>
-              <a:t>원문 입력</a:t>
+              <a:t>결제처 통합·분류</a:t>
             </a:r>
           </a:p>
           <a:p xmlns:a="http://schemas.openxmlformats.org/drawingml/2006/main">
@@ -4753,7 +4753,7 @@
                   <a:srgbClr val="13251F"/>
                 </a:solidFill>
               </a:rPr>
-              <a:t>날짜·결제처·금액</a:t>
+              <a:t>주기·금액·신뢰도</a:t>
             </a:r>
           </a:p>
           <a:p xmlns:a="http://schemas.openxmlformats.org/drawingml/2006/main">
@@ -4770,7 +4770,7 @@
                   <a:srgbClr val="13251F"/>
                 </a:solidFill>
               </a:rPr>
-              <a:t>주기·신뢰도 추출</a:t>
+              <a:t>민감정보 제거</a:t>
             </a:r>
           </a:p>
         </p:txBody>
@@ -4780,7 +4780,7 @@
           <p:cNvPr id="7" name="">
             <a:extLst xmlns:a="http://schemas.openxmlformats.org/drawingml/2006/main">
               <a:ext uri="{FF2B5EF4-FFF2-40B4-BE49-F238E27FC236}">
-                <a16:creationId xmlns:a16="http://schemas.microsoft.com/office/drawing/2014/main" id="{9AFF155C-1686-47F8-8AA8-65E4CB98323D}"/>
+                <a16:creationId xmlns:a16="http://schemas.microsoft.com/office/drawing/2014/main" id="{0A2A603E-1A7E-4774-8692-05F49A42EC16}"/>
               </a:ext>
             </a:extLst>
           </p:cNvPr>
@@ -4815,7 +4815,7 @@
           <p:cNvPr id="8" name="">
             <a:extLst xmlns:a="http://schemas.openxmlformats.org/drawingml/2006/main">
               <a:ext uri="{FF2B5EF4-FFF2-40B4-BE49-F238E27FC236}">
-                <a16:creationId xmlns:a16="http://schemas.microsoft.com/office/drawing/2014/main" id="{2F1FBB61-4B08-4320-A2B7-DB5F066280EA}"/>
+                <a16:creationId xmlns:a16="http://schemas.microsoft.com/office/drawing/2014/main" id="{FA530B8F-0AF0-48D7-832F-B07EBCC22098}"/>
               </a:ext>
             </a:extLst>
           </p:cNvPr>
@@ -4865,7 +4865,7 @@
           <p:cNvPr id="9" name="">
             <a:extLst xmlns:a="http://schemas.openxmlformats.org/drawingml/2006/main">
               <a:ext uri="{FF2B5EF4-FFF2-40B4-BE49-F238E27FC236}">
-                <a16:creationId xmlns:a16="http://schemas.microsoft.com/office/drawing/2014/main" id="{874F7EE4-7239-418A-995A-12A9592D9AA9}"/>
+                <a16:creationId xmlns:a16="http://schemas.microsoft.com/office/drawing/2014/main" id="{E1C5384D-FB2B-44E8-9DCD-B21C439E4DE5}"/>
               </a:ext>
             </a:extLst>
           </p:cNvPr>
@@ -4905,7 +4905,7 @@
                   <a:srgbClr val="13251F"/>
                 </a:solidFill>
               </a:rPr>
-              <a:t>API 키 보호</a:t>
+              <a:t>사용자 버튼으로 실행</a:t>
             </a:r>
           </a:p>
           <a:p xmlns:a="http://schemas.openxmlformats.org/drawingml/2006/main">
@@ -4922,26 +4922,26 @@
                   <a:srgbClr val="13251F"/>
                 </a:solidFill>
               </a:rPr>
+              <a:t>API 키 서버 보관</a:t>
+            </a:r>
+          </a:p>
+          <a:p xmlns:a="http://schemas.openxmlformats.org/drawingml/2006/main">
+            <a:pPr algn="l">
+              <a:defRPr sz="1425" b="0" i="0">
+                <a:solidFill>
+                  <a:srgbClr val="13251F"/>
+                </a:solidFill>
+              </a:defRPr>
+            </a:pPr>
+            <a:r>
+              <a:rPr sz="1425" b="0" i="0">
+                <a:solidFill>
+                  <a:srgbClr val="13251F"/>
+                </a:solidFill>
+              </a:rPr>
               <a:t>요약값만 전달</a:t>
             </a:r>
           </a:p>
-          <a:p xmlns:a="http://schemas.openxmlformats.org/drawingml/2006/main">
-            <a:pPr algn="l">
-              <a:defRPr sz="1425" b="0" i="0">
-                <a:solidFill>
-                  <a:srgbClr val="13251F"/>
-                </a:solidFill>
-              </a:defRPr>
-            </a:pPr>
-            <a:r>
-              <a:rPr sz="1425" b="0" i="0">
-                <a:solidFill>
-                  <a:srgbClr val="13251F"/>
-                </a:solidFill>
-              </a:rPr>
-              <a:t>store: false</a:t>
-            </a:r>
-          </a:p>
         </p:txBody>
       </p:sp>
       <p:sp>
@@ -4949,7 +4949,7 @@
           <p:cNvPr id="10" name="">
             <a:extLst xmlns:a="http://schemas.openxmlformats.org/drawingml/2006/main">
               <a:ext uri="{FF2B5EF4-FFF2-40B4-BE49-F238E27FC236}">
-                <a16:creationId xmlns:a16="http://schemas.microsoft.com/office/drawing/2014/main" id="{46152182-06D8-45E9-AEDF-3F049025FD3E}"/>
+                <a16:creationId xmlns:a16="http://schemas.microsoft.com/office/drawing/2014/main" id="{E4DA8A7A-DD2E-4B4A-8C8D-AA9331695FBB}"/>
               </a:ext>
             </a:extLst>
           </p:cNvPr>
@@ -4984,7 +4984,7 @@
           <p:cNvPr id="11" name="">
             <a:extLst xmlns:a="http://schemas.openxmlformats.org/drawingml/2006/main">
               <a:ext uri="{FF2B5EF4-FFF2-40B4-BE49-F238E27FC236}">
-                <a16:creationId xmlns:a16="http://schemas.microsoft.com/office/drawing/2014/main" id="{789974BE-E8AF-4725-B383-F7E5F9C0C0BA}"/>
+                <a16:creationId xmlns:a16="http://schemas.microsoft.com/office/drawing/2014/main" id="{7A29D1EC-2F58-4399-98FA-DD78F7822915}"/>
               </a:ext>
             </a:extLst>
           </p:cNvPr>
@@ -5034,7 +5034,7 @@
           <p:cNvPr id="12" name="">
             <a:extLst xmlns:a="http://schemas.openxmlformats.org/drawingml/2006/main">
               <a:ext uri="{FF2B5EF4-FFF2-40B4-BE49-F238E27FC236}">
-                <a16:creationId xmlns:a16="http://schemas.microsoft.com/office/drawing/2014/main" id="{8D5FE216-D8EC-4746-BDEA-604037CB2006}"/>
+                <a16:creationId xmlns:a16="http://schemas.microsoft.com/office/drawing/2014/main" id="{2161CA59-ED05-4055-BC9C-55A4302A45A5}"/>
               </a:ext>
             </a:extLst>
           </p:cNvPr>
@@ -5074,7 +5074,7 @@
                   <a:srgbClr val="FFFFFF"/>
                 </a:solidFill>
               </a:rPr>
-              <a:t>판단 근거</a:t>
+              <a:t>후보 설명·우선순위</a:t>
             </a:r>
           </a:p>
           <a:p xmlns:a="http://schemas.openxmlformats.org/drawingml/2006/main">
@@ -5091,7 +5091,7 @@
                   <a:srgbClr val="FFFFFF"/>
                 </a:solidFill>
               </a:rPr>
-              <a:t>월 지출 영향</a:t>
+              <a:t>월·1년 절약액</a:t>
             </a:r>
           </a:p>
           <a:p xmlns:a="http://schemas.openxmlformats.org/drawingml/2006/main">
@@ -5118,7 +5118,7 @@
           <p:cNvPr id="13" name="">
             <a:extLst xmlns:a="http://schemas.openxmlformats.org/drawingml/2006/main">
               <a:ext uri="{FF2B5EF4-FFF2-40B4-BE49-F238E27FC236}">
-                <a16:creationId xmlns:a16="http://schemas.microsoft.com/office/drawing/2014/main" id="{414F0556-9F7E-4970-B394-20FDEA3D8319}"/>
+                <a16:creationId xmlns:a16="http://schemas.microsoft.com/office/drawing/2014/main" id="{FBD57438-25F2-4EAB-AF02-4ABCC3FFF356}"/>
               </a:ext>
             </a:extLst>
           </p:cNvPr>
@@ -5158,7 +5158,7 @@
                   <a:srgbClr val="118060"/>
                 </a:solidFill>
               </a:rPr>
-              <a:t>원문 결제내역 전송 없음</a:t>
+              <a:t>원문·카드번호 전송 없음</a:t>
             </a:r>
           </a:p>
         </p:txBody>
@@ -5168,7 +5168,7 @@
           <p:cNvPr id="14" name="">
             <a:extLst xmlns:a="http://schemas.openxmlformats.org/drawingml/2006/main">
               <a:ext uri="{FF2B5EF4-FFF2-40B4-BE49-F238E27FC236}">
-                <a16:creationId xmlns:a16="http://schemas.microsoft.com/office/drawing/2014/main" id="{C6592F1B-9E29-471C-B456-4D2CDF16B86C}"/>
+                <a16:creationId xmlns:a16="http://schemas.microsoft.com/office/drawing/2014/main" id="{BD9ED19E-7DFE-496D-9F67-C9188523304F}"/>
               </a:ext>
             </a:extLst>
           </p:cNvPr>
@@ -5208,7 +5208,7 @@
                   <a:srgbClr val="118060"/>
                 </a:solidFill>
               </a:rPr>
-              <a:t>브라우저에 API 키 노출 없음</a:t>
+              <a:t>AI 분석 하루 5회 · 사용량 표시</a:t>
             </a:r>
           </a:p>
         </p:txBody>
@@ -5218,7 +5218,7 @@
           <p:cNvPr id="15" name="">
             <a:extLst xmlns:a="http://schemas.openxmlformats.org/drawingml/2006/main">
               <a:ext uri="{FF2B5EF4-FFF2-40B4-BE49-F238E27FC236}">
-                <a16:creationId xmlns:a16="http://schemas.microsoft.com/office/drawing/2014/main" id="{17423CC1-5C18-4E58-AC91-063C31F18ED6}"/>
+                <a16:creationId xmlns:a16="http://schemas.microsoft.com/office/drawing/2014/main" id="{865A2A85-7C2C-4060-B72C-41D689262634}"/>
               </a:ext>
             </a:extLst>
           </p:cNvPr>
@@ -5258,7 +5258,7 @@
                   <a:srgbClr val="118060"/>
                 </a:solidFill>
               </a:rPr>
-              <a:t>연결 실패 시 로컬 자동 설명</a:t>
+              <a:t>실패 시 로컬 자동 설명으로 계속</a:t>
             </a:r>
           </a:p>
         </p:txBody>
@@ -5268,7 +5268,7 @@
           <p:cNvPr id="16" name="">
             <a:extLst xmlns:a="http://schemas.openxmlformats.org/drawingml/2006/main">
               <a:ext uri="{FF2B5EF4-FFF2-40B4-BE49-F238E27FC236}">
-                <a16:creationId xmlns:a16="http://schemas.microsoft.com/office/drawing/2014/main" id="{5D3C8939-3040-41FF-9FC7-EE38252F201C}"/>
+                <a16:creationId xmlns:a16="http://schemas.microsoft.com/office/drawing/2014/main" id="{52A6FF4E-4FBC-4150-A5DB-185E0AE2331E}"/>
               </a:ext>
             </a:extLst>
           </p:cNvPr>
@@ -5316,7 +5316,7 @@
     </p:spTree>
     <p:extLst>
       <p:ext uri="{BB962C8B-B14F-4D97-AF65-F5344CB8AC3E}">
-        <p14:creationId xmlns:p14="http://schemas.microsoft.com/office/powerpoint/2010/main" val="874567128"/>
+        <p14:creationId xmlns:p14="http://schemas.microsoft.com/office/powerpoint/2010/main" val="2117564913"/>
       </p:ext>
     </p:extLst>
   </p:cSld>
@@ -5347,7 +5347,7 @@
           <p:cNvPr id="13" name="">
             <a:extLst xmlns:a="http://schemas.openxmlformats.org/drawingml/2006/main">
               <a:ext uri="{FF2B5EF4-FFF2-40B4-BE49-F238E27FC236}">
-                <a16:creationId xmlns:a16="http://schemas.microsoft.com/office/drawing/2014/main" id="{4F667143-9C3A-4DCC-98BD-6B955983DD63}"/>
+                <a16:creationId xmlns:a16="http://schemas.microsoft.com/office/drawing/2014/main" id="{4811CE00-F43B-4E5F-B3F1-B620429BD831}"/>
               </a:ext>
             </a:extLst>
           </p:cNvPr>
@@ -5397,7 +5397,7 @@
           <p:cNvPr id="2" name="">
             <a:extLst xmlns:a="http://schemas.openxmlformats.org/drawingml/2006/main">
               <a:ext uri="{FF2B5EF4-FFF2-40B4-BE49-F238E27FC236}">
-                <a16:creationId xmlns:a16="http://schemas.microsoft.com/office/drawing/2014/main" id="{AC3D9BAD-70E8-4D00-AEF3-D1BCD7D0C327}"/>
+                <a16:creationId xmlns:a16="http://schemas.microsoft.com/office/drawing/2014/main" id="{1A2E6679-DD7C-4FF8-A3B0-E99E43AF7CA4}"/>
               </a:ext>
             </a:extLst>
           </p:cNvPr>
@@ -5437,7 +5437,7 @@
                   <a:srgbClr val="13251F"/>
                 </a:solidFill>
               </a:rPr>
-              <a:t>판단을 설명으로 바꾸면 다음 행동까지 이어집니다</a:t>
+              <a:t>우선순위와 절약액이 다음 행동을 만듭니다</a:t>
             </a:r>
           </a:p>
         </p:txBody>
@@ -5447,7 +5447,7 @@
           <p:cNvPr id="3" name="">
             <a:extLst xmlns:a="http://schemas.openxmlformats.org/drawingml/2006/main">
               <a:ext uri="{FF2B5EF4-FFF2-40B4-BE49-F238E27FC236}">
-                <a16:creationId xmlns:a16="http://schemas.microsoft.com/office/drawing/2014/main" id="{421103A5-775E-491E-AA2D-A6FA509C8E87}"/>
+                <a16:creationId xmlns:a16="http://schemas.microsoft.com/office/drawing/2014/main" id="{665BD110-215D-4818-B189-1974883BCAD8}"/>
               </a:ext>
             </a:extLst>
           </p:cNvPr>
@@ -5497,7 +5497,7 @@
           <p:cNvPr id="4" name="">
             <a:extLst xmlns:a="http://schemas.openxmlformats.org/drawingml/2006/main">
               <a:ext uri="{FF2B5EF4-FFF2-40B4-BE49-F238E27FC236}">
-                <a16:creationId xmlns:a16="http://schemas.microsoft.com/office/drawing/2014/main" id="{9B7F5FB5-80CF-42B3-A672-3B043601971B}"/>
+                <a16:creationId xmlns:a16="http://schemas.microsoft.com/office/drawing/2014/main" id="{C352D24C-6F2D-43BE-88DD-66ABC8730E61}"/>
               </a:ext>
             </a:extLst>
           </p:cNvPr>
@@ -5532,7 +5532,7 @@
           <p:cNvPr id="5" name="">
             <a:extLst xmlns:a="http://schemas.openxmlformats.org/drawingml/2006/main">
               <a:ext uri="{FF2B5EF4-FFF2-40B4-BE49-F238E27FC236}">
-                <a16:creationId xmlns:a16="http://schemas.microsoft.com/office/drawing/2014/main" id="{C40B0767-1FE8-4302-838C-57D25FA969CB}"/>
+                <a16:creationId xmlns:a16="http://schemas.microsoft.com/office/drawing/2014/main" id="{80A91EA3-7ABE-4195-84F7-4EACC5F6A9D1}"/>
               </a:ext>
             </a:extLst>
           </p:cNvPr>
@@ -5582,7 +5582,7 @@
           <p:cNvPr id="6" name="">
             <a:extLst xmlns:a="http://schemas.openxmlformats.org/drawingml/2006/main">
               <a:ext uri="{FF2B5EF4-FFF2-40B4-BE49-F238E27FC236}">
-                <a16:creationId xmlns:a16="http://schemas.microsoft.com/office/drawing/2014/main" id="{FDF6DB86-D163-4484-8BA6-834663065833}"/>
+                <a16:creationId xmlns:a16="http://schemas.microsoft.com/office/drawing/2014/main" id="{7A3A6D6B-97F3-4D26-9EA3-1E03BFA7B61F}"/>
               </a:ext>
             </a:extLst>
           </p:cNvPr>
@@ -5594,30 +5594,30 @@
         <p:spPr>
           <a:xfrm xmlns:a="http://schemas.openxmlformats.org/drawingml/2006/main">
             <a:off x="1028700" y="2914650"/>
-            <a:ext cx="4857750" cy="1181100"/>
-          </a:xfrm>
-          <a:prstGeom xmlns:a="http://schemas.openxmlformats.org/drawingml/2006/main" prst="rect">
-            <a:avLst/>
-          </a:prstGeom>
-          <a:noFill xmlns:a="http://schemas.openxmlformats.org/drawingml/2006/main"/>
-          <a:ln xmlns:a="http://schemas.openxmlformats.org/drawingml/2006/main" w="0">
-            <a:noFill/>
-            <a:prstDash val="solid"/>
-          </a:ln>
-        </p:spPr>
-        <p:txBody>
-          <a:bodyPr xmlns:a="http://schemas.openxmlformats.org/drawingml/2006/main"/>
-          <a:lstStyle xmlns:a="http://schemas.openxmlformats.org/drawingml/2006/main"/>
-          <a:p xmlns:a="http://schemas.openxmlformats.org/drawingml/2006/main">
-            <a:pPr algn="l">
-              <a:defRPr sz="1500" b="1" i="0">
+            <a:ext cx="4857750" cy="1428750"/>
+          </a:xfrm>
+          <a:prstGeom xmlns:a="http://schemas.openxmlformats.org/drawingml/2006/main" prst="rect">
+            <a:avLst/>
+          </a:prstGeom>
+          <a:noFill xmlns:a="http://schemas.openxmlformats.org/drawingml/2006/main"/>
+          <a:ln xmlns:a="http://schemas.openxmlformats.org/drawingml/2006/main" w="0">
+            <a:noFill/>
+            <a:prstDash val="solid"/>
+          </a:ln>
+        </p:spPr>
+        <p:txBody>
+          <a:bodyPr xmlns:a="http://schemas.openxmlformats.org/drawingml/2006/main"/>
+          <a:lstStyle xmlns:a="http://schemas.openxmlformats.org/drawingml/2006/main"/>
+          <a:p xmlns:a="http://schemas.openxmlformats.org/drawingml/2006/main">
+            <a:pPr algn="l">
+              <a:defRPr sz="1350" b="1" i="0">
                 <a:solidFill>
                   <a:srgbClr val="FFFFFF"/>
                 </a:solidFill>
               </a:defRPr>
             </a:pPr>
             <a:r>
-              <a:rPr sz="1500" b="1" i="0">
+              <a:rPr sz="1350" b="1" i="0">
                 <a:solidFill>
                   <a:srgbClr val="FFFFFF"/>
                 </a:solidFill>
@@ -5627,36 +5627,53 @@
           </a:p>
           <a:p xmlns:a="http://schemas.openxmlformats.org/drawingml/2006/main">
             <a:pPr algn="l">
-              <a:defRPr sz="1500" b="1" i="0">
+              <a:defRPr sz="1350" b="1" i="0">
                 <a:solidFill>
                   <a:srgbClr val="FFFFFF"/>
                 </a:solidFill>
               </a:defRPr>
             </a:pPr>
             <a:r>
-              <a:rPr sz="1500" b="1" i="0">
+              <a:rPr sz="1350" b="1" i="0">
                 <a:solidFill>
                   <a:srgbClr val="FFFFFF"/>
                 </a:solidFill>
               </a:rPr>
-              <a:t>영향  월 17,000원이 반복 지출에 포함될 수 있습니다.</a:t>
-            </a:r>
-          </a:p>
-          <a:p xmlns:a="http://schemas.openxmlformats.org/drawingml/2006/main">
-            <a:pPr algn="l">
-              <a:defRPr sz="1500" b="1" i="0">
+              <a:t>영향  월 17,000원 · 1년 204,000원입니다.</a:t>
+            </a:r>
+          </a:p>
+          <a:p xmlns:a="http://schemas.openxmlformats.org/drawingml/2006/main">
+            <a:pPr algn="l">
+              <a:defRPr sz="1350" b="1" i="0">
                 <a:solidFill>
                   <a:srgbClr val="FFFFFF"/>
                 </a:solidFill>
               </a:defRPr>
             </a:pPr>
             <a:r>
-              <a:rPr sz="1500" b="1" i="0">
+              <a:rPr sz="1350" b="1" i="0">
                 <a:solidFill>
                   <a:srgbClr val="FFFFFF"/>
                 </a:solidFill>
               </a:rPr>
-              <a:t>다음 행동  다음 결제 전 실제 이용 여부를 확인하세요.</a:t>
+              <a:t>우선순위  모름 상태라 이용 여부를 먼저 확인하세요.</a:t>
+            </a:r>
+          </a:p>
+          <a:p xmlns:a="http://schemas.openxmlformats.org/drawingml/2006/main">
+            <a:pPr algn="l">
+              <a:defRPr sz="1350" b="1" i="0">
+                <a:solidFill>
+                  <a:srgbClr val="FFFFFF"/>
+                </a:solidFill>
+              </a:defRPr>
+            </a:pPr>
+            <a:r>
+              <a:rPr sz="1350" b="1" i="0">
+                <a:solidFill>
+                  <a:srgbClr val="FFFFFF"/>
+                </a:solidFill>
+              </a:rPr>
+              <a:t>다음 행동  필요하면 해지예정으로 표시하세요.</a:t>
             </a:r>
           </a:p>
         </p:txBody>
@@ -5666,18 +5683,18 @@
           <p:cNvPr id="7" name="">
             <a:extLst xmlns:a="http://schemas.openxmlformats.org/drawingml/2006/main">
               <a:ext uri="{FF2B5EF4-FFF2-40B4-BE49-F238E27FC236}">
-                <a16:creationId xmlns:a16="http://schemas.microsoft.com/office/drawing/2014/main" id="{0740486E-1AD8-4650-9AAE-63509053137C}"/>
-              </a:ext>
-            </a:extLst>
-          </p:cNvPr>
-          <p:cNvSpPr>
-            <a:spLocks xmlns:a="http://schemas.openxmlformats.org/drawingml/2006/main" noGrp="1"/>
-          </p:cNvSpPr>
-          <p:nvPr/>
-        </p:nvSpPr>
-        <p:spPr>
-          <a:xfrm xmlns:a="http://schemas.openxmlformats.org/drawingml/2006/main">
-            <a:off x="1028700" y="4248150"/>
+                <a16:creationId xmlns:a16="http://schemas.microsoft.com/office/drawing/2014/main" id="{2A9FD0E7-B346-46A9-83C8-E3E3DF4369AF}"/>
+              </a:ext>
+            </a:extLst>
+          </p:cNvPr>
+          <p:cNvSpPr>
+            <a:spLocks xmlns:a="http://schemas.openxmlformats.org/drawingml/2006/main" noGrp="1"/>
+          </p:cNvSpPr>
+          <p:nvPr/>
+        </p:nvSpPr>
+        <p:spPr>
+          <a:xfrm xmlns:a="http://schemas.openxmlformats.org/drawingml/2006/main">
+            <a:off x="1028700" y="4610100"/>
             <a:ext cx="4857750" cy="228600"/>
           </a:xfrm>
           <a:prstGeom xmlns:a="http://schemas.openxmlformats.org/drawingml/2006/main" prst="rect">
@@ -5696,14 +5713,14 @@
             <a:pPr algn="l">
               <a:defRPr sz="1125" b="0" i="0">
                 <a:solidFill>
-                  <a:srgbClr val="DFEEE7"/>
+                  <a:srgbClr val="63756E"/>
                 </a:solidFill>
               </a:defRPr>
             </a:pPr>
             <a:r>
               <a:rPr sz="1125" b="0" i="0">
                 <a:solidFill>
-                  <a:srgbClr val="DFEEE7"/>
+                  <a:srgbClr val="63756E"/>
                 </a:solidFill>
               </a:rPr>
               <a:t>참고 정보이며 카드사 조회나 해지 대행이 아닙니다.</a:t>
@@ -5716,7 +5733,7 @@
           <p:cNvPr id="8" name="">
             <a:extLst xmlns:a="http://schemas.openxmlformats.org/drawingml/2006/main">
               <a:ext uri="{FF2B5EF4-FFF2-40B4-BE49-F238E27FC236}">
-                <a16:creationId xmlns:a16="http://schemas.microsoft.com/office/drawing/2014/main" id="{E704476D-79E7-43DE-BDD7-8A589A9231B8}"/>
+                <a16:creationId xmlns:a16="http://schemas.microsoft.com/office/drawing/2014/main" id="{80822021-FF03-4E6A-AFA8-1C0711DE7C12}"/>
               </a:ext>
             </a:extLst>
           </p:cNvPr>
@@ -5766,7 +5783,7 @@
           <p:cNvPr id="9" name="">
             <a:extLst xmlns:a="http://schemas.openxmlformats.org/drawingml/2006/main">
               <a:ext uri="{FF2B5EF4-FFF2-40B4-BE49-F238E27FC236}">
-                <a16:creationId xmlns:a16="http://schemas.microsoft.com/office/drawing/2014/main" id="{5FB0FCFA-4F43-47A2-ABD5-5D4732807016}"/>
+                <a16:creationId xmlns:a16="http://schemas.microsoft.com/office/drawing/2014/main" id="{4FEA68AF-E40B-40FE-9806-876E771905FC}"/>
               </a:ext>
             </a:extLst>
           </p:cNvPr>
@@ -5794,14 +5811,14 @@
           <a:lstStyle xmlns:a="http://schemas.openxmlformats.org/drawingml/2006/main"/>
           <a:p xmlns:a="http://schemas.openxmlformats.org/drawingml/2006/main">
             <a:pPr algn="l">
-              <a:defRPr sz="2250" b="1" i="0">
+              <a:defRPr sz="2100" b="1" i="0">
                 <a:solidFill>
                   <a:srgbClr val="13251F"/>
                 </a:solidFill>
               </a:defRPr>
             </a:pPr>
             <a:r>
-              <a:rPr sz="2250" b="1" i="0">
+              <a:rPr sz="2100" b="1" i="0">
                 <a:solidFill>
                   <a:srgbClr val="13251F"/>
                 </a:solidFill>
@@ -5811,36 +5828,36 @@
           </a:p>
           <a:p xmlns:a="http://schemas.openxmlformats.org/drawingml/2006/main">
             <a:pPr algn="l">
-              <a:defRPr sz="2250" b="1" i="0">
+              <a:defRPr sz="2100" b="1" i="0">
                 <a:solidFill>
                   <a:srgbClr val="13251F"/>
                 </a:solidFill>
               </a:defRPr>
             </a:pPr>
             <a:r>
-              <a:rPr sz="2250" b="1" i="0">
+              <a:rPr sz="2100" b="1" i="0">
                 <a:solidFill>
                   <a:srgbClr val="13251F"/>
                 </a:solidFill>
               </a:rPr>
-              <a:t>예상 절약액과 목표 진행률이</a:t>
-            </a:r>
-          </a:p>
-          <a:p xmlns:a="http://schemas.openxmlformats.org/drawingml/2006/main">
-            <a:pPr algn="l">
-              <a:defRPr sz="2250" b="1" i="0">
+              <a:t>우선순위와 월·1년 절약액,</a:t>
+            </a:r>
+          </a:p>
+          <a:p xmlns:a="http://schemas.openxmlformats.org/drawingml/2006/main">
+            <a:pPr algn="l">
+              <a:defRPr sz="2100" b="1" i="0">
                 <a:solidFill>
                   <a:srgbClr val="13251F"/>
                 </a:solidFill>
               </a:defRPr>
             </a:pPr>
             <a:r>
-              <a:rPr sz="2250" b="1" i="0">
+              <a:rPr sz="2100" b="1" i="0">
                 <a:solidFill>
                   <a:srgbClr val="13251F"/>
                 </a:solidFill>
               </a:rPr>
-              <a:t>즉시 갱신됩니다.</a:t>
+              <a:t>목표 진행률이 즉시 갱신됩니다.</a:t>
             </a:r>
           </a:p>
         </p:txBody>
@@ -5850,7 +5867,7 @@
           <p:cNvPr id="10" name="">
             <a:extLst xmlns:a="http://schemas.openxmlformats.org/drawingml/2006/main">
               <a:ext uri="{FF2B5EF4-FFF2-40B4-BE49-F238E27FC236}">
-                <a16:creationId xmlns:a16="http://schemas.microsoft.com/office/drawing/2014/main" id="{52CEAD9D-1797-41B0-904F-48A52358E904}"/>
+                <a16:creationId xmlns:a16="http://schemas.microsoft.com/office/drawing/2014/main" id="{07279791-C692-4949-B492-181311677D22}"/>
               </a:ext>
             </a:extLst>
           </p:cNvPr>
@@ -5885,7 +5902,7 @@
           <p:cNvPr id="11" name="">
             <a:extLst xmlns:a="http://schemas.openxmlformats.org/drawingml/2006/main">
               <a:ext uri="{FF2B5EF4-FFF2-40B4-BE49-F238E27FC236}">
-                <a16:creationId xmlns:a16="http://schemas.microsoft.com/office/drawing/2014/main" id="{C8CD2C20-BA44-4948-905E-EF29FA8398F6}"/>
+                <a16:creationId xmlns:a16="http://schemas.microsoft.com/office/drawing/2014/main" id="{EE4FDFD6-CABF-4B77-8C08-679D55D9E889}"/>
               </a:ext>
             </a:extLst>
           </p:cNvPr>
@@ -5935,7 +5952,7 @@
           <p:cNvPr id="12" name="">
             <a:extLst xmlns:a="http://schemas.openxmlformats.org/drawingml/2006/main">
               <a:ext uri="{FF2B5EF4-FFF2-40B4-BE49-F238E27FC236}">
-                <a16:creationId xmlns:a16="http://schemas.microsoft.com/office/drawing/2014/main" id="{792A25A2-219E-40D9-B9FC-AE4168BA1CAA}"/>
+                <a16:creationId xmlns:a16="http://schemas.microsoft.com/office/drawing/2014/main" id="{CF055387-7BB9-4E82-821F-686654309892}"/>
               </a:ext>
             </a:extLst>
           </p:cNvPr>
@@ -5983,7 +6000,7 @@
     </p:spTree>
     <p:extLst>
       <p:ext uri="{BB962C8B-B14F-4D97-AF65-F5344CB8AC3E}">
-        <p14:creationId xmlns:p14="http://schemas.microsoft.com/office/powerpoint/2010/main" val="920620888"/>
+        <p14:creationId xmlns:p14="http://schemas.microsoft.com/office/powerpoint/2010/main" val="955849613"/>
       </p:ext>
     </p:extLst>
   </p:cSld>
@@ -6014,7 +6031,7 @@
           <p:cNvPr id="8" name="">
             <a:extLst xmlns:a="http://schemas.openxmlformats.org/drawingml/2006/main">
               <a:ext uri="{FF2B5EF4-FFF2-40B4-BE49-F238E27FC236}">
-                <a16:creationId xmlns:a16="http://schemas.microsoft.com/office/drawing/2014/main" id="{9A694B3F-6029-4748-BF61-4294D0285AB9}"/>
+                <a16:creationId xmlns:a16="http://schemas.microsoft.com/office/drawing/2014/main" id="{3EC18047-86A4-43D5-A740-F5CDB681D206}"/>
               </a:ext>
             </a:extLst>
           </p:cNvPr>
@@ -6064,7 +6081,7 @@
           <p:cNvPr id="2" name="">
             <a:extLst xmlns:a="http://schemas.openxmlformats.org/drawingml/2006/main">
               <a:ext uri="{FF2B5EF4-FFF2-40B4-BE49-F238E27FC236}">
-                <a16:creationId xmlns:a16="http://schemas.microsoft.com/office/drawing/2014/main" id="{0CA803A0-930C-4463-BB62-78EAD349CBD2}"/>
+                <a16:creationId xmlns:a16="http://schemas.microsoft.com/office/drawing/2014/main" id="{FF721EF6-B936-4225-87A9-EC32F6BB9865}"/>
               </a:ext>
             </a:extLst>
           </p:cNvPr>
@@ -6076,52 +6093,52 @@
         <p:spPr>
           <a:xfrm xmlns:a="http://schemas.openxmlformats.org/drawingml/2006/main">
             <a:off x="685800" y="1866900"/>
-            <a:ext cx="6667500" cy="857250"/>
-          </a:xfrm>
-          <a:prstGeom xmlns:a="http://schemas.openxmlformats.org/drawingml/2006/main" prst="rect">
-            <a:avLst/>
-          </a:prstGeom>
-          <a:noFill xmlns:a="http://schemas.openxmlformats.org/drawingml/2006/main"/>
-          <a:ln xmlns:a="http://schemas.openxmlformats.org/drawingml/2006/main" w="0">
-            <a:noFill/>
-            <a:prstDash val="solid"/>
-          </a:ln>
-        </p:spPr>
-        <p:txBody>
-          <a:bodyPr xmlns:a="http://schemas.openxmlformats.org/drawingml/2006/main"/>
-          <a:lstStyle xmlns:a="http://schemas.openxmlformats.org/drawingml/2006/main"/>
-          <a:p xmlns:a="http://schemas.openxmlformats.org/drawingml/2006/main">
-            <a:pPr algn="l">
-              <a:defRPr sz="2100" b="1" i="0">
+            <a:ext cx="7239000" cy="857250"/>
+          </a:xfrm>
+          <a:prstGeom xmlns:a="http://schemas.openxmlformats.org/drawingml/2006/main" prst="rect">
+            <a:avLst/>
+          </a:prstGeom>
+          <a:noFill xmlns:a="http://schemas.openxmlformats.org/drawingml/2006/main"/>
+          <a:ln xmlns:a="http://schemas.openxmlformats.org/drawingml/2006/main" w="0">
+            <a:noFill/>
+            <a:prstDash val="solid"/>
+          </a:ln>
+        </p:spPr>
+        <p:txBody>
+          <a:bodyPr xmlns:a="http://schemas.openxmlformats.org/drawingml/2006/main"/>
+          <a:lstStyle xmlns:a="http://schemas.openxmlformats.org/drawingml/2006/main"/>
+          <a:p xmlns:a="http://schemas.openxmlformats.org/drawingml/2006/main">
+            <a:pPr algn="l">
+              <a:defRPr sz="1950" b="1" i="0">
                 <a:solidFill>
                   <a:srgbClr val="DFEEE7"/>
                 </a:solidFill>
               </a:defRPr>
             </a:pPr>
             <a:r>
-              <a:rPr sz="2100" b="1" i="0">
+              <a:rPr sz="1950" b="1" i="0">
                 <a:solidFill>
                   <a:srgbClr val="DFEEE7"/>
                 </a:solidFill>
               </a:rPr>
-              <a:t>구독청소는 반복 결제를 발견하고,</a:t>
-            </a:r>
-          </a:p>
-          <a:p xmlns:a="http://schemas.openxmlformats.org/drawingml/2006/main">
-            <a:pPr algn="l">
-              <a:defRPr sz="2100" b="1" i="0">
+              <a:t>여러 카드와 결제 알림에 흩어진 자동결제를</a:t>
+            </a:r>
+          </a:p>
+          <a:p xmlns:a="http://schemas.openxmlformats.org/drawingml/2006/main">
+            <a:pPr algn="l">
+              <a:defRPr sz="1950" b="1" i="0">
                 <a:solidFill>
                   <a:srgbClr val="DFEEE7"/>
                 </a:solidFill>
               </a:defRPr>
             </a:pPr>
             <a:r>
-              <a:rPr sz="2100" b="1" i="0">
+              <a:rPr sz="1950" b="1" i="0">
                 <a:solidFill>
                   <a:srgbClr val="DFEEE7"/>
                 </a:solidFill>
               </a:rPr>
-              <a:t>AI가 이해 가능한 다음 행동으로 번역합니다.</a:t>
+              <a:t>AI로 정리하는 개인정보 보호형 구독 관리 도구입니다.</a:t>
             </a:r>
           </a:p>
         </p:txBody>
@@ -6131,7 +6148,7 @@
           <p:cNvPr id="3" name="">
             <a:extLst xmlns:a="http://schemas.openxmlformats.org/drawingml/2006/main">
               <a:ext uri="{FF2B5EF4-FFF2-40B4-BE49-F238E27FC236}">
-                <a16:creationId xmlns:a16="http://schemas.microsoft.com/office/drawing/2014/main" id="{4E112D84-AEB9-4A54-9FFD-AAF691216D0F}"/>
+                <a16:creationId xmlns:a16="http://schemas.microsoft.com/office/drawing/2014/main" id="{E982E847-C208-463A-A1D0-8BA94B5C1101}"/>
               </a:ext>
             </a:extLst>
           </p:cNvPr>
@@ -6166,7 +6183,7 @@
           <p:cNvPr id="4" name="">
             <a:extLst xmlns:a="http://schemas.openxmlformats.org/drawingml/2006/main">
               <a:ext uri="{FF2B5EF4-FFF2-40B4-BE49-F238E27FC236}">
-                <a16:creationId xmlns:a16="http://schemas.microsoft.com/office/drawing/2014/main" id="{0F73AF9B-49CE-4E55-842E-170C79E1D1CB}"/>
+                <a16:creationId xmlns:a16="http://schemas.microsoft.com/office/drawing/2014/main" id="{EB5EB5FB-2117-479F-87B6-A8A872DB0396}"/>
               </a:ext>
             </a:extLst>
           </p:cNvPr>
@@ -6216,7 +6233,7 @@
           <p:cNvPr id="5" name="">
             <a:extLst xmlns:a="http://schemas.openxmlformats.org/drawingml/2006/main">
               <a:ext uri="{FF2B5EF4-FFF2-40B4-BE49-F238E27FC236}">
-                <a16:creationId xmlns:a16="http://schemas.microsoft.com/office/drawing/2014/main" id="{F54E2E04-AA68-432A-B291-8148D28AE11A}"/>
+                <a16:creationId xmlns:a16="http://schemas.microsoft.com/office/drawing/2014/main" id="{C945C9CC-3094-49E4-AD8C-6E8025133E5C}"/>
               </a:ext>
             </a:extLst>
           </p:cNvPr>
@@ -6256,7 +6273,7 @@
                   <a:srgbClr val="FFD23F"/>
                 </a:solidFill>
               </a:rPr>
-              <a:t>실제 문제  ·  배포된 서비스  ·  AI 활용  ·  확장 가능한 구조</a:t>
+              <a:t>통합·분류  ·  AI 설명  ·  해지 우선순위  ·  월·1년 절약액</a:t>
             </a:r>
           </a:p>
         </p:txBody>
@@ -6266,7 +6283,7 @@
           <p:cNvPr id="6" name="">
             <a:extLst xmlns:a="http://schemas.openxmlformats.org/drawingml/2006/main">
               <a:ext uri="{FF2B5EF4-FFF2-40B4-BE49-F238E27FC236}">
-                <a16:creationId xmlns:a16="http://schemas.microsoft.com/office/drawing/2014/main" id="{9A769C09-F2CC-46D2-89C0-9BEA2AC22A56}"/>
+                <a16:creationId xmlns:a16="http://schemas.microsoft.com/office/drawing/2014/main" id="{28DFA39C-27EA-40C8-A2EE-0241408B11FF}"/>
               </a:ext>
             </a:extLst>
           </p:cNvPr>
@@ -6316,7 +6333,7 @@
           <p:cNvPr id="7" name="">
             <a:extLst xmlns:a="http://schemas.openxmlformats.org/drawingml/2006/main">
               <a:ext uri="{FF2B5EF4-FFF2-40B4-BE49-F238E27FC236}">
-                <a16:creationId xmlns:a16="http://schemas.microsoft.com/office/drawing/2014/main" id="{F05C88FC-4C4E-4366-99BA-D5B4CF984558}"/>
+                <a16:creationId xmlns:a16="http://schemas.microsoft.com/office/drawing/2014/main" id="{F1FEE9EA-8F22-43E1-8D52-045F68A04E37}"/>
               </a:ext>
             </a:extLst>
           </p:cNvPr>
@@ -6364,7 +6381,7 @@
     </p:spTree>
     <p:extLst>
       <p:ext uri="{BB962C8B-B14F-4D97-AF65-F5344CB8AC3E}">
-        <p14:creationId xmlns:p14="http://schemas.microsoft.com/office/powerpoint/2010/main" val="2044065525"/>
+        <p14:creationId xmlns:p14="http://schemas.microsoft.com/office/powerpoint/2010/main" val="1246154776"/>
       </p:ext>
     </p:extLst>
   </p:cSld>

</xml_diff>

<commit_message>
Switch AI insights to Gemini API
</commit_message>
<xml_diff>
--- a/deliverables/subscription-cleaning-wanted-ai-championship-2026.pptx
+++ b/deliverables/subscription-cleaning-wanted-ai-championship-2026.pptx
@@ -2,19 +2,19 @@
 <file path=ppt/presentation.xml><?xml version="1.0" encoding="utf-8"?>
 <p:presentation xmlns:p="http://schemas.openxmlformats.org/presentationml/2006/main">
   <p:sldMasterIdLst>
-    <p:sldMasterId xmlns:r="http://schemas.openxmlformats.org/officeDocument/2006/relationships" id="2147483648" r:id="Ref5f4989fe8b4f52"/>
+    <p:sldMasterId xmlns:r="http://schemas.openxmlformats.org/officeDocument/2006/relationships" id="2147483648" r:id="Rb1252781b9a142ce"/>
   </p:sldMasterIdLst>
   <p:notesMasterIdLst>
-    <p:notesMasterId xmlns:r="http://schemas.openxmlformats.org/officeDocument/2006/relationships" r:id="R2e72d144afaa490c"/>
+    <p:notesMasterId xmlns:r="http://schemas.openxmlformats.org/officeDocument/2006/relationships" r:id="Rc065c826e8ad49f0"/>
   </p:notesMasterIdLst>
   <p:sldIdLst>
-    <p:sldId xmlns:r="http://schemas.openxmlformats.org/officeDocument/2006/relationships" id="256" r:id="Rab77793f9dcf4e68"/>
-    <p:sldId xmlns:r="http://schemas.openxmlformats.org/officeDocument/2006/relationships" id="257" r:id="R4f4ac99af9464b68"/>
-    <p:sldId xmlns:r="http://schemas.openxmlformats.org/officeDocument/2006/relationships" id="258" r:id="R5fb894111c554e7f"/>
-    <p:sldId xmlns:r="http://schemas.openxmlformats.org/officeDocument/2006/relationships" id="259" r:id="R11eb0c7ee25b46e4"/>
-    <p:sldId xmlns:r="http://schemas.openxmlformats.org/officeDocument/2006/relationships" id="260" r:id="R886311ce9ca34679"/>
-    <p:sldId xmlns:r="http://schemas.openxmlformats.org/officeDocument/2006/relationships" id="261" r:id="Rc2ef5a8c82954334"/>
-    <p:sldId xmlns:r="http://schemas.openxmlformats.org/officeDocument/2006/relationships" id="262" r:id="R4e96d94f9b134ade"/>
+    <p:sldId xmlns:r="http://schemas.openxmlformats.org/officeDocument/2006/relationships" id="256" r:id="R529bd0d86ee4431e"/>
+    <p:sldId xmlns:r="http://schemas.openxmlformats.org/officeDocument/2006/relationships" id="257" r:id="Rd6fdf6d770924428"/>
+    <p:sldId xmlns:r="http://schemas.openxmlformats.org/officeDocument/2006/relationships" id="258" r:id="R7fe8550b04f340ac"/>
+    <p:sldId xmlns:r="http://schemas.openxmlformats.org/officeDocument/2006/relationships" id="259" r:id="Rb3ee4a4ff9de4d0a"/>
+    <p:sldId xmlns:r="http://schemas.openxmlformats.org/officeDocument/2006/relationships" id="260" r:id="Rf1d4713bc09845b5"/>
+    <p:sldId xmlns:r="http://schemas.openxmlformats.org/officeDocument/2006/relationships" id="261" r:id="R3f0628f01c3d47b9"/>
+    <p:sldId xmlns:r="http://schemas.openxmlformats.org/officeDocument/2006/relationships" id="262" r:id="R338f942093ef4f80"/>
   </p:sldIdLst>
   <p:sldSz cx="12192000" cy="6858000"/>
   <p:notesSz cx="6858000" cy="9144000"/>
@@ -808,7 +808,7 @@
           <a:lstStyle xmlns:a="http://schemas.openxmlformats.org/drawingml/2006/main"/>
           <a:p xmlns:a="http://schemas.openxmlformats.org/drawingml/2006/main">
             <a:r>
-              <a:t>AI 기능의 핵심은 데이터를 더 많이 보내는 것이 아니라, 필요한 정보만 구조화해서 보내는 것입니다. OpenAI Responses API 호출은 Vercel 서버 함수에서 수행하고, 연결이 없을 때도 시연 가능한 대체 설명을 둡니다.</a:t>
+              <a:t>AI 기능의 핵심은 데이터를 더 많이 보내는 것이 아니라, 필요한 정보만 구조화해서 보내는 것입니다. Google Gemini API 호출은 Vercel 서버 함수에서 수행하고, 연결이 없을 때도 시연 가능한 대체 설명을 둡니다.</a:t>
             </a:r>
           </a:p>
           <a:p xmlns:a="http://schemas.openxmlformats.org/drawingml/2006/main">
@@ -823,12 +823,12 @@
           </a:p>
           <a:p xmlns:a="http://schemas.openxmlformats.org/drawingml/2006/main">
             <a:r>
-              <a:t>- OpenAI API quickstart: https://platform.openai.com/docs/quickstart/make-your-first-api-request</a:t>
-            </a:r>
-          </a:p>
-          <a:p xmlns:a="http://schemas.openxmlformats.org/drawingml/2006/main">
-            <a:r>
-              <a:t>- OpenAI API data controls: https://platform.openai.com/docs/models/default-usage-policies-by-endpoint</a:t>
+              <a:t>- Gemini Generate Content API: https://ai.google.dev/api/generate-content</a:t>
+            </a:r>
+          </a:p>
+          <a:p xmlns:a="http://schemas.openxmlformats.org/drawingml/2006/main">
+            <a:r>
+              <a:t>- Gemini structured outputs: https://ai.google.dev/gemini-api/docs/structured-output</a:t>
             </a:r>
           </a:p>
           <a:p xmlns:a="http://schemas.openxmlformats.org/drawingml/2006/main">
@@ -1111,7 +1111,7 @@
   </p:cSld>
   <p:clrMap bg1="lt1" tx1="dk1" bg2="lt2" tx2="dk2" accent1="accent1" accent2="accent2" accent3="accent3" accent4="accent4" accent5="accent5" accent6="accent6" hlink="hlink" folHlink="folHlink"/>
   <p:sldLayoutIdLst>
-    <p:sldLayoutId xmlns:r="http://schemas.openxmlformats.org/officeDocument/2006/relationships" id="2147483649" r:id="R90276e5f6415442d"/>
+    <p:sldLayoutId xmlns:r="http://schemas.openxmlformats.org/officeDocument/2006/relationships" id="2147483649" r:id="Ra1fb1e080fe74019"/>
   </p:sldLayoutIdLst>
   <p:txStyles>
     <p:titleStyle>
@@ -1662,7 +1662,7 @@
           <p:cNvPr id="7" name="">
             <a:extLst xmlns:a="http://schemas.openxmlformats.org/drawingml/2006/main">
               <a:ext uri="{FF2B5EF4-FFF2-40B4-BE49-F238E27FC236}">
-                <a16:creationId xmlns:a16="http://schemas.microsoft.com/office/drawing/2014/main" id="{69D62F14-2184-40C1-83F8-530EC4B721D3}"/>
+                <a16:creationId xmlns:a16="http://schemas.microsoft.com/office/drawing/2014/main" id="{EA19BC6E-F26D-4781-AD88-0D6807BAE0B9}"/>
               </a:ext>
             </a:extLst>
           </p:cNvPr>
@@ -1695,7 +1695,7 @@
           <p:cNvPr id="2" name="">
             <a:extLst xmlns:a="http://schemas.openxmlformats.org/drawingml/2006/main">
               <a:ext uri="{FF2B5EF4-FFF2-40B4-BE49-F238E27FC236}">
-                <a16:creationId xmlns:a16="http://schemas.microsoft.com/office/drawing/2014/main" id="{15C01A5B-AB5C-409F-81B7-7D2E927C2E85}"/>
+                <a16:creationId xmlns:a16="http://schemas.microsoft.com/office/drawing/2014/main" id="{A7BE7C9A-582B-4540-8FC1-2F5E0B7D40A0}"/>
               </a:ext>
             </a:extLst>
           </p:cNvPr>
@@ -1745,7 +1745,7 @@
           <p:cNvPr id="3" name="">
             <a:extLst xmlns:a="http://schemas.openxmlformats.org/drawingml/2006/main">
               <a:ext uri="{FF2B5EF4-FFF2-40B4-BE49-F238E27FC236}">
-                <a16:creationId xmlns:a16="http://schemas.microsoft.com/office/drawing/2014/main" id="{1C92CB16-86AE-4D17-A77E-25B5A0112A14}"/>
+                <a16:creationId xmlns:a16="http://schemas.microsoft.com/office/drawing/2014/main" id="{88AB75C7-2D38-4E0B-AEF9-7D46D284F10C}"/>
               </a:ext>
             </a:extLst>
           </p:cNvPr>
@@ -1812,7 +1812,7 @@
           <p:cNvPr id="4" name="">
             <a:extLst xmlns:a="http://schemas.openxmlformats.org/drawingml/2006/main">
               <a:ext uri="{FF2B5EF4-FFF2-40B4-BE49-F238E27FC236}">
-                <a16:creationId xmlns:a16="http://schemas.microsoft.com/office/drawing/2014/main" id="{C0E66F0B-7B29-452F-A253-4D0286232E86}"/>
+                <a16:creationId xmlns:a16="http://schemas.microsoft.com/office/drawing/2014/main" id="{C6A2AE35-2FDB-488D-8DDF-D9B55B3E169C}"/>
               </a:ext>
             </a:extLst>
           </p:cNvPr>
@@ -1862,7 +1862,7 @@
           <p:cNvPr id="5" name="">
             <a:extLst xmlns:a="http://schemas.openxmlformats.org/drawingml/2006/main">
               <a:ext uri="{FF2B5EF4-FFF2-40B4-BE49-F238E27FC236}">
-                <a16:creationId xmlns:a16="http://schemas.microsoft.com/office/drawing/2014/main" id="{A7DCF206-DCC8-40EF-B40B-9C1DC0D79BCC}"/>
+                <a16:creationId xmlns:a16="http://schemas.microsoft.com/office/drawing/2014/main" id="{98E48D2A-11AC-4C93-A7BE-34ECB6C7E267}"/>
               </a:ext>
             </a:extLst>
           </p:cNvPr>
@@ -1901,7 +1901,7 @@
           <p:nvPr/>
         </p:nvPicPr>
         <p:blipFill>
-          <a:blip xmlns:r="http://schemas.openxmlformats.org/officeDocument/2006/relationships" xmlns:a="http://schemas.openxmlformats.org/drawingml/2006/main" r:embed="Rd2d16e3cc1d24366"/>
+          <a:blip xmlns:r="http://schemas.openxmlformats.org/officeDocument/2006/relationships" xmlns:a="http://schemas.openxmlformats.org/drawingml/2006/main" r:embed="R92e1629d2bc44079"/>
           <a:stretch xmlns:a="http://schemas.openxmlformats.org/drawingml/2006/main"/>
         </p:blipFill>
         <p:spPr>
@@ -1919,7 +1919,7 @@
     </p:spTree>
     <p:extLst>
       <p:ext uri="{BB962C8B-B14F-4D97-AF65-F5344CB8AC3E}">
-        <p14:creationId xmlns:p14="http://schemas.microsoft.com/office/powerpoint/2010/main" val="817198352"/>
+        <p14:creationId xmlns:p14="http://schemas.microsoft.com/office/powerpoint/2010/main" val="2111704040"/>
       </p:ext>
     </p:extLst>
   </p:cSld>
@@ -1950,7 +1950,7 @@
           <p:cNvPr id="15" name="">
             <a:extLst xmlns:a="http://schemas.openxmlformats.org/drawingml/2006/main">
               <a:ext uri="{FF2B5EF4-FFF2-40B4-BE49-F238E27FC236}">
-                <a16:creationId xmlns:a16="http://schemas.microsoft.com/office/drawing/2014/main" id="{4D3E3438-D7DD-4B3C-ADB8-D3CD0E8C5A01}"/>
+                <a16:creationId xmlns:a16="http://schemas.microsoft.com/office/drawing/2014/main" id="{FDB5E653-4532-495C-A234-DE4121B7305D}"/>
               </a:ext>
             </a:extLst>
           </p:cNvPr>
@@ -2000,7 +2000,7 @@
           <p:cNvPr id="2" name="">
             <a:extLst xmlns:a="http://schemas.openxmlformats.org/drawingml/2006/main">
               <a:ext uri="{FF2B5EF4-FFF2-40B4-BE49-F238E27FC236}">
-                <a16:creationId xmlns:a16="http://schemas.microsoft.com/office/drawing/2014/main" id="{44B1741C-3915-4B18-8091-131902C85C50}"/>
+                <a16:creationId xmlns:a16="http://schemas.microsoft.com/office/drawing/2014/main" id="{8ECF86E7-6574-4C93-B30B-2809F612A425}"/>
               </a:ext>
             </a:extLst>
           </p:cNvPr>
@@ -2050,7 +2050,7 @@
           <p:cNvPr id="3" name="">
             <a:extLst xmlns:a="http://schemas.openxmlformats.org/drawingml/2006/main">
               <a:ext uri="{FF2B5EF4-FFF2-40B4-BE49-F238E27FC236}">
-                <a16:creationId xmlns:a16="http://schemas.microsoft.com/office/drawing/2014/main" id="{37BCE595-96C4-4ADC-88B4-299E518DD9BD}"/>
+                <a16:creationId xmlns:a16="http://schemas.microsoft.com/office/drawing/2014/main" id="{779ABD5D-9A76-4219-952D-47E4E18CDBB6}"/>
               </a:ext>
             </a:extLst>
           </p:cNvPr>
@@ -2100,7 +2100,7 @@
           <p:cNvPr id="4" name="">
             <a:extLst xmlns:a="http://schemas.openxmlformats.org/drawingml/2006/main">
               <a:ext uri="{FF2B5EF4-FFF2-40B4-BE49-F238E27FC236}">
-                <a16:creationId xmlns:a16="http://schemas.microsoft.com/office/drawing/2014/main" id="{5AAFF541-EB30-4763-BD44-E65CA9046E78}"/>
+                <a16:creationId xmlns:a16="http://schemas.microsoft.com/office/drawing/2014/main" id="{C9BAAFF2-0895-4350-9F7C-DE761D8EF967}"/>
               </a:ext>
             </a:extLst>
           </p:cNvPr>
@@ -2167,7 +2167,7 @@
           <p:cNvPr id="5" name="">
             <a:extLst xmlns:a="http://schemas.openxmlformats.org/drawingml/2006/main">
               <a:ext uri="{FF2B5EF4-FFF2-40B4-BE49-F238E27FC236}">
-                <a16:creationId xmlns:a16="http://schemas.microsoft.com/office/drawing/2014/main" id="{22F4385E-6888-4A2B-9EE5-CFA8858D567A}"/>
+                <a16:creationId xmlns:a16="http://schemas.microsoft.com/office/drawing/2014/main" id="{EE0BFD26-0BC4-4221-A832-3F9A2CD0E779}"/>
               </a:ext>
             </a:extLst>
           </p:cNvPr>
@@ -2202,7 +2202,7 @@
           <p:cNvPr id="6" name="">
             <a:extLst xmlns:a="http://schemas.openxmlformats.org/drawingml/2006/main">
               <a:ext uri="{FF2B5EF4-FFF2-40B4-BE49-F238E27FC236}">
-                <a16:creationId xmlns:a16="http://schemas.microsoft.com/office/drawing/2014/main" id="{8BA57B0E-E0A6-4F74-8E4A-0453E996DA95}"/>
+                <a16:creationId xmlns:a16="http://schemas.microsoft.com/office/drawing/2014/main" id="{9FAE88EF-21F4-4AEA-B535-A77EA11C9080}"/>
               </a:ext>
             </a:extLst>
           </p:cNvPr>
@@ -2252,7 +2252,7 @@
           <p:cNvPr id="7" name="">
             <a:extLst xmlns:a="http://schemas.openxmlformats.org/drawingml/2006/main">
               <a:ext uri="{FF2B5EF4-FFF2-40B4-BE49-F238E27FC236}">
-                <a16:creationId xmlns:a16="http://schemas.microsoft.com/office/drawing/2014/main" id="{73072031-C413-4D47-A0FB-29C7D900309A}"/>
+                <a16:creationId xmlns:a16="http://schemas.microsoft.com/office/drawing/2014/main" id="{850F1D0E-5EF3-4A6F-BB26-5BFBBEFF02E5}"/>
               </a:ext>
             </a:extLst>
           </p:cNvPr>
@@ -2336,7 +2336,7 @@
           <p:cNvPr id="8" name="">
             <a:extLst xmlns:a="http://schemas.openxmlformats.org/drawingml/2006/main">
               <a:ext uri="{FF2B5EF4-FFF2-40B4-BE49-F238E27FC236}">
-                <a16:creationId xmlns:a16="http://schemas.microsoft.com/office/drawing/2014/main" id="{1C98FA51-367D-44B6-A15B-A07DE293796F}"/>
+                <a16:creationId xmlns:a16="http://schemas.microsoft.com/office/drawing/2014/main" id="{5AE9264D-0251-4854-95F8-3719C3A69595}"/>
               </a:ext>
             </a:extLst>
           </p:cNvPr>
@@ -2371,7 +2371,7 @@
           <p:cNvPr id="9" name="">
             <a:extLst xmlns:a="http://schemas.openxmlformats.org/drawingml/2006/main">
               <a:ext uri="{FF2B5EF4-FFF2-40B4-BE49-F238E27FC236}">
-                <a16:creationId xmlns:a16="http://schemas.microsoft.com/office/drawing/2014/main" id="{FDC55029-6245-4965-90CD-8B0B572C65C6}"/>
+                <a16:creationId xmlns:a16="http://schemas.microsoft.com/office/drawing/2014/main" id="{17D487AB-B982-4ED6-BCBA-FD93E12D2BDB}"/>
               </a:ext>
             </a:extLst>
           </p:cNvPr>
@@ -2421,7 +2421,7 @@
           <p:cNvPr id="10" name="">
             <a:extLst xmlns:a="http://schemas.openxmlformats.org/drawingml/2006/main">
               <a:ext uri="{FF2B5EF4-FFF2-40B4-BE49-F238E27FC236}">
-                <a16:creationId xmlns:a16="http://schemas.microsoft.com/office/drawing/2014/main" id="{DBE91B59-474B-480A-8D93-085530AFE9E0}"/>
+                <a16:creationId xmlns:a16="http://schemas.microsoft.com/office/drawing/2014/main" id="{011C6766-4FD6-4161-A04B-F2C13932B1F3}"/>
               </a:ext>
             </a:extLst>
           </p:cNvPr>
@@ -2505,7 +2505,7 @@
           <p:cNvPr id="11" name="">
             <a:extLst xmlns:a="http://schemas.openxmlformats.org/drawingml/2006/main">
               <a:ext uri="{FF2B5EF4-FFF2-40B4-BE49-F238E27FC236}">
-                <a16:creationId xmlns:a16="http://schemas.microsoft.com/office/drawing/2014/main" id="{CB84D3E0-36FF-4DDA-B58C-0E87EA312C15}"/>
+                <a16:creationId xmlns:a16="http://schemas.microsoft.com/office/drawing/2014/main" id="{95C299A2-1AD2-45DE-A5AD-DAB2BBD5581D}"/>
               </a:ext>
             </a:extLst>
           </p:cNvPr>
@@ -2540,7 +2540,7 @@
           <p:cNvPr id="12" name="">
             <a:extLst xmlns:a="http://schemas.openxmlformats.org/drawingml/2006/main">
               <a:ext uri="{FF2B5EF4-FFF2-40B4-BE49-F238E27FC236}">
-                <a16:creationId xmlns:a16="http://schemas.microsoft.com/office/drawing/2014/main" id="{6CD7B78A-D402-4DA8-B73F-C70E030A0192}"/>
+                <a16:creationId xmlns:a16="http://schemas.microsoft.com/office/drawing/2014/main" id="{B62FECFA-1191-476C-9EA8-89EDB13B8D92}"/>
               </a:ext>
             </a:extLst>
           </p:cNvPr>
@@ -2590,7 +2590,7 @@
           <p:cNvPr id="13" name="">
             <a:extLst xmlns:a="http://schemas.openxmlformats.org/drawingml/2006/main">
               <a:ext uri="{FF2B5EF4-FFF2-40B4-BE49-F238E27FC236}">
-                <a16:creationId xmlns:a16="http://schemas.microsoft.com/office/drawing/2014/main" id="{D04CE191-7E12-4756-8C03-9905DD7D5A6F}"/>
+                <a16:creationId xmlns:a16="http://schemas.microsoft.com/office/drawing/2014/main" id="{9B52A5A1-A569-4B25-A232-E74C46198B62}"/>
               </a:ext>
             </a:extLst>
           </p:cNvPr>
@@ -2674,7 +2674,7 @@
           <p:cNvPr id="14" name="">
             <a:extLst xmlns:a="http://schemas.openxmlformats.org/drawingml/2006/main">
               <a:ext uri="{FF2B5EF4-FFF2-40B4-BE49-F238E27FC236}">
-                <a16:creationId xmlns:a16="http://schemas.microsoft.com/office/drawing/2014/main" id="{80076BFF-3D8F-48F8-89E4-54AE753EF690}"/>
+                <a16:creationId xmlns:a16="http://schemas.microsoft.com/office/drawing/2014/main" id="{1652AA9F-F136-4C72-913F-C6FBDBC4817D}"/>
               </a:ext>
             </a:extLst>
           </p:cNvPr>
@@ -2722,7 +2722,7 @@
     </p:spTree>
     <p:extLst>
       <p:ext uri="{BB962C8B-B14F-4D97-AF65-F5344CB8AC3E}">
-        <p14:creationId xmlns:p14="http://schemas.microsoft.com/office/powerpoint/2010/main" val="1343881525"/>
+        <p14:creationId xmlns:p14="http://schemas.microsoft.com/office/powerpoint/2010/main" val="975738254"/>
       </p:ext>
     </p:extLst>
   </p:cSld>
@@ -2753,7 +2753,7 @@
           <p:cNvPr id="25" name="">
             <a:extLst xmlns:a="http://schemas.openxmlformats.org/drawingml/2006/main">
               <a:ext uri="{FF2B5EF4-FFF2-40B4-BE49-F238E27FC236}">
-                <a16:creationId xmlns:a16="http://schemas.microsoft.com/office/drawing/2014/main" id="{844777FE-FAC2-4767-8F53-727C8FAABABE}"/>
+                <a16:creationId xmlns:a16="http://schemas.microsoft.com/office/drawing/2014/main" id="{E90BAAC3-D763-4750-B5D9-98BFA9A5710E}"/>
               </a:ext>
             </a:extLst>
           </p:cNvPr>
@@ -2803,7 +2803,7 @@
           <p:cNvPr id="2" name="">
             <a:extLst xmlns:a="http://schemas.openxmlformats.org/drawingml/2006/main">
               <a:ext uri="{FF2B5EF4-FFF2-40B4-BE49-F238E27FC236}">
-                <a16:creationId xmlns:a16="http://schemas.microsoft.com/office/drawing/2014/main" id="{B944F5D3-155A-4D02-8350-84E67A2FC44F}"/>
+                <a16:creationId xmlns:a16="http://schemas.microsoft.com/office/drawing/2014/main" id="{7C53138D-5961-4DE6-B00A-263D8F723DF7}"/>
               </a:ext>
             </a:extLst>
           </p:cNvPr>
@@ -2853,7 +2853,7 @@
           <p:cNvPr id="3" name="">
             <a:extLst xmlns:a="http://schemas.openxmlformats.org/drawingml/2006/main">
               <a:ext uri="{FF2B5EF4-FFF2-40B4-BE49-F238E27FC236}">
-                <a16:creationId xmlns:a16="http://schemas.microsoft.com/office/drawing/2014/main" id="{B2B74B35-3FF7-46D5-AB34-88096C986570}"/>
+                <a16:creationId xmlns:a16="http://schemas.microsoft.com/office/drawing/2014/main" id="{8A5AA1E7-A6C5-46BD-B1C0-20C8A1C64A55}"/>
               </a:ext>
             </a:extLst>
           </p:cNvPr>
@@ -2903,7 +2903,7 @@
           <p:cNvPr id="4" name="">
             <a:extLst xmlns:a="http://schemas.openxmlformats.org/drawingml/2006/main">
               <a:ext uri="{FF2B5EF4-FFF2-40B4-BE49-F238E27FC236}">
-                <a16:creationId xmlns:a16="http://schemas.microsoft.com/office/drawing/2014/main" id="{18A1C20A-C8FB-4F1E-81D4-6F47653D6A14}"/>
+                <a16:creationId xmlns:a16="http://schemas.microsoft.com/office/drawing/2014/main" id="{FF5AC5A0-C267-408B-8326-012D1687FA02}"/>
               </a:ext>
             </a:extLst>
           </p:cNvPr>
@@ -2936,7 +2936,7 @@
           <p:cNvPr id="5" name="">
             <a:extLst xmlns:a="http://schemas.openxmlformats.org/drawingml/2006/main">
               <a:ext uri="{FF2B5EF4-FFF2-40B4-BE49-F238E27FC236}">
-                <a16:creationId xmlns:a16="http://schemas.microsoft.com/office/drawing/2014/main" id="{201DF532-890C-4072-876D-BD2C48BEFDAD}"/>
+                <a16:creationId xmlns:a16="http://schemas.microsoft.com/office/drawing/2014/main" id="{D713282E-AE2B-4AC2-92E6-467CABCDBB2E}"/>
               </a:ext>
             </a:extLst>
           </p:cNvPr>
@@ -2971,7 +2971,7 @@
           <p:cNvPr id="6" name="">
             <a:extLst xmlns:a="http://schemas.openxmlformats.org/drawingml/2006/main">
               <a:ext uri="{FF2B5EF4-FFF2-40B4-BE49-F238E27FC236}">
-                <a16:creationId xmlns:a16="http://schemas.microsoft.com/office/drawing/2014/main" id="{0C7845CC-181B-4E29-869A-FC72D0B3F8AC}"/>
+                <a16:creationId xmlns:a16="http://schemas.microsoft.com/office/drawing/2014/main" id="{FAA0DA3F-6A40-4EC3-8C7F-7D899D6DF104}"/>
               </a:ext>
             </a:extLst>
           </p:cNvPr>
@@ -3021,7 +3021,7 @@
           <p:cNvPr id="7" name="">
             <a:extLst xmlns:a="http://schemas.openxmlformats.org/drawingml/2006/main">
               <a:ext uri="{FF2B5EF4-FFF2-40B4-BE49-F238E27FC236}">
-                <a16:creationId xmlns:a16="http://schemas.microsoft.com/office/drawing/2014/main" id="{091CC886-52C3-4F3A-A0A3-6613EE3434DF}"/>
+                <a16:creationId xmlns:a16="http://schemas.microsoft.com/office/drawing/2014/main" id="{EFAB5BA1-D52F-439B-8780-71F50CCB28F3}"/>
               </a:ext>
             </a:extLst>
           </p:cNvPr>
@@ -3071,7 +3071,7 @@
           <p:cNvPr id="8" name="">
             <a:extLst xmlns:a="http://schemas.openxmlformats.org/drawingml/2006/main">
               <a:ext uri="{FF2B5EF4-FFF2-40B4-BE49-F238E27FC236}">
-                <a16:creationId xmlns:a16="http://schemas.microsoft.com/office/drawing/2014/main" id="{153CA9FD-C382-47D1-B8DC-9516304BAFF1}"/>
+                <a16:creationId xmlns:a16="http://schemas.microsoft.com/office/drawing/2014/main" id="{8B911762-6450-477C-AEF0-97412A291CB0}"/>
               </a:ext>
             </a:extLst>
           </p:cNvPr>
@@ -3121,7 +3121,7 @@
           <p:cNvPr id="9" name="">
             <a:extLst xmlns:a="http://schemas.openxmlformats.org/drawingml/2006/main">
               <a:ext uri="{FF2B5EF4-FFF2-40B4-BE49-F238E27FC236}">
-                <a16:creationId xmlns:a16="http://schemas.microsoft.com/office/drawing/2014/main" id="{EB24F09E-8D71-4CFA-8D26-876CD8E4F119}"/>
+                <a16:creationId xmlns:a16="http://schemas.microsoft.com/office/drawing/2014/main" id="{6BACF3CF-BAF4-4D80-889B-C42D37B84A79}"/>
               </a:ext>
             </a:extLst>
           </p:cNvPr>
@@ -3154,7 +3154,7 @@
           <p:cNvPr id="10" name="">
             <a:extLst xmlns:a="http://schemas.openxmlformats.org/drawingml/2006/main">
               <a:ext uri="{FF2B5EF4-FFF2-40B4-BE49-F238E27FC236}">
-                <a16:creationId xmlns:a16="http://schemas.microsoft.com/office/drawing/2014/main" id="{AD6BB1B5-7B5B-4A5E-A59F-0CE6578BF12C}"/>
+                <a16:creationId xmlns:a16="http://schemas.microsoft.com/office/drawing/2014/main" id="{AF45E78C-713D-4F84-B596-08E4199F62C5}"/>
               </a:ext>
             </a:extLst>
           </p:cNvPr>
@@ -3189,7 +3189,7 @@
           <p:cNvPr id="11" name="">
             <a:extLst xmlns:a="http://schemas.openxmlformats.org/drawingml/2006/main">
               <a:ext uri="{FF2B5EF4-FFF2-40B4-BE49-F238E27FC236}">
-                <a16:creationId xmlns:a16="http://schemas.microsoft.com/office/drawing/2014/main" id="{0E7697B6-5EB0-4888-A506-C9DD07F6A090}"/>
+                <a16:creationId xmlns:a16="http://schemas.microsoft.com/office/drawing/2014/main" id="{39846DB8-6101-40B7-B78C-CCDEA0370B8A}"/>
               </a:ext>
             </a:extLst>
           </p:cNvPr>
@@ -3239,7 +3239,7 @@
           <p:cNvPr id="12" name="">
             <a:extLst xmlns:a="http://schemas.openxmlformats.org/drawingml/2006/main">
               <a:ext uri="{FF2B5EF4-FFF2-40B4-BE49-F238E27FC236}">
-                <a16:creationId xmlns:a16="http://schemas.microsoft.com/office/drawing/2014/main" id="{B69CE269-232C-4567-9193-3B160791801D}"/>
+                <a16:creationId xmlns:a16="http://schemas.microsoft.com/office/drawing/2014/main" id="{0BAE6BB0-6853-4177-A8EB-6E64C68CC354}"/>
               </a:ext>
             </a:extLst>
           </p:cNvPr>
@@ -3289,7 +3289,7 @@
           <p:cNvPr id="13" name="">
             <a:extLst xmlns:a="http://schemas.openxmlformats.org/drawingml/2006/main">
               <a:ext uri="{FF2B5EF4-FFF2-40B4-BE49-F238E27FC236}">
-                <a16:creationId xmlns:a16="http://schemas.microsoft.com/office/drawing/2014/main" id="{74AC0E54-7B53-47B8-88C2-D6C101FAA5B3}"/>
+                <a16:creationId xmlns:a16="http://schemas.microsoft.com/office/drawing/2014/main" id="{F6FE4031-4D1D-47C4-98D1-393437BB19C9}"/>
               </a:ext>
             </a:extLst>
           </p:cNvPr>
@@ -3339,7 +3339,7 @@
           <p:cNvPr id="14" name="">
             <a:extLst xmlns:a="http://schemas.openxmlformats.org/drawingml/2006/main">
               <a:ext uri="{FF2B5EF4-FFF2-40B4-BE49-F238E27FC236}">
-                <a16:creationId xmlns:a16="http://schemas.microsoft.com/office/drawing/2014/main" id="{13521985-29EA-4D27-BF43-83151ABFE9B8}"/>
+                <a16:creationId xmlns:a16="http://schemas.microsoft.com/office/drawing/2014/main" id="{6B5EB9E6-8E6F-4C86-BBCC-C848A0588369}"/>
               </a:ext>
             </a:extLst>
           </p:cNvPr>
@@ -3372,7 +3372,7 @@
           <p:cNvPr id="15" name="">
             <a:extLst xmlns:a="http://schemas.openxmlformats.org/drawingml/2006/main">
               <a:ext uri="{FF2B5EF4-FFF2-40B4-BE49-F238E27FC236}">
-                <a16:creationId xmlns:a16="http://schemas.microsoft.com/office/drawing/2014/main" id="{0073A1D7-50D3-46DD-9001-6845A9FF4C25}"/>
+                <a16:creationId xmlns:a16="http://schemas.microsoft.com/office/drawing/2014/main" id="{4489919C-FC04-46A8-8E91-B6B8B6D2C90C}"/>
               </a:ext>
             </a:extLst>
           </p:cNvPr>
@@ -3407,7 +3407,7 @@
           <p:cNvPr id="16" name="">
             <a:extLst xmlns:a="http://schemas.openxmlformats.org/drawingml/2006/main">
               <a:ext uri="{FF2B5EF4-FFF2-40B4-BE49-F238E27FC236}">
-                <a16:creationId xmlns:a16="http://schemas.microsoft.com/office/drawing/2014/main" id="{CA75252A-F577-4CE2-B42A-2741349B025B}"/>
+                <a16:creationId xmlns:a16="http://schemas.microsoft.com/office/drawing/2014/main" id="{66B09CD1-1C06-46FC-8908-8D8397B55885}"/>
               </a:ext>
             </a:extLst>
           </p:cNvPr>
@@ -3457,7 +3457,7 @@
           <p:cNvPr id="17" name="">
             <a:extLst xmlns:a="http://schemas.openxmlformats.org/drawingml/2006/main">
               <a:ext uri="{FF2B5EF4-FFF2-40B4-BE49-F238E27FC236}">
-                <a16:creationId xmlns:a16="http://schemas.microsoft.com/office/drawing/2014/main" id="{77933412-A320-4A15-9944-11DB31232CDC}"/>
+                <a16:creationId xmlns:a16="http://schemas.microsoft.com/office/drawing/2014/main" id="{6B125F85-30C7-4FAC-BC36-1A6E50CCB11C}"/>
               </a:ext>
             </a:extLst>
           </p:cNvPr>
@@ -3507,7 +3507,7 @@
           <p:cNvPr id="18" name="">
             <a:extLst xmlns:a="http://schemas.openxmlformats.org/drawingml/2006/main">
               <a:ext uri="{FF2B5EF4-FFF2-40B4-BE49-F238E27FC236}">
-                <a16:creationId xmlns:a16="http://schemas.microsoft.com/office/drawing/2014/main" id="{1EDC7914-3E9E-44DA-A506-A9910123F1D2}"/>
+                <a16:creationId xmlns:a16="http://schemas.microsoft.com/office/drawing/2014/main" id="{B45F0DB7-1006-437E-84C5-E144EBECAE58}"/>
               </a:ext>
             </a:extLst>
           </p:cNvPr>
@@ -3557,7 +3557,7 @@
           <p:cNvPr id="19" name="">
             <a:extLst xmlns:a="http://schemas.openxmlformats.org/drawingml/2006/main">
               <a:ext uri="{FF2B5EF4-FFF2-40B4-BE49-F238E27FC236}">
-                <a16:creationId xmlns:a16="http://schemas.microsoft.com/office/drawing/2014/main" id="{E3FEEFEC-8171-439C-AAB8-F864B0A8217D}"/>
+                <a16:creationId xmlns:a16="http://schemas.microsoft.com/office/drawing/2014/main" id="{A8AF01CE-461C-430E-AD3F-767CF50E08CB}"/>
               </a:ext>
             </a:extLst>
           </p:cNvPr>
@@ -3592,7 +3592,7 @@
           <p:cNvPr id="20" name="">
             <a:extLst xmlns:a="http://schemas.openxmlformats.org/drawingml/2006/main">
               <a:ext uri="{FF2B5EF4-FFF2-40B4-BE49-F238E27FC236}">
-                <a16:creationId xmlns:a16="http://schemas.microsoft.com/office/drawing/2014/main" id="{882F370D-5A35-485F-8138-17A1B09A7810}"/>
+                <a16:creationId xmlns:a16="http://schemas.microsoft.com/office/drawing/2014/main" id="{785D2317-7EF3-4401-A704-495AEC89A5C2}"/>
               </a:ext>
             </a:extLst>
           </p:cNvPr>
@@ -3642,7 +3642,7 @@
           <p:cNvPr id="21" name="">
             <a:extLst xmlns:a="http://schemas.openxmlformats.org/drawingml/2006/main">
               <a:ext uri="{FF2B5EF4-FFF2-40B4-BE49-F238E27FC236}">
-                <a16:creationId xmlns:a16="http://schemas.microsoft.com/office/drawing/2014/main" id="{9183538B-57FA-49CE-A54F-360958C2AC65}"/>
+                <a16:creationId xmlns:a16="http://schemas.microsoft.com/office/drawing/2014/main" id="{AFB2C4E4-754B-4FB0-9FF7-1789F01B8E97}"/>
               </a:ext>
             </a:extLst>
           </p:cNvPr>
@@ -3692,7 +3692,7 @@
           <p:cNvPr id="22" name="">
             <a:extLst xmlns:a="http://schemas.openxmlformats.org/drawingml/2006/main">
               <a:ext uri="{FF2B5EF4-FFF2-40B4-BE49-F238E27FC236}">
-                <a16:creationId xmlns:a16="http://schemas.microsoft.com/office/drawing/2014/main" id="{72710385-EDE0-4B60-ADE2-2E46A8E1233B}"/>
+                <a16:creationId xmlns:a16="http://schemas.microsoft.com/office/drawing/2014/main" id="{DAC71F89-23C1-4D9B-B12B-0C71D01407B0}"/>
               </a:ext>
             </a:extLst>
           </p:cNvPr>
@@ -3742,7 +3742,7 @@
           <p:cNvPr id="23" name="">
             <a:extLst xmlns:a="http://schemas.openxmlformats.org/drawingml/2006/main">
               <a:ext uri="{FF2B5EF4-FFF2-40B4-BE49-F238E27FC236}">
-                <a16:creationId xmlns:a16="http://schemas.microsoft.com/office/drawing/2014/main" id="{041E9A4E-E602-4BB7-858B-2AE786C5E5BA}"/>
+                <a16:creationId xmlns:a16="http://schemas.microsoft.com/office/drawing/2014/main" id="{34DA002B-7902-485C-9C1E-71B0B199B36E}"/>
               </a:ext>
             </a:extLst>
           </p:cNvPr>
@@ -3792,7 +3792,7 @@
           <p:cNvPr id="24" name="">
             <a:extLst xmlns:a="http://schemas.openxmlformats.org/drawingml/2006/main">
               <a:ext uri="{FF2B5EF4-FFF2-40B4-BE49-F238E27FC236}">
-                <a16:creationId xmlns:a16="http://schemas.microsoft.com/office/drawing/2014/main" id="{843DE169-A339-4A28-87D7-235E5ED30696}"/>
+                <a16:creationId xmlns:a16="http://schemas.microsoft.com/office/drawing/2014/main" id="{34BA2151-54B4-48E6-A45A-23ED58C79EE2}"/>
               </a:ext>
             </a:extLst>
           </p:cNvPr>
@@ -3840,7 +3840,7 @@
     </p:spTree>
     <p:extLst>
       <p:ext uri="{BB962C8B-B14F-4D97-AF65-F5344CB8AC3E}">
-        <p14:creationId xmlns:p14="http://schemas.microsoft.com/office/powerpoint/2010/main" val="114061516"/>
+        <p14:creationId xmlns:p14="http://schemas.microsoft.com/office/powerpoint/2010/main" val="1062922992"/>
       </p:ext>
     </p:extLst>
   </p:cSld>
@@ -3871,7 +3871,7 @@
           <p:cNvPr id="13" name="">
             <a:extLst xmlns:a="http://schemas.openxmlformats.org/drawingml/2006/main">
               <a:ext uri="{FF2B5EF4-FFF2-40B4-BE49-F238E27FC236}">
-                <a16:creationId xmlns:a16="http://schemas.microsoft.com/office/drawing/2014/main" id="{F8617849-A7E5-4368-BFA0-9FC65AE956F8}"/>
+                <a16:creationId xmlns:a16="http://schemas.microsoft.com/office/drawing/2014/main" id="{186A4C11-4FFC-45A8-AC3D-74CE8EAE4149}"/>
               </a:ext>
             </a:extLst>
           </p:cNvPr>
@@ -3921,7 +3921,7 @@
           <p:cNvPr id="2" name="">
             <a:extLst xmlns:a="http://schemas.openxmlformats.org/drawingml/2006/main">
               <a:ext uri="{FF2B5EF4-FFF2-40B4-BE49-F238E27FC236}">
-                <a16:creationId xmlns:a16="http://schemas.microsoft.com/office/drawing/2014/main" id="{08F6DD2E-5CD0-44FA-8813-2047214B4070}"/>
+                <a16:creationId xmlns:a16="http://schemas.microsoft.com/office/drawing/2014/main" id="{3582125E-8FDF-46F3-86DE-FEDDC94962A1}"/>
               </a:ext>
             </a:extLst>
           </p:cNvPr>
@@ -3971,7 +3971,7 @@
           <p:cNvPr id="3" name="">
             <a:extLst xmlns:a="http://schemas.openxmlformats.org/drawingml/2006/main">
               <a:ext uri="{FF2B5EF4-FFF2-40B4-BE49-F238E27FC236}">
-                <a16:creationId xmlns:a16="http://schemas.microsoft.com/office/drawing/2014/main" id="{BCF6575C-63E2-4601-A611-7377EE06B1E3}"/>
+                <a16:creationId xmlns:a16="http://schemas.microsoft.com/office/drawing/2014/main" id="{F68150FC-BDAB-47AF-BFC3-64F4CBBF2D4F}"/>
               </a:ext>
             </a:extLst>
           </p:cNvPr>
@@ -4021,7 +4021,7 @@
           <p:cNvPr id="4" name="">
             <a:extLst xmlns:a="http://schemas.openxmlformats.org/drawingml/2006/main">
               <a:ext uri="{FF2B5EF4-FFF2-40B4-BE49-F238E27FC236}">
-                <a16:creationId xmlns:a16="http://schemas.microsoft.com/office/drawing/2014/main" id="{CEDBA894-F8E0-436E-9ED5-20E6CB9227C4}"/>
+                <a16:creationId xmlns:a16="http://schemas.microsoft.com/office/drawing/2014/main" id="{D3BFC130-FBA8-41A9-8768-546589759916}"/>
               </a:ext>
             </a:extLst>
           </p:cNvPr>
@@ -4071,7 +4071,7 @@
           <p:cNvPr id="5" name="">
             <a:extLst xmlns:a="http://schemas.openxmlformats.org/drawingml/2006/main">
               <a:ext uri="{FF2B5EF4-FFF2-40B4-BE49-F238E27FC236}">
-                <a16:creationId xmlns:a16="http://schemas.microsoft.com/office/drawing/2014/main" id="{9693B954-5FC1-4C0D-9A51-63C644F9D5FB}"/>
+                <a16:creationId xmlns:a16="http://schemas.microsoft.com/office/drawing/2014/main" id="{724C8D8B-9C63-4BB4-AE82-28B1B54B4F0D}"/>
               </a:ext>
             </a:extLst>
           </p:cNvPr>
@@ -4121,7 +4121,7 @@
           <p:cNvPr id="6" name="">
             <a:extLst xmlns:a="http://schemas.openxmlformats.org/drawingml/2006/main">
               <a:ext uri="{FF2B5EF4-FFF2-40B4-BE49-F238E27FC236}">
-                <a16:creationId xmlns:a16="http://schemas.microsoft.com/office/drawing/2014/main" id="{8B488EF9-C453-4FF1-AFAB-69DFD1BF9E28}"/>
+                <a16:creationId xmlns:a16="http://schemas.microsoft.com/office/drawing/2014/main" id="{86A4DEA5-E58C-4A9D-B49B-59C5009478AD}"/>
               </a:ext>
             </a:extLst>
           </p:cNvPr>
@@ -4188,7 +4188,7 @@
           <p:cNvPr id="7" name="">
             <a:extLst xmlns:a="http://schemas.openxmlformats.org/drawingml/2006/main">
               <a:ext uri="{FF2B5EF4-FFF2-40B4-BE49-F238E27FC236}">
-                <a16:creationId xmlns:a16="http://schemas.microsoft.com/office/drawing/2014/main" id="{F45CF28E-09E9-449E-ABC7-A51FB87187F2}"/>
+                <a16:creationId xmlns:a16="http://schemas.microsoft.com/office/drawing/2014/main" id="{27344995-9F2F-42EB-8F3C-68841A7C3E05}"/>
               </a:ext>
             </a:extLst>
           </p:cNvPr>
@@ -4223,7 +4223,7 @@
           <p:cNvPr id="8" name="">
             <a:extLst xmlns:a="http://schemas.openxmlformats.org/drawingml/2006/main">
               <a:ext uri="{FF2B5EF4-FFF2-40B4-BE49-F238E27FC236}">
-                <a16:creationId xmlns:a16="http://schemas.microsoft.com/office/drawing/2014/main" id="{069B465F-8A26-4A66-ABF7-0BA363DF3F55}"/>
+                <a16:creationId xmlns:a16="http://schemas.microsoft.com/office/drawing/2014/main" id="{9A92A5D1-338A-45A0-BE73-4638ADB29F17}"/>
               </a:ext>
             </a:extLst>
           </p:cNvPr>
@@ -4273,7 +4273,7 @@
           <p:cNvPr id="9" name="">
             <a:extLst xmlns:a="http://schemas.openxmlformats.org/drawingml/2006/main">
               <a:ext uri="{FF2B5EF4-FFF2-40B4-BE49-F238E27FC236}">
-                <a16:creationId xmlns:a16="http://schemas.microsoft.com/office/drawing/2014/main" id="{B15BE5CF-10EF-4C75-8DC2-F8909C5C9A9E}"/>
+                <a16:creationId xmlns:a16="http://schemas.microsoft.com/office/drawing/2014/main" id="{5F3AF9F3-6172-45E1-8333-40AF609B15E2}"/>
               </a:ext>
             </a:extLst>
           </p:cNvPr>
@@ -4323,7 +4323,7 @@
           <p:cNvPr id="10" name="">
             <a:extLst xmlns:a="http://schemas.openxmlformats.org/drawingml/2006/main">
               <a:ext uri="{FF2B5EF4-FFF2-40B4-BE49-F238E27FC236}">
-                <a16:creationId xmlns:a16="http://schemas.microsoft.com/office/drawing/2014/main" id="{0E520C96-0B0F-4E86-9669-CB6F37A31093}"/>
+                <a16:creationId xmlns:a16="http://schemas.microsoft.com/office/drawing/2014/main" id="{2F348BE4-3B87-4A8E-8D02-765085B44BE5}"/>
               </a:ext>
             </a:extLst>
           </p:cNvPr>
@@ -4362,7 +4362,7 @@
           <p:nvPr/>
         </p:nvPicPr>
         <p:blipFill>
-          <a:blip xmlns:r="http://schemas.openxmlformats.org/officeDocument/2006/relationships" xmlns:a="http://schemas.openxmlformats.org/drawingml/2006/main" r:embed="Raf30da1509e64569"/>
+          <a:blip xmlns:r="http://schemas.openxmlformats.org/officeDocument/2006/relationships" xmlns:a="http://schemas.openxmlformats.org/drawingml/2006/main" r:embed="R6502d5154b6548b6"/>
           <a:stretch xmlns:a="http://schemas.openxmlformats.org/drawingml/2006/main"/>
         </p:blipFill>
         <p:spPr>
@@ -4382,7 +4382,7 @@
           <p:cNvPr id="12" name="">
             <a:extLst xmlns:a="http://schemas.openxmlformats.org/drawingml/2006/main">
               <a:ext uri="{FF2B5EF4-FFF2-40B4-BE49-F238E27FC236}">
-                <a16:creationId xmlns:a16="http://schemas.microsoft.com/office/drawing/2014/main" id="{7EA09C3A-313D-42CF-981C-53DAC95B3597}"/>
+                <a16:creationId xmlns:a16="http://schemas.microsoft.com/office/drawing/2014/main" id="{5EBF847A-2E44-4DA2-962C-8832E0D506E9}"/>
               </a:ext>
             </a:extLst>
           </p:cNvPr>
@@ -4430,7 +4430,7 @@
     </p:spTree>
     <p:extLst>
       <p:ext uri="{BB962C8B-B14F-4D97-AF65-F5344CB8AC3E}">
-        <p14:creationId xmlns:p14="http://schemas.microsoft.com/office/powerpoint/2010/main" val="29486254"/>
+        <p14:creationId xmlns:p14="http://schemas.microsoft.com/office/powerpoint/2010/main" val="568561480"/>
       </p:ext>
     </p:extLst>
   </p:cSld>
@@ -4461,7 +4461,7 @@
           <p:cNvPr id="17" name="">
             <a:extLst xmlns:a="http://schemas.openxmlformats.org/drawingml/2006/main">
               <a:ext uri="{FF2B5EF4-FFF2-40B4-BE49-F238E27FC236}">
-                <a16:creationId xmlns:a16="http://schemas.microsoft.com/office/drawing/2014/main" id="{627349D1-1A42-401A-AAE7-D4F7FDD8C447}"/>
+                <a16:creationId xmlns:a16="http://schemas.microsoft.com/office/drawing/2014/main" id="{013CE9FF-217B-4ADB-B2AF-5A8D9F3A1F46}"/>
               </a:ext>
             </a:extLst>
           </p:cNvPr>
@@ -4511,7 +4511,7 @@
           <p:cNvPr id="2" name="">
             <a:extLst xmlns:a="http://schemas.openxmlformats.org/drawingml/2006/main">
               <a:ext uri="{FF2B5EF4-FFF2-40B4-BE49-F238E27FC236}">
-                <a16:creationId xmlns:a16="http://schemas.microsoft.com/office/drawing/2014/main" id="{52B38468-FAF9-4B6A-A189-DAC02FB955C8}"/>
+                <a16:creationId xmlns:a16="http://schemas.microsoft.com/office/drawing/2014/main" id="{FCA7A1C3-029D-4356-BB67-2535A3F7814F}"/>
               </a:ext>
             </a:extLst>
           </p:cNvPr>
@@ -4561,7 +4561,7 @@
           <p:cNvPr id="3" name="">
             <a:extLst xmlns:a="http://schemas.openxmlformats.org/drawingml/2006/main">
               <a:ext uri="{FF2B5EF4-FFF2-40B4-BE49-F238E27FC236}">
-                <a16:creationId xmlns:a16="http://schemas.microsoft.com/office/drawing/2014/main" id="{24CEB163-AFC3-48D2-9334-8EB605409F2A}"/>
+                <a16:creationId xmlns:a16="http://schemas.microsoft.com/office/drawing/2014/main" id="{73970624-7A3E-4792-9677-5ABC6FDC879E}"/>
               </a:ext>
             </a:extLst>
           </p:cNvPr>
@@ -4611,7 +4611,7 @@
           <p:cNvPr id="4" name="">
             <a:extLst xmlns:a="http://schemas.openxmlformats.org/drawingml/2006/main">
               <a:ext uri="{FF2B5EF4-FFF2-40B4-BE49-F238E27FC236}">
-                <a16:creationId xmlns:a16="http://schemas.microsoft.com/office/drawing/2014/main" id="{E68791DF-6EA6-477A-BE8D-A4375FBDEEFE}"/>
+                <a16:creationId xmlns:a16="http://schemas.microsoft.com/office/drawing/2014/main" id="{D3CFBED4-0BFB-4C7A-916C-71F34BE96740}"/>
               </a:ext>
             </a:extLst>
           </p:cNvPr>
@@ -4646,7 +4646,7 @@
           <p:cNvPr id="5" name="">
             <a:extLst xmlns:a="http://schemas.openxmlformats.org/drawingml/2006/main">
               <a:ext uri="{FF2B5EF4-FFF2-40B4-BE49-F238E27FC236}">
-                <a16:creationId xmlns:a16="http://schemas.microsoft.com/office/drawing/2014/main" id="{4D408B42-E618-4CAD-8348-8565A1F83CB8}"/>
+                <a16:creationId xmlns:a16="http://schemas.microsoft.com/office/drawing/2014/main" id="{11079ED2-CF83-45AA-94B5-88DB968F7A39}"/>
               </a:ext>
             </a:extLst>
           </p:cNvPr>
@@ -4696,7 +4696,7 @@
           <p:cNvPr id="6" name="">
             <a:extLst xmlns:a="http://schemas.openxmlformats.org/drawingml/2006/main">
               <a:ext uri="{FF2B5EF4-FFF2-40B4-BE49-F238E27FC236}">
-                <a16:creationId xmlns:a16="http://schemas.microsoft.com/office/drawing/2014/main" id="{28D4C14E-1F21-4572-806E-3B82A18716F2}"/>
+                <a16:creationId xmlns:a16="http://schemas.microsoft.com/office/drawing/2014/main" id="{76579272-838A-403A-92B0-948FA2830421}"/>
               </a:ext>
             </a:extLst>
           </p:cNvPr>
@@ -4780,7 +4780,7 @@
           <p:cNvPr id="7" name="">
             <a:extLst xmlns:a="http://schemas.openxmlformats.org/drawingml/2006/main">
               <a:ext uri="{FF2B5EF4-FFF2-40B4-BE49-F238E27FC236}">
-                <a16:creationId xmlns:a16="http://schemas.microsoft.com/office/drawing/2014/main" id="{0A2A603E-1A7E-4774-8692-05F49A42EC16}"/>
+                <a16:creationId xmlns:a16="http://schemas.microsoft.com/office/drawing/2014/main" id="{278D2DA1-9D13-472C-BBC0-6C6D33C1859A}"/>
               </a:ext>
             </a:extLst>
           </p:cNvPr>
@@ -4815,7 +4815,7 @@
           <p:cNvPr id="8" name="">
             <a:extLst xmlns:a="http://schemas.openxmlformats.org/drawingml/2006/main">
               <a:ext uri="{FF2B5EF4-FFF2-40B4-BE49-F238E27FC236}">
-                <a16:creationId xmlns:a16="http://schemas.microsoft.com/office/drawing/2014/main" id="{FA530B8F-0AF0-48D7-832F-B07EBCC22098}"/>
+                <a16:creationId xmlns:a16="http://schemas.microsoft.com/office/drawing/2014/main" id="{E203D2F7-2F77-4BBD-99AA-BD002AB2269A}"/>
               </a:ext>
             </a:extLst>
           </p:cNvPr>
@@ -4865,7 +4865,7 @@
           <p:cNvPr id="9" name="">
             <a:extLst xmlns:a="http://schemas.openxmlformats.org/drawingml/2006/main">
               <a:ext uri="{FF2B5EF4-FFF2-40B4-BE49-F238E27FC236}">
-                <a16:creationId xmlns:a16="http://schemas.microsoft.com/office/drawing/2014/main" id="{E1C5384D-FB2B-44E8-9DCD-B21C439E4DE5}"/>
+                <a16:creationId xmlns:a16="http://schemas.microsoft.com/office/drawing/2014/main" id="{2AFAC294-1120-4358-8725-707120589C06}"/>
               </a:ext>
             </a:extLst>
           </p:cNvPr>
@@ -4905,7 +4905,7 @@
                   <a:srgbClr val="13251F"/>
                 </a:solidFill>
               </a:rPr>
-              <a:t>사용자 버튼으로 실행</a:t>
+              <a:t>Gemini API 호출</a:t>
             </a:r>
           </a:p>
           <a:p xmlns:a="http://schemas.openxmlformats.org/drawingml/2006/main">
@@ -4949,7 +4949,7 @@
           <p:cNvPr id="10" name="">
             <a:extLst xmlns:a="http://schemas.openxmlformats.org/drawingml/2006/main">
               <a:ext uri="{FF2B5EF4-FFF2-40B4-BE49-F238E27FC236}">
-                <a16:creationId xmlns:a16="http://schemas.microsoft.com/office/drawing/2014/main" id="{E4DA8A7A-DD2E-4B4A-8C8D-AA9331695FBB}"/>
+                <a16:creationId xmlns:a16="http://schemas.microsoft.com/office/drawing/2014/main" id="{92168CA8-69EA-4890-9020-4D5DFDCE05FD}"/>
               </a:ext>
             </a:extLst>
           </p:cNvPr>
@@ -4984,7 +4984,7 @@
           <p:cNvPr id="11" name="">
             <a:extLst xmlns:a="http://schemas.openxmlformats.org/drawingml/2006/main">
               <a:ext uri="{FF2B5EF4-FFF2-40B4-BE49-F238E27FC236}">
-                <a16:creationId xmlns:a16="http://schemas.microsoft.com/office/drawing/2014/main" id="{7A29D1EC-2F58-4399-98FA-DD78F7822915}"/>
+                <a16:creationId xmlns:a16="http://schemas.microsoft.com/office/drawing/2014/main" id="{49E7CFE4-4C8F-48EC-875B-509C2BF827D1}"/>
               </a:ext>
             </a:extLst>
           </p:cNvPr>
@@ -5034,7 +5034,7 @@
           <p:cNvPr id="12" name="">
             <a:extLst xmlns:a="http://schemas.openxmlformats.org/drawingml/2006/main">
               <a:ext uri="{FF2B5EF4-FFF2-40B4-BE49-F238E27FC236}">
-                <a16:creationId xmlns:a16="http://schemas.microsoft.com/office/drawing/2014/main" id="{2161CA59-ED05-4055-BC9C-55A4302A45A5}"/>
+                <a16:creationId xmlns:a16="http://schemas.microsoft.com/office/drawing/2014/main" id="{F510096E-210C-447B-B315-4A22D6665153}"/>
               </a:ext>
             </a:extLst>
           </p:cNvPr>
@@ -5118,7 +5118,7 @@
           <p:cNvPr id="13" name="">
             <a:extLst xmlns:a="http://schemas.openxmlformats.org/drawingml/2006/main">
               <a:ext uri="{FF2B5EF4-FFF2-40B4-BE49-F238E27FC236}">
-                <a16:creationId xmlns:a16="http://schemas.microsoft.com/office/drawing/2014/main" id="{FBD57438-25F2-4EAB-AF02-4ABCC3FFF356}"/>
+                <a16:creationId xmlns:a16="http://schemas.microsoft.com/office/drawing/2014/main" id="{28F645F0-C956-451A-9AE6-8A1885D8AFBE}"/>
               </a:ext>
             </a:extLst>
           </p:cNvPr>
@@ -5168,7 +5168,7 @@
           <p:cNvPr id="14" name="">
             <a:extLst xmlns:a="http://schemas.openxmlformats.org/drawingml/2006/main">
               <a:ext uri="{FF2B5EF4-FFF2-40B4-BE49-F238E27FC236}">
-                <a16:creationId xmlns:a16="http://schemas.microsoft.com/office/drawing/2014/main" id="{BD9ED19E-7DFE-496D-9F67-C9188523304F}"/>
+                <a16:creationId xmlns:a16="http://schemas.microsoft.com/office/drawing/2014/main" id="{BE643843-4A20-4830-A287-F2C7C1B078EB}"/>
               </a:ext>
             </a:extLst>
           </p:cNvPr>
@@ -5218,7 +5218,7 @@
           <p:cNvPr id="15" name="">
             <a:extLst xmlns:a="http://schemas.openxmlformats.org/drawingml/2006/main">
               <a:ext uri="{FF2B5EF4-FFF2-40B4-BE49-F238E27FC236}">
-                <a16:creationId xmlns:a16="http://schemas.microsoft.com/office/drawing/2014/main" id="{865A2A85-7C2C-4060-B72C-41D689262634}"/>
+                <a16:creationId xmlns:a16="http://schemas.microsoft.com/office/drawing/2014/main" id="{60822472-7610-49CE-BB67-19C1B4B65A24}"/>
               </a:ext>
             </a:extLst>
           </p:cNvPr>
@@ -5268,7 +5268,7 @@
           <p:cNvPr id="16" name="">
             <a:extLst xmlns:a="http://schemas.openxmlformats.org/drawingml/2006/main">
               <a:ext uri="{FF2B5EF4-FFF2-40B4-BE49-F238E27FC236}">
-                <a16:creationId xmlns:a16="http://schemas.microsoft.com/office/drawing/2014/main" id="{52A6FF4E-4FBC-4150-A5DB-185E0AE2331E}"/>
+                <a16:creationId xmlns:a16="http://schemas.microsoft.com/office/drawing/2014/main" id="{1205F78C-B61C-4B07-A05D-87161F8C3BBC}"/>
               </a:ext>
             </a:extLst>
           </p:cNvPr>
@@ -5316,7 +5316,7 @@
     </p:spTree>
     <p:extLst>
       <p:ext uri="{BB962C8B-B14F-4D97-AF65-F5344CB8AC3E}">
-        <p14:creationId xmlns:p14="http://schemas.microsoft.com/office/powerpoint/2010/main" val="2117564913"/>
+        <p14:creationId xmlns:p14="http://schemas.microsoft.com/office/powerpoint/2010/main" val="2064082378"/>
       </p:ext>
     </p:extLst>
   </p:cSld>
@@ -5347,7 +5347,7 @@
           <p:cNvPr id="13" name="">
             <a:extLst xmlns:a="http://schemas.openxmlformats.org/drawingml/2006/main">
               <a:ext uri="{FF2B5EF4-FFF2-40B4-BE49-F238E27FC236}">
-                <a16:creationId xmlns:a16="http://schemas.microsoft.com/office/drawing/2014/main" id="{4811CE00-F43B-4E5F-B3F1-B620429BD831}"/>
+                <a16:creationId xmlns:a16="http://schemas.microsoft.com/office/drawing/2014/main" id="{1E0175E7-7950-4161-99F2-0DCB46957773}"/>
               </a:ext>
             </a:extLst>
           </p:cNvPr>
@@ -5397,7 +5397,7 @@
           <p:cNvPr id="2" name="">
             <a:extLst xmlns:a="http://schemas.openxmlformats.org/drawingml/2006/main">
               <a:ext uri="{FF2B5EF4-FFF2-40B4-BE49-F238E27FC236}">
-                <a16:creationId xmlns:a16="http://schemas.microsoft.com/office/drawing/2014/main" id="{1A2E6679-DD7C-4FF8-A3B0-E99E43AF7CA4}"/>
+                <a16:creationId xmlns:a16="http://schemas.microsoft.com/office/drawing/2014/main" id="{060A858D-2712-444B-A408-6C84F56A9C49}"/>
               </a:ext>
             </a:extLst>
           </p:cNvPr>
@@ -5447,7 +5447,7 @@
           <p:cNvPr id="3" name="">
             <a:extLst xmlns:a="http://schemas.openxmlformats.org/drawingml/2006/main">
               <a:ext uri="{FF2B5EF4-FFF2-40B4-BE49-F238E27FC236}">
-                <a16:creationId xmlns:a16="http://schemas.microsoft.com/office/drawing/2014/main" id="{665BD110-215D-4818-B189-1974883BCAD8}"/>
+                <a16:creationId xmlns:a16="http://schemas.microsoft.com/office/drawing/2014/main" id="{A0E01F9D-A344-41CB-A5A6-05BF4E7FD35D}"/>
               </a:ext>
             </a:extLst>
           </p:cNvPr>
@@ -5497,7 +5497,7 @@
           <p:cNvPr id="4" name="">
             <a:extLst xmlns:a="http://schemas.openxmlformats.org/drawingml/2006/main">
               <a:ext uri="{FF2B5EF4-FFF2-40B4-BE49-F238E27FC236}">
-                <a16:creationId xmlns:a16="http://schemas.microsoft.com/office/drawing/2014/main" id="{C352D24C-6F2D-43BE-88DD-66ABC8730E61}"/>
+                <a16:creationId xmlns:a16="http://schemas.microsoft.com/office/drawing/2014/main" id="{72798779-CCB8-4162-A0A4-CB8A9B0854B3}"/>
               </a:ext>
             </a:extLst>
           </p:cNvPr>
@@ -5532,7 +5532,7 @@
           <p:cNvPr id="5" name="">
             <a:extLst xmlns:a="http://schemas.openxmlformats.org/drawingml/2006/main">
               <a:ext uri="{FF2B5EF4-FFF2-40B4-BE49-F238E27FC236}">
-                <a16:creationId xmlns:a16="http://schemas.microsoft.com/office/drawing/2014/main" id="{80A91EA3-7ABE-4195-84F7-4EACC5F6A9D1}"/>
+                <a16:creationId xmlns:a16="http://schemas.microsoft.com/office/drawing/2014/main" id="{2E222944-6F17-45A2-A948-855491E1399A}"/>
               </a:ext>
             </a:extLst>
           </p:cNvPr>
@@ -5582,7 +5582,7 @@
           <p:cNvPr id="6" name="">
             <a:extLst xmlns:a="http://schemas.openxmlformats.org/drawingml/2006/main">
               <a:ext uri="{FF2B5EF4-FFF2-40B4-BE49-F238E27FC236}">
-                <a16:creationId xmlns:a16="http://schemas.microsoft.com/office/drawing/2014/main" id="{7A3A6D6B-97F3-4D26-9EA3-1E03BFA7B61F}"/>
+                <a16:creationId xmlns:a16="http://schemas.microsoft.com/office/drawing/2014/main" id="{6AC3DC72-662E-42DD-B2D3-5F12678E83E3}"/>
               </a:ext>
             </a:extLst>
           </p:cNvPr>
@@ -5683,7 +5683,7 @@
           <p:cNvPr id="7" name="">
             <a:extLst xmlns:a="http://schemas.openxmlformats.org/drawingml/2006/main">
               <a:ext uri="{FF2B5EF4-FFF2-40B4-BE49-F238E27FC236}">
-                <a16:creationId xmlns:a16="http://schemas.microsoft.com/office/drawing/2014/main" id="{2A9FD0E7-B346-46A9-83C8-E3E3DF4369AF}"/>
+                <a16:creationId xmlns:a16="http://schemas.microsoft.com/office/drawing/2014/main" id="{048622D7-DF18-4073-9F5B-4C72925C315C}"/>
               </a:ext>
             </a:extLst>
           </p:cNvPr>
@@ -5733,7 +5733,7 @@
           <p:cNvPr id="8" name="">
             <a:extLst xmlns:a="http://schemas.openxmlformats.org/drawingml/2006/main">
               <a:ext uri="{FF2B5EF4-FFF2-40B4-BE49-F238E27FC236}">
-                <a16:creationId xmlns:a16="http://schemas.microsoft.com/office/drawing/2014/main" id="{80822021-FF03-4E6A-AFA8-1C0711DE7C12}"/>
+                <a16:creationId xmlns:a16="http://schemas.microsoft.com/office/drawing/2014/main" id="{77555647-F054-45E9-A0A3-FBC69088AA41}"/>
               </a:ext>
             </a:extLst>
           </p:cNvPr>
@@ -5783,7 +5783,7 @@
           <p:cNvPr id="9" name="">
             <a:extLst xmlns:a="http://schemas.openxmlformats.org/drawingml/2006/main">
               <a:ext uri="{FF2B5EF4-FFF2-40B4-BE49-F238E27FC236}">
-                <a16:creationId xmlns:a16="http://schemas.microsoft.com/office/drawing/2014/main" id="{4FEA68AF-E40B-40FE-9806-876E771905FC}"/>
+                <a16:creationId xmlns:a16="http://schemas.microsoft.com/office/drawing/2014/main" id="{2791591B-8007-4E61-A953-C60C292EF1B1}"/>
               </a:ext>
             </a:extLst>
           </p:cNvPr>
@@ -5867,7 +5867,7 @@
           <p:cNvPr id="10" name="">
             <a:extLst xmlns:a="http://schemas.openxmlformats.org/drawingml/2006/main">
               <a:ext uri="{FF2B5EF4-FFF2-40B4-BE49-F238E27FC236}">
-                <a16:creationId xmlns:a16="http://schemas.microsoft.com/office/drawing/2014/main" id="{07279791-C692-4949-B492-181311677D22}"/>
+                <a16:creationId xmlns:a16="http://schemas.microsoft.com/office/drawing/2014/main" id="{C699D08C-738D-4B94-86B7-06408B052E19}"/>
               </a:ext>
             </a:extLst>
           </p:cNvPr>
@@ -5902,7 +5902,7 @@
           <p:cNvPr id="11" name="">
             <a:extLst xmlns:a="http://schemas.openxmlformats.org/drawingml/2006/main">
               <a:ext uri="{FF2B5EF4-FFF2-40B4-BE49-F238E27FC236}">
-                <a16:creationId xmlns:a16="http://schemas.microsoft.com/office/drawing/2014/main" id="{EE4FDFD6-CABF-4B77-8C08-679D55D9E889}"/>
+                <a16:creationId xmlns:a16="http://schemas.microsoft.com/office/drawing/2014/main" id="{2A97A31B-5C00-40B7-ACF8-76382D13F60B}"/>
               </a:ext>
             </a:extLst>
           </p:cNvPr>
@@ -5952,7 +5952,7 @@
           <p:cNvPr id="12" name="">
             <a:extLst xmlns:a="http://schemas.openxmlformats.org/drawingml/2006/main">
               <a:ext uri="{FF2B5EF4-FFF2-40B4-BE49-F238E27FC236}">
-                <a16:creationId xmlns:a16="http://schemas.microsoft.com/office/drawing/2014/main" id="{CF055387-7BB9-4E82-821F-686654309892}"/>
+                <a16:creationId xmlns:a16="http://schemas.microsoft.com/office/drawing/2014/main" id="{AFFFA557-3863-49C4-8DAD-EF0BC1FD0EB9}"/>
               </a:ext>
             </a:extLst>
           </p:cNvPr>
@@ -6000,7 +6000,7 @@
     </p:spTree>
     <p:extLst>
       <p:ext uri="{BB962C8B-B14F-4D97-AF65-F5344CB8AC3E}">
-        <p14:creationId xmlns:p14="http://schemas.microsoft.com/office/powerpoint/2010/main" val="955849613"/>
+        <p14:creationId xmlns:p14="http://schemas.microsoft.com/office/powerpoint/2010/main" val="2107002189"/>
       </p:ext>
     </p:extLst>
   </p:cSld>
@@ -6031,7 +6031,7 @@
           <p:cNvPr id="8" name="">
             <a:extLst xmlns:a="http://schemas.openxmlformats.org/drawingml/2006/main">
               <a:ext uri="{FF2B5EF4-FFF2-40B4-BE49-F238E27FC236}">
-                <a16:creationId xmlns:a16="http://schemas.microsoft.com/office/drawing/2014/main" id="{3EC18047-86A4-43D5-A740-F5CDB681D206}"/>
+                <a16:creationId xmlns:a16="http://schemas.microsoft.com/office/drawing/2014/main" id="{CA1CAF72-9459-47BD-B5D0-93D5D3265AFB}"/>
               </a:ext>
             </a:extLst>
           </p:cNvPr>
@@ -6081,7 +6081,7 @@
           <p:cNvPr id="2" name="">
             <a:extLst xmlns:a="http://schemas.openxmlformats.org/drawingml/2006/main">
               <a:ext uri="{FF2B5EF4-FFF2-40B4-BE49-F238E27FC236}">
-                <a16:creationId xmlns:a16="http://schemas.microsoft.com/office/drawing/2014/main" id="{FF721EF6-B936-4225-87A9-EC32F6BB9865}"/>
+                <a16:creationId xmlns:a16="http://schemas.microsoft.com/office/drawing/2014/main" id="{61957405-2510-4847-A016-25B24207B3B3}"/>
               </a:ext>
             </a:extLst>
           </p:cNvPr>
@@ -6148,7 +6148,7 @@
           <p:cNvPr id="3" name="">
             <a:extLst xmlns:a="http://schemas.openxmlformats.org/drawingml/2006/main">
               <a:ext uri="{FF2B5EF4-FFF2-40B4-BE49-F238E27FC236}">
-                <a16:creationId xmlns:a16="http://schemas.microsoft.com/office/drawing/2014/main" id="{E982E847-C208-463A-A1D0-8BA94B5C1101}"/>
+                <a16:creationId xmlns:a16="http://schemas.microsoft.com/office/drawing/2014/main" id="{D8CA87B2-6091-42A6-B94F-7D0A00BF9BFF}"/>
               </a:ext>
             </a:extLst>
           </p:cNvPr>
@@ -6183,7 +6183,7 @@
           <p:cNvPr id="4" name="">
             <a:extLst xmlns:a="http://schemas.openxmlformats.org/drawingml/2006/main">
               <a:ext uri="{FF2B5EF4-FFF2-40B4-BE49-F238E27FC236}">
-                <a16:creationId xmlns:a16="http://schemas.microsoft.com/office/drawing/2014/main" id="{EB5EB5FB-2117-479F-87B6-A8A872DB0396}"/>
+                <a16:creationId xmlns:a16="http://schemas.microsoft.com/office/drawing/2014/main" id="{817131AF-543D-41FF-AE15-70CF7E7B6046}"/>
               </a:ext>
             </a:extLst>
           </p:cNvPr>
@@ -6233,7 +6233,7 @@
           <p:cNvPr id="5" name="">
             <a:extLst xmlns:a="http://schemas.openxmlformats.org/drawingml/2006/main">
               <a:ext uri="{FF2B5EF4-FFF2-40B4-BE49-F238E27FC236}">
-                <a16:creationId xmlns:a16="http://schemas.microsoft.com/office/drawing/2014/main" id="{C945C9CC-3094-49E4-AD8C-6E8025133E5C}"/>
+                <a16:creationId xmlns:a16="http://schemas.microsoft.com/office/drawing/2014/main" id="{AA86F5FC-CEF2-43F7-8F80-B04A91FCA540}"/>
               </a:ext>
             </a:extLst>
           </p:cNvPr>
@@ -6283,7 +6283,7 @@
           <p:cNvPr id="6" name="">
             <a:extLst xmlns:a="http://schemas.openxmlformats.org/drawingml/2006/main">
               <a:ext uri="{FF2B5EF4-FFF2-40B4-BE49-F238E27FC236}">
-                <a16:creationId xmlns:a16="http://schemas.microsoft.com/office/drawing/2014/main" id="{28DFA39C-27EA-40C8-A2EE-0241408B11FF}"/>
+                <a16:creationId xmlns:a16="http://schemas.microsoft.com/office/drawing/2014/main" id="{47B16845-926F-4EED-9BAF-F326D0DCA358}"/>
               </a:ext>
             </a:extLst>
           </p:cNvPr>
@@ -6333,7 +6333,7 @@
           <p:cNvPr id="7" name="">
             <a:extLst xmlns:a="http://schemas.openxmlformats.org/drawingml/2006/main">
               <a:ext uri="{FF2B5EF4-FFF2-40B4-BE49-F238E27FC236}">
-                <a16:creationId xmlns:a16="http://schemas.microsoft.com/office/drawing/2014/main" id="{F1FEE9EA-8F22-43E1-8D52-045F68A04E37}"/>
+                <a16:creationId xmlns:a16="http://schemas.microsoft.com/office/drawing/2014/main" id="{F935C04D-0428-4240-AE82-BC0A7CA8AA93}"/>
               </a:ext>
             </a:extLst>
           </p:cNvPr>
@@ -6381,7 +6381,7 @@
     </p:spTree>
     <p:extLst>
       <p:ext uri="{BB962C8B-B14F-4D97-AF65-F5344CB8AC3E}">
-        <p14:creationId xmlns:p14="http://schemas.microsoft.com/office/powerpoint/2010/main" val="1246154776"/>
+        <p14:creationId xmlns:p14="http://schemas.microsoft.com/office/powerpoint/2010/main" val="898429797"/>
       </p:ext>
     </p:extLst>
   </p:cSld>

</xml_diff>

<commit_message>
Batch Gemini analysis for all subscriptions
</commit_message>
<xml_diff>
--- a/deliverables/subscription-cleaning-wanted-ai-championship-2026.pptx
+++ b/deliverables/subscription-cleaning-wanted-ai-championship-2026.pptx
@@ -2,19 +2,19 @@
 <file path=ppt/presentation.xml><?xml version="1.0" encoding="utf-8"?>
 <p:presentation xmlns:p="http://schemas.openxmlformats.org/presentationml/2006/main">
   <p:sldMasterIdLst>
-    <p:sldMasterId xmlns:r="http://schemas.openxmlformats.org/officeDocument/2006/relationships" id="2147483648" r:id="Rb1252781b9a142ce"/>
+    <p:sldMasterId xmlns:r="http://schemas.openxmlformats.org/officeDocument/2006/relationships" id="2147483648" r:id="Ra6ba0bb245ca4ecd"/>
   </p:sldMasterIdLst>
   <p:notesMasterIdLst>
-    <p:notesMasterId xmlns:r="http://schemas.openxmlformats.org/officeDocument/2006/relationships" r:id="Rc065c826e8ad49f0"/>
+    <p:notesMasterId xmlns:r="http://schemas.openxmlformats.org/officeDocument/2006/relationships" r:id="Rf5ca0f4503a24c83"/>
   </p:notesMasterIdLst>
   <p:sldIdLst>
-    <p:sldId xmlns:r="http://schemas.openxmlformats.org/officeDocument/2006/relationships" id="256" r:id="R529bd0d86ee4431e"/>
-    <p:sldId xmlns:r="http://schemas.openxmlformats.org/officeDocument/2006/relationships" id="257" r:id="Rd6fdf6d770924428"/>
-    <p:sldId xmlns:r="http://schemas.openxmlformats.org/officeDocument/2006/relationships" id="258" r:id="R7fe8550b04f340ac"/>
-    <p:sldId xmlns:r="http://schemas.openxmlformats.org/officeDocument/2006/relationships" id="259" r:id="Rb3ee4a4ff9de4d0a"/>
-    <p:sldId xmlns:r="http://schemas.openxmlformats.org/officeDocument/2006/relationships" id="260" r:id="Rf1d4713bc09845b5"/>
-    <p:sldId xmlns:r="http://schemas.openxmlformats.org/officeDocument/2006/relationships" id="261" r:id="R3f0628f01c3d47b9"/>
-    <p:sldId xmlns:r="http://schemas.openxmlformats.org/officeDocument/2006/relationships" id="262" r:id="R338f942093ef4f80"/>
+    <p:sldId xmlns:r="http://schemas.openxmlformats.org/officeDocument/2006/relationships" id="256" r:id="Rc49e9e400b324fc6"/>
+    <p:sldId xmlns:r="http://schemas.openxmlformats.org/officeDocument/2006/relationships" id="257" r:id="Re677eb668c8b463d"/>
+    <p:sldId xmlns:r="http://schemas.openxmlformats.org/officeDocument/2006/relationships" id="258" r:id="R72f5d2c9ca2c4ce3"/>
+    <p:sldId xmlns:r="http://schemas.openxmlformats.org/officeDocument/2006/relationships" id="259" r:id="Rdc2781ca200d49ef"/>
+    <p:sldId xmlns:r="http://schemas.openxmlformats.org/officeDocument/2006/relationships" id="260" r:id="Rc13e43d3c16848c8"/>
+    <p:sldId xmlns:r="http://schemas.openxmlformats.org/officeDocument/2006/relationships" id="261" r:id="Reebb75b7f5ed489f"/>
+    <p:sldId xmlns:r="http://schemas.openxmlformats.org/officeDocument/2006/relationships" id="262" r:id="R24df89ed5ae64454"/>
   </p:sldIdLst>
   <p:sldSz cx="12192000" cy="6858000"/>
   <p:notesSz cx="6858000" cy="9144000"/>
@@ -718,7 +718,7 @@
           <a:lstStyle xmlns:a="http://schemas.openxmlformats.org/drawingml/2006/main"/>
           <a:p xmlns:a="http://schemas.openxmlformats.org/drawingml/2006/main">
             <a:r>
-              <a:t>시연 화면은 샘플 결제내역을 분석한 실제 로컬 실행 결과입니다. 14건에서 5개 후보가 생성되고, 결제처가 통합·분류됩니다. 후보 카드의 AI 설명 버튼을 누르면 설명 모달이 열립니다.</a:t>
+              <a:t>시연 화면은 샘플 결제내역을 분석한 실제 로컬 실행 결과입니다. 14건에서 5개 후보가 생성되고, 결제처가 통합·분류됩니다. 분석 버튼을 다시 누르면 전체 후보의 AI 설명을 한 번에 요청합니다.</a:t>
             </a:r>
           </a:p>
           <a:p xmlns:a="http://schemas.openxmlformats.org/drawingml/2006/main">
@@ -1111,7 +1111,7 @@
   </p:cSld>
   <p:clrMap bg1="lt1" tx1="dk1" bg2="lt2" tx2="dk2" accent1="accent1" accent2="accent2" accent3="accent3" accent4="accent4" accent5="accent5" accent6="accent6" hlink="hlink" folHlink="folHlink"/>
   <p:sldLayoutIdLst>
-    <p:sldLayoutId xmlns:r="http://schemas.openxmlformats.org/officeDocument/2006/relationships" id="2147483649" r:id="Ra1fb1e080fe74019"/>
+    <p:sldLayoutId xmlns:r="http://schemas.openxmlformats.org/officeDocument/2006/relationships" id="2147483649" r:id="R3cb683abfdd741c0"/>
   </p:sldLayoutIdLst>
   <p:txStyles>
     <p:titleStyle>
@@ -1662,7 +1662,7 @@
           <p:cNvPr id="7" name="">
             <a:extLst xmlns:a="http://schemas.openxmlformats.org/drawingml/2006/main">
               <a:ext uri="{FF2B5EF4-FFF2-40B4-BE49-F238E27FC236}">
-                <a16:creationId xmlns:a16="http://schemas.microsoft.com/office/drawing/2014/main" id="{EA19BC6E-F26D-4781-AD88-0D6807BAE0B9}"/>
+                <a16:creationId xmlns:a16="http://schemas.microsoft.com/office/drawing/2014/main" id="{464363B0-3BCB-4232-ACCD-8E4EB8F67CFB}"/>
               </a:ext>
             </a:extLst>
           </p:cNvPr>
@@ -1695,7 +1695,7 @@
           <p:cNvPr id="2" name="">
             <a:extLst xmlns:a="http://schemas.openxmlformats.org/drawingml/2006/main">
               <a:ext uri="{FF2B5EF4-FFF2-40B4-BE49-F238E27FC236}">
-                <a16:creationId xmlns:a16="http://schemas.microsoft.com/office/drawing/2014/main" id="{A7BE7C9A-582B-4540-8FC1-2F5E0B7D40A0}"/>
+                <a16:creationId xmlns:a16="http://schemas.microsoft.com/office/drawing/2014/main" id="{8958A360-205C-4A30-8963-3211DEAD5C88}"/>
               </a:ext>
             </a:extLst>
           </p:cNvPr>
@@ -1745,7 +1745,7 @@
           <p:cNvPr id="3" name="">
             <a:extLst xmlns:a="http://schemas.openxmlformats.org/drawingml/2006/main">
               <a:ext uri="{FF2B5EF4-FFF2-40B4-BE49-F238E27FC236}">
-                <a16:creationId xmlns:a16="http://schemas.microsoft.com/office/drawing/2014/main" id="{88AB75C7-2D38-4E0B-AEF9-7D46D284F10C}"/>
+                <a16:creationId xmlns:a16="http://schemas.microsoft.com/office/drawing/2014/main" id="{634B4F9D-32A1-4076-83C5-D72D1AFE65A6}"/>
               </a:ext>
             </a:extLst>
           </p:cNvPr>
@@ -1812,7 +1812,7 @@
           <p:cNvPr id="4" name="">
             <a:extLst xmlns:a="http://schemas.openxmlformats.org/drawingml/2006/main">
               <a:ext uri="{FF2B5EF4-FFF2-40B4-BE49-F238E27FC236}">
-                <a16:creationId xmlns:a16="http://schemas.microsoft.com/office/drawing/2014/main" id="{C6A2AE35-2FDB-488D-8DDF-D9B55B3E169C}"/>
+                <a16:creationId xmlns:a16="http://schemas.microsoft.com/office/drawing/2014/main" id="{3224ABB8-6863-420A-B757-F1608DFDD5E1}"/>
               </a:ext>
             </a:extLst>
           </p:cNvPr>
@@ -1862,7 +1862,7 @@
           <p:cNvPr id="5" name="">
             <a:extLst xmlns:a="http://schemas.openxmlformats.org/drawingml/2006/main">
               <a:ext uri="{FF2B5EF4-FFF2-40B4-BE49-F238E27FC236}">
-                <a16:creationId xmlns:a16="http://schemas.microsoft.com/office/drawing/2014/main" id="{98E48D2A-11AC-4C93-A7BE-34ECB6C7E267}"/>
+                <a16:creationId xmlns:a16="http://schemas.microsoft.com/office/drawing/2014/main" id="{3B60D65D-2085-4C5A-9D62-3F0450F13951}"/>
               </a:ext>
             </a:extLst>
           </p:cNvPr>
@@ -1901,7 +1901,7 @@
           <p:nvPr/>
         </p:nvPicPr>
         <p:blipFill>
-          <a:blip xmlns:r="http://schemas.openxmlformats.org/officeDocument/2006/relationships" xmlns:a="http://schemas.openxmlformats.org/drawingml/2006/main" r:embed="R92e1629d2bc44079"/>
+          <a:blip xmlns:r="http://schemas.openxmlformats.org/officeDocument/2006/relationships" xmlns:a="http://schemas.openxmlformats.org/drawingml/2006/main" r:embed="Raaba8cc343594f86"/>
           <a:stretch xmlns:a="http://schemas.openxmlformats.org/drawingml/2006/main"/>
         </p:blipFill>
         <p:spPr>
@@ -1919,7 +1919,7 @@
     </p:spTree>
     <p:extLst>
       <p:ext uri="{BB962C8B-B14F-4D97-AF65-F5344CB8AC3E}">
-        <p14:creationId xmlns:p14="http://schemas.microsoft.com/office/powerpoint/2010/main" val="2111704040"/>
+        <p14:creationId xmlns:p14="http://schemas.microsoft.com/office/powerpoint/2010/main" val="1229725563"/>
       </p:ext>
     </p:extLst>
   </p:cSld>
@@ -1950,7 +1950,7 @@
           <p:cNvPr id="15" name="">
             <a:extLst xmlns:a="http://schemas.openxmlformats.org/drawingml/2006/main">
               <a:ext uri="{FF2B5EF4-FFF2-40B4-BE49-F238E27FC236}">
-                <a16:creationId xmlns:a16="http://schemas.microsoft.com/office/drawing/2014/main" id="{FDB5E653-4532-495C-A234-DE4121B7305D}"/>
+                <a16:creationId xmlns:a16="http://schemas.microsoft.com/office/drawing/2014/main" id="{0CDACBBE-4D23-47EF-8DB8-8B16357C889E}"/>
               </a:ext>
             </a:extLst>
           </p:cNvPr>
@@ -2000,7 +2000,7 @@
           <p:cNvPr id="2" name="">
             <a:extLst xmlns:a="http://schemas.openxmlformats.org/drawingml/2006/main">
               <a:ext uri="{FF2B5EF4-FFF2-40B4-BE49-F238E27FC236}">
-                <a16:creationId xmlns:a16="http://schemas.microsoft.com/office/drawing/2014/main" id="{8ECF86E7-6574-4C93-B30B-2809F612A425}"/>
+                <a16:creationId xmlns:a16="http://schemas.microsoft.com/office/drawing/2014/main" id="{A445DAA9-DE18-453B-936B-3927A966BE1F}"/>
               </a:ext>
             </a:extLst>
           </p:cNvPr>
@@ -2050,7 +2050,7 @@
           <p:cNvPr id="3" name="">
             <a:extLst xmlns:a="http://schemas.openxmlformats.org/drawingml/2006/main">
               <a:ext uri="{FF2B5EF4-FFF2-40B4-BE49-F238E27FC236}">
-                <a16:creationId xmlns:a16="http://schemas.microsoft.com/office/drawing/2014/main" id="{779ABD5D-9A76-4219-952D-47E4E18CDBB6}"/>
+                <a16:creationId xmlns:a16="http://schemas.microsoft.com/office/drawing/2014/main" id="{F3523DAC-A0C8-4DE0-B92A-F15B8E705134}"/>
               </a:ext>
             </a:extLst>
           </p:cNvPr>
@@ -2100,7 +2100,7 @@
           <p:cNvPr id="4" name="">
             <a:extLst xmlns:a="http://schemas.openxmlformats.org/drawingml/2006/main">
               <a:ext uri="{FF2B5EF4-FFF2-40B4-BE49-F238E27FC236}">
-                <a16:creationId xmlns:a16="http://schemas.microsoft.com/office/drawing/2014/main" id="{C9BAAFF2-0895-4350-9F7C-DE761D8EF967}"/>
+                <a16:creationId xmlns:a16="http://schemas.microsoft.com/office/drawing/2014/main" id="{D8C3D99D-CACC-4929-974E-EA4C5C151E6D}"/>
               </a:ext>
             </a:extLst>
           </p:cNvPr>
@@ -2167,7 +2167,7 @@
           <p:cNvPr id="5" name="">
             <a:extLst xmlns:a="http://schemas.openxmlformats.org/drawingml/2006/main">
               <a:ext uri="{FF2B5EF4-FFF2-40B4-BE49-F238E27FC236}">
-                <a16:creationId xmlns:a16="http://schemas.microsoft.com/office/drawing/2014/main" id="{EE0BFD26-0BC4-4221-A832-3F9A2CD0E779}"/>
+                <a16:creationId xmlns:a16="http://schemas.microsoft.com/office/drawing/2014/main" id="{3E2C32F3-E6EA-4DC0-A218-B89022CFB546}"/>
               </a:ext>
             </a:extLst>
           </p:cNvPr>
@@ -2202,7 +2202,7 @@
           <p:cNvPr id="6" name="">
             <a:extLst xmlns:a="http://schemas.openxmlformats.org/drawingml/2006/main">
               <a:ext uri="{FF2B5EF4-FFF2-40B4-BE49-F238E27FC236}">
-                <a16:creationId xmlns:a16="http://schemas.microsoft.com/office/drawing/2014/main" id="{9FAE88EF-21F4-4AEA-B535-A77EA11C9080}"/>
+                <a16:creationId xmlns:a16="http://schemas.microsoft.com/office/drawing/2014/main" id="{47763CD2-7B3A-48FA-8CB8-2A61FB794108}"/>
               </a:ext>
             </a:extLst>
           </p:cNvPr>
@@ -2252,7 +2252,7 @@
           <p:cNvPr id="7" name="">
             <a:extLst xmlns:a="http://schemas.openxmlformats.org/drawingml/2006/main">
               <a:ext uri="{FF2B5EF4-FFF2-40B4-BE49-F238E27FC236}">
-                <a16:creationId xmlns:a16="http://schemas.microsoft.com/office/drawing/2014/main" id="{850F1D0E-5EF3-4A6F-BB26-5BFBBEFF02E5}"/>
+                <a16:creationId xmlns:a16="http://schemas.microsoft.com/office/drawing/2014/main" id="{15D89B25-66E7-4FDC-B40D-F93EF8D1B364}"/>
               </a:ext>
             </a:extLst>
           </p:cNvPr>
@@ -2336,7 +2336,7 @@
           <p:cNvPr id="8" name="">
             <a:extLst xmlns:a="http://schemas.openxmlformats.org/drawingml/2006/main">
               <a:ext uri="{FF2B5EF4-FFF2-40B4-BE49-F238E27FC236}">
-                <a16:creationId xmlns:a16="http://schemas.microsoft.com/office/drawing/2014/main" id="{5AE9264D-0251-4854-95F8-3719C3A69595}"/>
+                <a16:creationId xmlns:a16="http://schemas.microsoft.com/office/drawing/2014/main" id="{C0C0171C-E8F7-49CB-8B8F-64970E333BD5}"/>
               </a:ext>
             </a:extLst>
           </p:cNvPr>
@@ -2371,7 +2371,7 @@
           <p:cNvPr id="9" name="">
             <a:extLst xmlns:a="http://schemas.openxmlformats.org/drawingml/2006/main">
               <a:ext uri="{FF2B5EF4-FFF2-40B4-BE49-F238E27FC236}">
-                <a16:creationId xmlns:a16="http://schemas.microsoft.com/office/drawing/2014/main" id="{17D487AB-B982-4ED6-BCBA-FD93E12D2BDB}"/>
+                <a16:creationId xmlns:a16="http://schemas.microsoft.com/office/drawing/2014/main" id="{9365ED8C-99B7-4BA0-A840-2D6602C6E510}"/>
               </a:ext>
             </a:extLst>
           </p:cNvPr>
@@ -2421,7 +2421,7 @@
           <p:cNvPr id="10" name="">
             <a:extLst xmlns:a="http://schemas.openxmlformats.org/drawingml/2006/main">
               <a:ext uri="{FF2B5EF4-FFF2-40B4-BE49-F238E27FC236}">
-                <a16:creationId xmlns:a16="http://schemas.microsoft.com/office/drawing/2014/main" id="{011C6766-4FD6-4161-A04B-F2C13932B1F3}"/>
+                <a16:creationId xmlns:a16="http://schemas.microsoft.com/office/drawing/2014/main" id="{6B6B25D6-F012-4DD8-B5EB-1EE162BB01AE}"/>
               </a:ext>
             </a:extLst>
           </p:cNvPr>
@@ -2505,7 +2505,7 @@
           <p:cNvPr id="11" name="">
             <a:extLst xmlns:a="http://schemas.openxmlformats.org/drawingml/2006/main">
               <a:ext uri="{FF2B5EF4-FFF2-40B4-BE49-F238E27FC236}">
-                <a16:creationId xmlns:a16="http://schemas.microsoft.com/office/drawing/2014/main" id="{95C299A2-1AD2-45DE-A5AD-DAB2BBD5581D}"/>
+                <a16:creationId xmlns:a16="http://schemas.microsoft.com/office/drawing/2014/main" id="{8F48B5D5-4D9B-49FC-AE4C-B56DFA75C83C}"/>
               </a:ext>
             </a:extLst>
           </p:cNvPr>
@@ -2540,7 +2540,7 @@
           <p:cNvPr id="12" name="">
             <a:extLst xmlns:a="http://schemas.openxmlformats.org/drawingml/2006/main">
               <a:ext uri="{FF2B5EF4-FFF2-40B4-BE49-F238E27FC236}">
-                <a16:creationId xmlns:a16="http://schemas.microsoft.com/office/drawing/2014/main" id="{B62FECFA-1191-476C-9EA8-89EDB13B8D92}"/>
+                <a16:creationId xmlns:a16="http://schemas.microsoft.com/office/drawing/2014/main" id="{9C19DF38-A647-4F35-9353-6C8D3969D3A6}"/>
               </a:ext>
             </a:extLst>
           </p:cNvPr>
@@ -2590,7 +2590,7 @@
           <p:cNvPr id="13" name="">
             <a:extLst xmlns:a="http://schemas.openxmlformats.org/drawingml/2006/main">
               <a:ext uri="{FF2B5EF4-FFF2-40B4-BE49-F238E27FC236}">
-                <a16:creationId xmlns:a16="http://schemas.microsoft.com/office/drawing/2014/main" id="{9B52A5A1-A569-4B25-A232-E74C46198B62}"/>
+                <a16:creationId xmlns:a16="http://schemas.microsoft.com/office/drawing/2014/main" id="{364599A4-E6D1-4ECD-86B6-194A49B2104F}"/>
               </a:ext>
             </a:extLst>
           </p:cNvPr>
@@ -2674,7 +2674,7 @@
           <p:cNvPr id="14" name="">
             <a:extLst xmlns:a="http://schemas.openxmlformats.org/drawingml/2006/main">
               <a:ext uri="{FF2B5EF4-FFF2-40B4-BE49-F238E27FC236}">
-                <a16:creationId xmlns:a16="http://schemas.microsoft.com/office/drawing/2014/main" id="{1652AA9F-F136-4C72-913F-C6FBDBC4817D}"/>
+                <a16:creationId xmlns:a16="http://schemas.microsoft.com/office/drawing/2014/main" id="{A0865C49-1C36-424B-934D-5E47434B88E0}"/>
               </a:ext>
             </a:extLst>
           </p:cNvPr>
@@ -2722,7 +2722,7 @@
     </p:spTree>
     <p:extLst>
       <p:ext uri="{BB962C8B-B14F-4D97-AF65-F5344CB8AC3E}">
-        <p14:creationId xmlns:p14="http://schemas.microsoft.com/office/powerpoint/2010/main" val="975738254"/>
+        <p14:creationId xmlns:p14="http://schemas.microsoft.com/office/powerpoint/2010/main" val="2022928499"/>
       </p:ext>
     </p:extLst>
   </p:cSld>
@@ -2753,7 +2753,7 @@
           <p:cNvPr id="25" name="">
             <a:extLst xmlns:a="http://schemas.openxmlformats.org/drawingml/2006/main">
               <a:ext uri="{FF2B5EF4-FFF2-40B4-BE49-F238E27FC236}">
-                <a16:creationId xmlns:a16="http://schemas.microsoft.com/office/drawing/2014/main" id="{E90BAAC3-D763-4750-B5D9-98BFA9A5710E}"/>
+                <a16:creationId xmlns:a16="http://schemas.microsoft.com/office/drawing/2014/main" id="{35E0E739-8A53-4642-9DD0-CED61364DEB6}"/>
               </a:ext>
             </a:extLst>
           </p:cNvPr>
@@ -2803,7 +2803,7 @@
           <p:cNvPr id="2" name="">
             <a:extLst xmlns:a="http://schemas.openxmlformats.org/drawingml/2006/main">
               <a:ext uri="{FF2B5EF4-FFF2-40B4-BE49-F238E27FC236}">
-                <a16:creationId xmlns:a16="http://schemas.microsoft.com/office/drawing/2014/main" id="{7C53138D-5961-4DE6-B00A-263D8F723DF7}"/>
+                <a16:creationId xmlns:a16="http://schemas.microsoft.com/office/drawing/2014/main" id="{105180A1-CA83-46B0-8F93-99B81F63E725}"/>
               </a:ext>
             </a:extLst>
           </p:cNvPr>
@@ -2853,7 +2853,7 @@
           <p:cNvPr id="3" name="">
             <a:extLst xmlns:a="http://schemas.openxmlformats.org/drawingml/2006/main">
               <a:ext uri="{FF2B5EF4-FFF2-40B4-BE49-F238E27FC236}">
-                <a16:creationId xmlns:a16="http://schemas.microsoft.com/office/drawing/2014/main" id="{8A5AA1E7-A6C5-46BD-B1C0-20C8A1C64A55}"/>
+                <a16:creationId xmlns:a16="http://schemas.microsoft.com/office/drawing/2014/main" id="{924A8525-6EC3-4577-B2CE-093B0842D6C9}"/>
               </a:ext>
             </a:extLst>
           </p:cNvPr>
@@ -2903,7 +2903,7 @@
           <p:cNvPr id="4" name="">
             <a:extLst xmlns:a="http://schemas.openxmlformats.org/drawingml/2006/main">
               <a:ext uri="{FF2B5EF4-FFF2-40B4-BE49-F238E27FC236}">
-                <a16:creationId xmlns:a16="http://schemas.microsoft.com/office/drawing/2014/main" id="{FF5AC5A0-C267-408B-8326-012D1687FA02}"/>
+                <a16:creationId xmlns:a16="http://schemas.microsoft.com/office/drawing/2014/main" id="{13D41B6B-13DB-47B4-B7E4-3498159E152E}"/>
               </a:ext>
             </a:extLst>
           </p:cNvPr>
@@ -2936,7 +2936,7 @@
           <p:cNvPr id="5" name="">
             <a:extLst xmlns:a="http://schemas.openxmlformats.org/drawingml/2006/main">
               <a:ext uri="{FF2B5EF4-FFF2-40B4-BE49-F238E27FC236}">
-                <a16:creationId xmlns:a16="http://schemas.microsoft.com/office/drawing/2014/main" id="{D713282E-AE2B-4AC2-92E6-467CABCDBB2E}"/>
+                <a16:creationId xmlns:a16="http://schemas.microsoft.com/office/drawing/2014/main" id="{4D49D588-0278-49EF-B37E-4A48EA6DD517}"/>
               </a:ext>
             </a:extLst>
           </p:cNvPr>
@@ -2971,7 +2971,7 @@
           <p:cNvPr id="6" name="">
             <a:extLst xmlns:a="http://schemas.openxmlformats.org/drawingml/2006/main">
               <a:ext uri="{FF2B5EF4-FFF2-40B4-BE49-F238E27FC236}">
-                <a16:creationId xmlns:a16="http://schemas.microsoft.com/office/drawing/2014/main" id="{FAA0DA3F-6A40-4EC3-8C7F-7D899D6DF104}"/>
+                <a16:creationId xmlns:a16="http://schemas.microsoft.com/office/drawing/2014/main" id="{936D5F97-075C-4CAD-9D0A-E47F89B87C01}"/>
               </a:ext>
             </a:extLst>
           </p:cNvPr>
@@ -3021,7 +3021,7 @@
           <p:cNvPr id="7" name="">
             <a:extLst xmlns:a="http://schemas.openxmlformats.org/drawingml/2006/main">
               <a:ext uri="{FF2B5EF4-FFF2-40B4-BE49-F238E27FC236}">
-                <a16:creationId xmlns:a16="http://schemas.microsoft.com/office/drawing/2014/main" id="{EFAB5BA1-D52F-439B-8780-71F50CCB28F3}"/>
+                <a16:creationId xmlns:a16="http://schemas.microsoft.com/office/drawing/2014/main" id="{D954AEF0-0536-496C-86F7-CB45C9B5A6C4}"/>
               </a:ext>
             </a:extLst>
           </p:cNvPr>
@@ -3071,7 +3071,7 @@
           <p:cNvPr id="8" name="">
             <a:extLst xmlns:a="http://schemas.openxmlformats.org/drawingml/2006/main">
               <a:ext uri="{FF2B5EF4-FFF2-40B4-BE49-F238E27FC236}">
-                <a16:creationId xmlns:a16="http://schemas.microsoft.com/office/drawing/2014/main" id="{8B911762-6450-477C-AEF0-97412A291CB0}"/>
+                <a16:creationId xmlns:a16="http://schemas.microsoft.com/office/drawing/2014/main" id="{E25779D3-D606-4CAA-83B9-2754556C6B47}"/>
               </a:ext>
             </a:extLst>
           </p:cNvPr>
@@ -3121,7 +3121,7 @@
           <p:cNvPr id="9" name="">
             <a:extLst xmlns:a="http://schemas.openxmlformats.org/drawingml/2006/main">
               <a:ext uri="{FF2B5EF4-FFF2-40B4-BE49-F238E27FC236}">
-                <a16:creationId xmlns:a16="http://schemas.microsoft.com/office/drawing/2014/main" id="{6BACF3CF-BAF4-4D80-889B-C42D37B84A79}"/>
+                <a16:creationId xmlns:a16="http://schemas.microsoft.com/office/drawing/2014/main" id="{770BF113-2A70-451A-9ED9-659A778402C6}"/>
               </a:ext>
             </a:extLst>
           </p:cNvPr>
@@ -3154,7 +3154,7 @@
           <p:cNvPr id="10" name="">
             <a:extLst xmlns:a="http://schemas.openxmlformats.org/drawingml/2006/main">
               <a:ext uri="{FF2B5EF4-FFF2-40B4-BE49-F238E27FC236}">
-                <a16:creationId xmlns:a16="http://schemas.microsoft.com/office/drawing/2014/main" id="{AF45E78C-713D-4F84-B596-08E4199F62C5}"/>
+                <a16:creationId xmlns:a16="http://schemas.microsoft.com/office/drawing/2014/main" id="{AF87BF9B-990F-451F-A92E-2537E0299495}"/>
               </a:ext>
             </a:extLst>
           </p:cNvPr>
@@ -3189,7 +3189,7 @@
           <p:cNvPr id="11" name="">
             <a:extLst xmlns:a="http://schemas.openxmlformats.org/drawingml/2006/main">
               <a:ext uri="{FF2B5EF4-FFF2-40B4-BE49-F238E27FC236}">
-                <a16:creationId xmlns:a16="http://schemas.microsoft.com/office/drawing/2014/main" id="{39846DB8-6101-40B7-B78C-CCDEA0370B8A}"/>
+                <a16:creationId xmlns:a16="http://schemas.microsoft.com/office/drawing/2014/main" id="{84571C7C-93FB-4CAB-929E-3C876A4A9D10}"/>
               </a:ext>
             </a:extLst>
           </p:cNvPr>
@@ -3239,7 +3239,7 @@
           <p:cNvPr id="12" name="">
             <a:extLst xmlns:a="http://schemas.openxmlformats.org/drawingml/2006/main">
               <a:ext uri="{FF2B5EF4-FFF2-40B4-BE49-F238E27FC236}">
-                <a16:creationId xmlns:a16="http://schemas.microsoft.com/office/drawing/2014/main" id="{0BAE6BB0-6853-4177-A8EB-6E64C68CC354}"/>
+                <a16:creationId xmlns:a16="http://schemas.microsoft.com/office/drawing/2014/main" id="{9375E447-D976-42E1-B209-AB48D8BC4018}"/>
               </a:ext>
             </a:extLst>
           </p:cNvPr>
@@ -3289,7 +3289,7 @@
           <p:cNvPr id="13" name="">
             <a:extLst xmlns:a="http://schemas.openxmlformats.org/drawingml/2006/main">
               <a:ext uri="{FF2B5EF4-FFF2-40B4-BE49-F238E27FC236}">
-                <a16:creationId xmlns:a16="http://schemas.microsoft.com/office/drawing/2014/main" id="{F6FE4031-4D1D-47C4-98D1-393437BB19C9}"/>
+                <a16:creationId xmlns:a16="http://schemas.microsoft.com/office/drawing/2014/main" id="{7503427A-2C9F-4E43-BCB0-B96F42B8D301}"/>
               </a:ext>
             </a:extLst>
           </p:cNvPr>
@@ -3339,7 +3339,7 @@
           <p:cNvPr id="14" name="">
             <a:extLst xmlns:a="http://schemas.openxmlformats.org/drawingml/2006/main">
               <a:ext uri="{FF2B5EF4-FFF2-40B4-BE49-F238E27FC236}">
-                <a16:creationId xmlns:a16="http://schemas.microsoft.com/office/drawing/2014/main" id="{6B5EB9E6-8E6F-4C86-BBCC-C848A0588369}"/>
+                <a16:creationId xmlns:a16="http://schemas.microsoft.com/office/drawing/2014/main" id="{7D1C125F-B6D1-4007-9639-7A041238FC2D}"/>
               </a:ext>
             </a:extLst>
           </p:cNvPr>
@@ -3372,7 +3372,7 @@
           <p:cNvPr id="15" name="">
             <a:extLst xmlns:a="http://schemas.openxmlformats.org/drawingml/2006/main">
               <a:ext uri="{FF2B5EF4-FFF2-40B4-BE49-F238E27FC236}">
-                <a16:creationId xmlns:a16="http://schemas.microsoft.com/office/drawing/2014/main" id="{4489919C-FC04-46A8-8E91-B6B8B6D2C90C}"/>
+                <a16:creationId xmlns:a16="http://schemas.microsoft.com/office/drawing/2014/main" id="{8974FF47-1761-4CD4-B30A-74929498C5A2}"/>
               </a:ext>
             </a:extLst>
           </p:cNvPr>
@@ -3407,7 +3407,7 @@
           <p:cNvPr id="16" name="">
             <a:extLst xmlns:a="http://schemas.openxmlformats.org/drawingml/2006/main">
               <a:ext uri="{FF2B5EF4-FFF2-40B4-BE49-F238E27FC236}">
-                <a16:creationId xmlns:a16="http://schemas.microsoft.com/office/drawing/2014/main" id="{66B09CD1-1C06-46FC-8908-8D8397B55885}"/>
+                <a16:creationId xmlns:a16="http://schemas.microsoft.com/office/drawing/2014/main" id="{81CD48FA-FA70-4DEB-9111-E9308D206157}"/>
               </a:ext>
             </a:extLst>
           </p:cNvPr>
@@ -3457,7 +3457,7 @@
           <p:cNvPr id="17" name="">
             <a:extLst xmlns:a="http://schemas.openxmlformats.org/drawingml/2006/main">
               <a:ext uri="{FF2B5EF4-FFF2-40B4-BE49-F238E27FC236}">
-                <a16:creationId xmlns:a16="http://schemas.microsoft.com/office/drawing/2014/main" id="{6B125F85-30C7-4FAC-BC36-1A6E50CCB11C}"/>
+                <a16:creationId xmlns:a16="http://schemas.microsoft.com/office/drawing/2014/main" id="{97AF7FFB-739C-488A-A321-7FF4B1C921E7}"/>
               </a:ext>
             </a:extLst>
           </p:cNvPr>
@@ -3507,7 +3507,7 @@
           <p:cNvPr id="18" name="">
             <a:extLst xmlns:a="http://schemas.openxmlformats.org/drawingml/2006/main">
               <a:ext uri="{FF2B5EF4-FFF2-40B4-BE49-F238E27FC236}">
-                <a16:creationId xmlns:a16="http://schemas.microsoft.com/office/drawing/2014/main" id="{B45F0DB7-1006-437E-84C5-E144EBECAE58}"/>
+                <a16:creationId xmlns:a16="http://schemas.microsoft.com/office/drawing/2014/main" id="{76E0AD0D-ABE7-4AB4-8E92-FCB7D3EBB215}"/>
               </a:ext>
             </a:extLst>
           </p:cNvPr>
@@ -3557,7 +3557,7 @@
           <p:cNvPr id="19" name="">
             <a:extLst xmlns:a="http://schemas.openxmlformats.org/drawingml/2006/main">
               <a:ext uri="{FF2B5EF4-FFF2-40B4-BE49-F238E27FC236}">
-                <a16:creationId xmlns:a16="http://schemas.microsoft.com/office/drawing/2014/main" id="{A8AF01CE-461C-430E-AD3F-767CF50E08CB}"/>
+                <a16:creationId xmlns:a16="http://schemas.microsoft.com/office/drawing/2014/main" id="{EA7744AF-D6FB-4D52-B3C7-0915E99FBC5B}"/>
               </a:ext>
             </a:extLst>
           </p:cNvPr>
@@ -3592,7 +3592,7 @@
           <p:cNvPr id="20" name="">
             <a:extLst xmlns:a="http://schemas.openxmlformats.org/drawingml/2006/main">
               <a:ext uri="{FF2B5EF4-FFF2-40B4-BE49-F238E27FC236}">
-                <a16:creationId xmlns:a16="http://schemas.microsoft.com/office/drawing/2014/main" id="{785D2317-7EF3-4401-A704-495AEC89A5C2}"/>
+                <a16:creationId xmlns:a16="http://schemas.microsoft.com/office/drawing/2014/main" id="{D7D7BFA0-E1E2-45DA-8579-CBADC6E80FC3}"/>
               </a:ext>
             </a:extLst>
           </p:cNvPr>
@@ -3642,7 +3642,7 @@
           <p:cNvPr id="21" name="">
             <a:extLst xmlns:a="http://schemas.openxmlformats.org/drawingml/2006/main">
               <a:ext uri="{FF2B5EF4-FFF2-40B4-BE49-F238E27FC236}">
-                <a16:creationId xmlns:a16="http://schemas.microsoft.com/office/drawing/2014/main" id="{AFB2C4E4-754B-4FB0-9FF7-1789F01B8E97}"/>
+                <a16:creationId xmlns:a16="http://schemas.microsoft.com/office/drawing/2014/main" id="{D9466179-1522-4B46-886D-E8ADEC205377}"/>
               </a:ext>
             </a:extLst>
           </p:cNvPr>
@@ -3692,7 +3692,7 @@
           <p:cNvPr id="22" name="">
             <a:extLst xmlns:a="http://schemas.openxmlformats.org/drawingml/2006/main">
               <a:ext uri="{FF2B5EF4-FFF2-40B4-BE49-F238E27FC236}">
-                <a16:creationId xmlns:a16="http://schemas.microsoft.com/office/drawing/2014/main" id="{DAC71F89-23C1-4D9B-B12B-0C71D01407B0}"/>
+                <a16:creationId xmlns:a16="http://schemas.microsoft.com/office/drawing/2014/main" id="{8FAD2792-C5E7-4630-8EBE-6DCF8423986E}"/>
               </a:ext>
             </a:extLst>
           </p:cNvPr>
@@ -3742,7 +3742,7 @@
           <p:cNvPr id="23" name="">
             <a:extLst xmlns:a="http://schemas.openxmlformats.org/drawingml/2006/main">
               <a:ext uri="{FF2B5EF4-FFF2-40B4-BE49-F238E27FC236}">
-                <a16:creationId xmlns:a16="http://schemas.microsoft.com/office/drawing/2014/main" id="{34DA002B-7902-485C-9C1E-71B0B199B36E}"/>
+                <a16:creationId xmlns:a16="http://schemas.microsoft.com/office/drawing/2014/main" id="{F5ECECDD-F5E8-4A80-A485-9F8F6B9259D4}"/>
               </a:ext>
             </a:extLst>
           </p:cNvPr>
@@ -3782,7 +3782,7 @@
                   <a:srgbClr val="63756E"/>
                 </a:solidFill>
               </a:rPr>
-              <a:t>기본 분석은 브라우저에서 실행되고, 사용자가 원할 때만 민감정보를 제거한 요약값으로 AI 설명을 요청합니다.</a:t>
+              <a:t>기본 분석은 브라우저에서 실행되고, 사용자가 분석을 누를 때만 전체 후보의 최소 요약값을 AI에 전달합니다.</a:t>
             </a:r>
           </a:p>
         </p:txBody>
@@ -3792,7 +3792,7 @@
           <p:cNvPr id="24" name="">
             <a:extLst xmlns:a="http://schemas.openxmlformats.org/drawingml/2006/main">
               <a:ext uri="{FF2B5EF4-FFF2-40B4-BE49-F238E27FC236}">
-                <a16:creationId xmlns:a16="http://schemas.microsoft.com/office/drawing/2014/main" id="{34BA2151-54B4-48E6-A45A-23ED58C79EE2}"/>
+                <a16:creationId xmlns:a16="http://schemas.microsoft.com/office/drawing/2014/main" id="{C1C53D69-EEE2-485B-AAE6-14C1A2924A07}"/>
               </a:ext>
             </a:extLst>
           </p:cNvPr>
@@ -3840,7 +3840,7 @@
     </p:spTree>
     <p:extLst>
       <p:ext uri="{BB962C8B-B14F-4D97-AF65-F5344CB8AC3E}">
-        <p14:creationId xmlns:p14="http://schemas.microsoft.com/office/powerpoint/2010/main" val="1062922992"/>
+        <p14:creationId xmlns:p14="http://schemas.microsoft.com/office/powerpoint/2010/main" val="1037964823"/>
       </p:ext>
     </p:extLst>
   </p:cSld>
@@ -3871,7 +3871,7 @@
           <p:cNvPr id="13" name="">
             <a:extLst xmlns:a="http://schemas.openxmlformats.org/drawingml/2006/main">
               <a:ext uri="{FF2B5EF4-FFF2-40B4-BE49-F238E27FC236}">
-                <a16:creationId xmlns:a16="http://schemas.microsoft.com/office/drawing/2014/main" id="{186A4C11-4FFC-45A8-AC3D-74CE8EAE4149}"/>
+                <a16:creationId xmlns:a16="http://schemas.microsoft.com/office/drawing/2014/main" id="{89F19913-EB1C-4121-9D46-9D78F01B43BA}"/>
               </a:ext>
             </a:extLst>
           </p:cNvPr>
@@ -3921,7 +3921,7 @@
           <p:cNvPr id="2" name="">
             <a:extLst xmlns:a="http://schemas.openxmlformats.org/drawingml/2006/main">
               <a:ext uri="{FF2B5EF4-FFF2-40B4-BE49-F238E27FC236}">
-                <a16:creationId xmlns:a16="http://schemas.microsoft.com/office/drawing/2014/main" id="{3582125E-8FDF-46F3-86DE-FEDDC94962A1}"/>
+                <a16:creationId xmlns:a16="http://schemas.microsoft.com/office/drawing/2014/main" id="{CAA3A73C-B9A5-427B-82B5-637D8D13E101}"/>
               </a:ext>
             </a:extLst>
           </p:cNvPr>
@@ -3971,7 +3971,7 @@
           <p:cNvPr id="3" name="">
             <a:extLst xmlns:a="http://schemas.openxmlformats.org/drawingml/2006/main">
               <a:ext uri="{FF2B5EF4-FFF2-40B4-BE49-F238E27FC236}">
-                <a16:creationId xmlns:a16="http://schemas.microsoft.com/office/drawing/2014/main" id="{F68150FC-BDAB-47AF-BFC3-64F4CBBF2D4F}"/>
+                <a16:creationId xmlns:a16="http://schemas.microsoft.com/office/drawing/2014/main" id="{50600BAE-2A2F-4D21-BBD5-1B48482E84C3}"/>
               </a:ext>
             </a:extLst>
           </p:cNvPr>
@@ -4021,7 +4021,7 @@
           <p:cNvPr id="4" name="">
             <a:extLst xmlns:a="http://schemas.openxmlformats.org/drawingml/2006/main">
               <a:ext uri="{FF2B5EF4-FFF2-40B4-BE49-F238E27FC236}">
-                <a16:creationId xmlns:a16="http://schemas.microsoft.com/office/drawing/2014/main" id="{D3BFC130-FBA8-41A9-8768-546589759916}"/>
+                <a16:creationId xmlns:a16="http://schemas.microsoft.com/office/drawing/2014/main" id="{7C72893F-C8D6-41B2-93C7-42216F012E8E}"/>
               </a:ext>
             </a:extLst>
           </p:cNvPr>
@@ -4071,7 +4071,7 @@
           <p:cNvPr id="5" name="">
             <a:extLst xmlns:a="http://schemas.openxmlformats.org/drawingml/2006/main">
               <a:ext uri="{FF2B5EF4-FFF2-40B4-BE49-F238E27FC236}">
-                <a16:creationId xmlns:a16="http://schemas.microsoft.com/office/drawing/2014/main" id="{724C8D8B-9C63-4BB4-AE82-28B1B54B4F0D}"/>
+                <a16:creationId xmlns:a16="http://schemas.microsoft.com/office/drawing/2014/main" id="{0FDCD989-62AF-4B20-8A4C-276DB6D584B4}"/>
               </a:ext>
             </a:extLst>
           </p:cNvPr>
@@ -4121,7 +4121,7 @@
           <p:cNvPr id="6" name="">
             <a:extLst xmlns:a="http://schemas.openxmlformats.org/drawingml/2006/main">
               <a:ext uri="{FF2B5EF4-FFF2-40B4-BE49-F238E27FC236}">
-                <a16:creationId xmlns:a16="http://schemas.microsoft.com/office/drawing/2014/main" id="{86A4DEA5-E58C-4A9D-B49B-59C5009478AD}"/>
+                <a16:creationId xmlns:a16="http://schemas.microsoft.com/office/drawing/2014/main" id="{CB205F65-7861-404A-86CC-5200B16D9D67}"/>
               </a:ext>
             </a:extLst>
           </p:cNvPr>
@@ -4188,7 +4188,7 @@
           <p:cNvPr id="7" name="">
             <a:extLst xmlns:a="http://schemas.openxmlformats.org/drawingml/2006/main">
               <a:ext uri="{FF2B5EF4-FFF2-40B4-BE49-F238E27FC236}">
-                <a16:creationId xmlns:a16="http://schemas.microsoft.com/office/drawing/2014/main" id="{27344995-9F2F-42EB-8F3C-68841A7C3E05}"/>
+                <a16:creationId xmlns:a16="http://schemas.microsoft.com/office/drawing/2014/main" id="{6F2BD744-29A2-4958-977D-A7B4B7621807}"/>
               </a:ext>
             </a:extLst>
           </p:cNvPr>
@@ -4223,7 +4223,7 @@
           <p:cNvPr id="8" name="">
             <a:extLst xmlns:a="http://schemas.openxmlformats.org/drawingml/2006/main">
               <a:ext uri="{FF2B5EF4-FFF2-40B4-BE49-F238E27FC236}">
-                <a16:creationId xmlns:a16="http://schemas.microsoft.com/office/drawing/2014/main" id="{9A92A5D1-338A-45A0-BE73-4638ADB29F17}"/>
+                <a16:creationId xmlns:a16="http://schemas.microsoft.com/office/drawing/2014/main" id="{0F940265-D472-4141-981D-381F4ECF42B2}"/>
               </a:ext>
             </a:extLst>
           </p:cNvPr>
@@ -4273,7 +4273,7 @@
           <p:cNvPr id="9" name="">
             <a:extLst xmlns:a="http://schemas.openxmlformats.org/drawingml/2006/main">
               <a:ext uri="{FF2B5EF4-FFF2-40B4-BE49-F238E27FC236}">
-                <a16:creationId xmlns:a16="http://schemas.microsoft.com/office/drawing/2014/main" id="{5F3AF9F3-6172-45E1-8333-40AF609B15E2}"/>
+                <a16:creationId xmlns:a16="http://schemas.microsoft.com/office/drawing/2014/main" id="{F112F549-A295-4328-BD96-64E9AEDF249A}"/>
               </a:ext>
             </a:extLst>
           </p:cNvPr>
@@ -4323,7 +4323,7 @@
           <p:cNvPr id="10" name="">
             <a:extLst xmlns:a="http://schemas.openxmlformats.org/drawingml/2006/main">
               <a:ext uri="{FF2B5EF4-FFF2-40B4-BE49-F238E27FC236}">
-                <a16:creationId xmlns:a16="http://schemas.microsoft.com/office/drawing/2014/main" id="{2F348BE4-3B87-4A8E-8D02-765085B44BE5}"/>
+                <a16:creationId xmlns:a16="http://schemas.microsoft.com/office/drawing/2014/main" id="{0A10C2B8-4AE0-4403-9B72-61EEFAF01625}"/>
               </a:ext>
             </a:extLst>
           </p:cNvPr>
@@ -4362,7 +4362,7 @@
           <p:nvPr/>
         </p:nvPicPr>
         <p:blipFill>
-          <a:blip xmlns:r="http://schemas.openxmlformats.org/officeDocument/2006/relationships" xmlns:a="http://schemas.openxmlformats.org/drawingml/2006/main" r:embed="R6502d5154b6548b6"/>
+          <a:blip xmlns:r="http://schemas.openxmlformats.org/officeDocument/2006/relationships" xmlns:a="http://schemas.openxmlformats.org/drawingml/2006/main" r:embed="R9757a93e81e64c38"/>
           <a:stretch xmlns:a="http://schemas.openxmlformats.org/drawingml/2006/main"/>
         </p:blipFill>
         <p:spPr>
@@ -4382,7 +4382,7 @@
           <p:cNvPr id="12" name="">
             <a:extLst xmlns:a="http://schemas.openxmlformats.org/drawingml/2006/main">
               <a:ext uri="{FF2B5EF4-FFF2-40B4-BE49-F238E27FC236}">
-                <a16:creationId xmlns:a16="http://schemas.microsoft.com/office/drawing/2014/main" id="{5EBF847A-2E44-4DA2-962C-8832E0D506E9}"/>
+                <a16:creationId xmlns:a16="http://schemas.microsoft.com/office/drawing/2014/main" id="{60A14D22-3DA4-46B1-861D-29AC399EEA19}"/>
               </a:ext>
             </a:extLst>
           </p:cNvPr>
@@ -4430,7 +4430,7 @@
     </p:spTree>
     <p:extLst>
       <p:ext uri="{BB962C8B-B14F-4D97-AF65-F5344CB8AC3E}">
-        <p14:creationId xmlns:p14="http://schemas.microsoft.com/office/powerpoint/2010/main" val="568561480"/>
+        <p14:creationId xmlns:p14="http://schemas.microsoft.com/office/powerpoint/2010/main" val="591791563"/>
       </p:ext>
     </p:extLst>
   </p:cSld>
@@ -4461,7 +4461,7 @@
           <p:cNvPr id="17" name="">
             <a:extLst xmlns:a="http://schemas.openxmlformats.org/drawingml/2006/main">
               <a:ext uri="{FF2B5EF4-FFF2-40B4-BE49-F238E27FC236}">
-                <a16:creationId xmlns:a16="http://schemas.microsoft.com/office/drawing/2014/main" id="{013CE9FF-217B-4ADB-B2AF-5A8D9F3A1F46}"/>
+                <a16:creationId xmlns:a16="http://schemas.microsoft.com/office/drawing/2014/main" id="{7F67489E-E129-4B08-99DF-0B6397B191A9}"/>
               </a:ext>
             </a:extLst>
           </p:cNvPr>
@@ -4511,7 +4511,7 @@
           <p:cNvPr id="2" name="">
             <a:extLst xmlns:a="http://schemas.openxmlformats.org/drawingml/2006/main">
               <a:ext uri="{FF2B5EF4-FFF2-40B4-BE49-F238E27FC236}">
-                <a16:creationId xmlns:a16="http://schemas.microsoft.com/office/drawing/2014/main" id="{FCA7A1C3-029D-4356-BB67-2535A3F7814F}"/>
+                <a16:creationId xmlns:a16="http://schemas.microsoft.com/office/drawing/2014/main" id="{2046B3A3-F8AF-47E1-858A-A860CE33F806}"/>
               </a:ext>
             </a:extLst>
           </p:cNvPr>
@@ -4561,7 +4561,7 @@
           <p:cNvPr id="3" name="">
             <a:extLst xmlns:a="http://schemas.openxmlformats.org/drawingml/2006/main">
               <a:ext uri="{FF2B5EF4-FFF2-40B4-BE49-F238E27FC236}">
-                <a16:creationId xmlns:a16="http://schemas.microsoft.com/office/drawing/2014/main" id="{73970624-7A3E-4792-9677-5ABC6FDC879E}"/>
+                <a16:creationId xmlns:a16="http://schemas.microsoft.com/office/drawing/2014/main" id="{9D0E9E45-91E9-4146-8F66-A089C8BE9613}"/>
               </a:ext>
             </a:extLst>
           </p:cNvPr>
@@ -4611,7 +4611,7 @@
           <p:cNvPr id="4" name="">
             <a:extLst xmlns:a="http://schemas.openxmlformats.org/drawingml/2006/main">
               <a:ext uri="{FF2B5EF4-FFF2-40B4-BE49-F238E27FC236}">
-                <a16:creationId xmlns:a16="http://schemas.microsoft.com/office/drawing/2014/main" id="{D3CFBED4-0BFB-4C7A-916C-71F34BE96740}"/>
+                <a16:creationId xmlns:a16="http://schemas.microsoft.com/office/drawing/2014/main" id="{706E6E9D-46E6-453C-A54D-E1558C5DC6B4}"/>
               </a:ext>
             </a:extLst>
           </p:cNvPr>
@@ -4646,7 +4646,7 @@
           <p:cNvPr id="5" name="">
             <a:extLst xmlns:a="http://schemas.openxmlformats.org/drawingml/2006/main">
               <a:ext uri="{FF2B5EF4-FFF2-40B4-BE49-F238E27FC236}">
-                <a16:creationId xmlns:a16="http://schemas.microsoft.com/office/drawing/2014/main" id="{11079ED2-CF83-45AA-94B5-88DB968F7A39}"/>
+                <a16:creationId xmlns:a16="http://schemas.microsoft.com/office/drawing/2014/main" id="{7B3FE6EA-FC43-4804-8C47-323E9F40997E}"/>
               </a:ext>
             </a:extLst>
           </p:cNvPr>
@@ -4696,7 +4696,7 @@
           <p:cNvPr id="6" name="">
             <a:extLst xmlns:a="http://schemas.openxmlformats.org/drawingml/2006/main">
               <a:ext uri="{FF2B5EF4-FFF2-40B4-BE49-F238E27FC236}">
-                <a16:creationId xmlns:a16="http://schemas.microsoft.com/office/drawing/2014/main" id="{76579272-838A-403A-92B0-948FA2830421}"/>
+                <a16:creationId xmlns:a16="http://schemas.microsoft.com/office/drawing/2014/main" id="{688AE15C-4D87-47AA-B644-E7C87C715EB0}"/>
               </a:ext>
             </a:extLst>
           </p:cNvPr>
@@ -4780,7 +4780,7 @@
           <p:cNvPr id="7" name="">
             <a:extLst xmlns:a="http://schemas.openxmlformats.org/drawingml/2006/main">
               <a:ext uri="{FF2B5EF4-FFF2-40B4-BE49-F238E27FC236}">
-                <a16:creationId xmlns:a16="http://schemas.microsoft.com/office/drawing/2014/main" id="{278D2DA1-9D13-472C-BBC0-6C6D33C1859A}"/>
+                <a16:creationId xmlns:a16="http://schemas.microsoft.com/office/drawing/2014/main" id="{07F9C61E-FB86-4FA7-9AF6-5338BFD88CC5}"/>
               </a:ext>
             </a:extLst>
           </p:cNvPr>
@@ -4815,7 +4815,7 @@
           <p:cNvPr id="8" name="">
             <a:extLst xmlns:a="http://schemas.openxmlformats.org/drawingml/2006/main">
               <a:ext uri="{FF2B5EF4-FFF2-40B4-BE49-F238E27FC236}">
-                <a16:creationId xmlns:a16="http://schemas.microsoft.com/office/drawing/2014/main" id="{E203D2F7-2F77-4BBD-99AA-BD002AB2269A}"/>
+                <a16:creationId xmlns:a16="http://schemas.microsoft.com/office/drawing/2014/main" id="{5265B832-85FD-45B5-A32F-364CB0A72DCC}"/>
               </a:ext>
             </a:extLst>
           </p:cNvPr>
@@ -4865,7 +4865,7 @@
           <p:cNvPr id="9" name="">
             <a:extLst xmlns:a="http://schemas.openxmlformats.org/drawingml/2006/main">
               <a:ext uri="{FF2B5EF4-FFF2-40B4-BE49-F238E27FC236}">
-                <a16:creationId xmlns:a16="http://schemas.microsoft.com/office/drawing/2014/main" id="{2AFAC294-1120-4358-8725-707120589C06}"/>
+                <a16:creationId xmlns:a16="http://schemas.microsoft.com/office/drawing/2014/main" id="{B4488DA2-A6C4-4C2D-9014-784C379A3CAF}"/>
               </a:ext>
             </a:extLst>
           </p:cNvPr>
@@ -4949,7 +4949,7 @@
           <p:cNvPr id="10" name="">
             <a:extLst xmlns:a="http://schemas.openxmlformats.org/drawingml/2006/main">
               <a:ext uri="{FF2B5EF4-FFF2-40B4-BE49-F238E27FC236}">
-                <a16:creationId xmlns:a16="http://schemas.microsoft.com/office/drawing/2014/main" id="{92168CA8-69EA-4890-9020-4D5DFDCE05FD}"/>
+                <a16:creationId xmlns:a16="http://schemas.microsoft.com/office/drawing/2014/main" id="{C1688C4B-3F34-4179-8838-22182DD10D4C}"/>
               </a:ext>
             </a:extLst>
           </p:cNvPr>
@@ -4984,7 +4984,7 @@
           <p:cNvPr id="11" name="">
             <a:extLst xmlns:a="http://schemas.openxmlformats.org/drawingml/2006/main">
               <a:ext uri="{FF2B5EF4-FFF2-40B4-BE49-F238E27FC236}">
-                <a16:creationId xmlns:a16="http://schemas.microsoft.com/office/drawing/2014/main" id="{49E7CFE4-4C8F-48EC-875B-509C2BF827D1}"/>
+                <a16:creationId xmlns:a16="http://schemas.microsoft.com/office/drawing/2014/main" id="{755125CC-D9C2-467F-8D77-9CADAA4D662E}"/>
               </a:ext>
             </a:extLst>
           </p:cNvPr>
@@ -5024,7 +5024,7 @@
                   <a:srgbClr val="FFFFFF"/>
                 </a:solidFill>
               </a:rPr>
-              <a:t>AI 설명</a:t>
+              <a:t>후보별 결과</a:t>
             </a:r>
           </a:p>
         </p:txBody>
@@ -5034,7 +5034,7 @@
           <p:cNvPr id="12" name="">
             <a:extLst xmlns:a="http://schemas.openxmlformats.org/drawingml/2006/main">
               <a:ext uri="{FF2B5EF4-FFF2-40B4-BE49-F238E27FC236}">
-                <a16:creationId xmlns:a16="http://schemas.microsoft.com/office/drawing/2014/main" id="{F510096E-210C-447B-B315-4A22D6665153}"/>
+                <a16:creationId xmlns:a16="http://schemas.microsoft.com/office/drawing/2014/main" id="{D38F5E87-6840-48C0-A79C-2A9F6AE0922D}"/>
               </a:ext>
             </a:extLst>
           </p:cNvPr>
@@ -5118,7 +5118,7 @@
           <p:cNvPr id="13" name="">
             <a:extLst xmlns:a="http://schemas.openxmlformats.org/drawingml/2006/main">
               <a:ext uri="{FF2B5EF4-FFF2-40B4-BE49-F238E27FC236}">
-                <a16:creationId xmlns:a16="http://schemas.microsoft.com/office/drawing/2014/main" id="{28F645F0-C956-451A-9AE6-8A1885D8AFBE}"/>
+                <a16:creationId xmlns:a16="http://schemas.microsoft.com/office/drawing/2014/main" id="{3C321DBB-F61B-49D5-A77F-662621D9ADAA}"/>
               </a:ext>
             </a:extLst>
           </p:cNvPr>
@@ -5168,7 +5168,7 @@
           <p:cNvPr id="14" name="">
             <a:extLst xmlns:a="http://schemas.openxmlformats.org/drawingml/2006/main">
               <a:ext uri="{FF2B5EF4-FFF2-40B4-BE49-F238E27FC236}">
-                <a16:creationId xmlns:a16="http://schemas.microsoft.com/office/drawing/2014/main" id="{BE643843-4A20-4830-A287-F2C7C1B078EB}"/>
+                <a16:creationId xmlns:a16="http://schemas.microsoft.com/office/drawing/2014/main" id="{4DEF63C1-A79B-4E4D-BDCD-557B79BDAF43}"/>
               </a:ext>
             </a:extLst>
           </p:cNvPr>
@@ -5208,7 +5208,7 @@
                   <a:srgbClr val="118060"/>
                 </a:solidFill>
               </a:rPr>
-              <a:t>AI 분석 하루 5회 · 사용량 표시</a:t>
+              <a:t>AI 일괄 분석 하루 7회 · 사용량 표시</a:t>
             </a:r>
           </a:p>
         </p:txBody>
@@ -5218,7 +5218,7 @@
           <p:cNvPr id="15" name="">
             <a:extLst xmlns:a="http://schemas.openxmlformats.org/drawingml/2006/main">
               <a:ext uri="{FF2B5EF4-FFF2-40B4-BE49-F238E27FC236}">
-                <a16:creationId xmlns:a16="http://schemas.microsoft.com/office/drawing/2014/main" id="{60822472-7610-49CE-BB67-19C1B4B65A24}"/>
+                <a16:creationId xmlns:a16="http://schemas.microsoft.com/office/drawing/2014/main" id="{B4EF68C9-B267-403E-8EA2-CEED481E445F}"/>
               </a:ext>
             </a:extLst>
           </p:cNvPr>
@@ -5268,7 +5268,7 @@
           <p:cNvPr id="16" name="">
             <a:extLst xmlns:a="http://schemas.openxmlformats.org/drawingml/2006/main">
               <a:ext uri="{FF2B5EF4-FFF2-40B4-BE49-F238E27FC236}">
-                <a16:creationId xmlns:a16="http://schemas.microsoft.com/office/drawing/2014/main" id="{1205F78C-B61C-4B07-A05D-87161F8C3BBC}"/>
+                <a16:creationId xmlns:a16="http://schemas.microsoft.com/office/drawing/2014/main" id="{C526217C-013C-4180-87E7-830FD094FD78}"/>
               </a:ext>
             </a:extLst>
           </p:cNvPr>
@@ -5316,7 +5316,7 @@
     </p:spTree>
     <p:extLst>
       <p:ext uri="{BB962C8B-B14F-4D97-AF65-F5344CB8AC3E}">
-        <p14:creationId xmlns:p14="http://schemas.microsoft.com/office/powerpoint/2010/main" val="2064082378"/>
+        <p14:creationId xmlns:p14="http://schemas.microsoft.com/office/powerpoint/2010/main" val="1732974834"/>
       </p:ext>
     </p:extLst>
   </p:cSld>
@@ -5347,7 +5347,7 @@
           <p:cNvPr id="13" name="">
             <a:extLst xmlns:a="http://schemas.openxmlformats.org/drawingml/2006/main">
               <a:ext uri="{FF2B5EF4-FFF2-40B4-BE49-F238E27FC236}">
-                <a16:creationId xmlns:a16="http://schemas.microsoft.com/office/drawing/2014/main" id="{1E0175E7-7950-4161-99F2-0DCB46957773}"/>
+                <a16:creationId xmlns:a16="http://schemas.microsoft.com/office/drawing/2014/main" id="{C0FBF48C-D986-4A56-A13E-B10FADD0E817}"/>
               </a:ext>
             </a:extLst>
           </p:cNvPr>
@@ -5397,7 +5397,7 @@
           <p:cNvPr id="2" name="">
             <a:extLst xmlns:a="http://schemas.openxmlformats.org/drawingml/2006/main">
               <a:ext uri="{FF2B5EF4-FFF2-40B4-BE49-F238E27FC236}">
-                <a16:creationId xmlns:a16="http://schemas.microsoft.com/office/drawing/2014/main" id="{060A858D-2712-444B-A408-6C84F56A9C49}"/>
+                <a16:creationId xmlns:a16="http://schemas.microsoft.com/office/drawing/2014/main" id="{44F424E7-6DED-43A2-8BE6-4F56457BC8BD}"/>
               </a:ext>
             </a:extLst>
           </p:cNvPr>
@@ -5447,7 +5447,7 @@
           <p:cNvPr id="3" name="">
             <a:extLst xmlns:a="http://schemas.openxmlformats.org/drawingml/2006/main">
               <a:ext uri="{FF2B5EF4-FFF2-40B4-BE49-F238E27FC236}">
-                <a16:creationId xmlns:a16="http://schemas.microsoft.com/office/drawing/2014/main" id="{A0E01F9D-A344-41CB-A5A6-05BF4E7FD35D}"/>
+                <a16:creationId xmlns:a16="http://schemas.microsoft.com/office/drawing/2014/main" id="{2920036F-75DE-4586-B209-79390F1FCE2B}"/>
               </a:ext>
             </a:extLst>
           </p:cNvPr>
@@ -5497,7 +5497,7 @@
           <p:cNvPr id="4" name="">
             <a:extLst xmlns:a="http://schemas.openxmlformats.org/drawingml/2006/main">
               <a:ext uri="{FF2B5EF4-FFF2-40B4-BE49-F238E27FC236}">
-                <a16:creationId xmlns:a16="http://schemas.microsoft.com/office/drawing/2014/main" id="{72798779-CCB8-4162-A0A4-CB8A9B0854B3}"/>
+                <a16:creationId xmlns:a16="http://schemas.microsoft.com/office/drawing/2014/main" id="{D82C53DC-5123-422C-966C-F017307A8C29}"/>
               </a:ext>
             </a:extLst>
           </p:cNvPr>
@@ -5532,7 +5532,7 @@
           <p:cNvPr id="5" name="">
             <a:extLst xmlns:a="http://schemas.openxmlformats.org/drawingml/2006/main">
               <a:ext uri="{FF2B5EF4-FFF2-40B4-BE49-F238E27FC236}">
-                <a16:creationId xmlns:a16="http://schemas.microsoft.com/office/drawing/2014/main" id="{2E222944-6F17-45A2-A948-855491E1399A}"/>
+                <a16:creationId xmlns:a16="http://schemas.microsoft.com/office/drawing/2014/main" id="{5492C05F-7ADE-49E8-8C48-9589AC4282E3}"/>
               </a:ext>
             </a:extLst>
           </p:cNvPr>
@@ -5572,7 +5572,7 @@
                   <a:srgbClr val="FFD23F"/>
                 </a:solidFill>
               </a:rPr>
-              <a:t>AI 설명 예시</a:t>
+              <a:t>AI 분석 예시</a:t>
             </a:r>
           </a:p>
         </p:txBody>
@@ -5582,7 +5582,7 @@
           <p:cNvPr id="6" name="">
             <a:extLst xmlns:a="http://schemas.openxmlformats.org/drawingml/2006/main">
               <a:ext uri="{FF2B5EF4-FFF2-40B4-BE49-F238E27FC236}">
-                <a16:creationId xmlns:a16="http://schemas.microsoft.com/office/drawing/2014/main" id="{6AC3DC72-662E-42DD-B2D3-5F12678E83E3}"/>
+                <a16:creationId xmlns:a16="http://schemas.microsoft.com/office/drawing/2014/main" id="{ED3FBE4E-74D1-4033-8FF4-3F7C758668ED}"/>
               </a:ext>
             </a:extLst>
           </p:cNvPr>
@@ -5683,7 +5683,7 @@
           <p:cNvPr id="7" name="">
             <a:extLst xmlns:a="http://schemas.openxmlformats.org/drawingml/2006/main">
               <a:ext uri="{FF2B5EF4-FFF2-40B4-BE49-F238E27FC236}">
-                <a16:creationId xmlns:a16="http://schemas.microsoft.com/office/drawing/2014/main" id="{048622D7-DF18-4073-9F5B-4C72925C315C}"/>
+                <a16:creationId xmlns:a16="http://schemas.microsoft.com/office/drawing/2014/main" id="{194F03AC-19C0-4E38-9575-F0183955ED03}"/>
               </a:ext>
             </a:extLst>
           </p:cNvPr>
@@ -5733,7 +5733,7 @@
           <p:cNvPr id="8" name="">
             <a:extLst xmlns:a="http://schemas.openxmlformats.org/drawingml/2006/main">
               <a:ext uri="{FF2B5EF4-FFF2-40B4-BE49-F238E27FC236}">
-                <a16:creationId xmlns:a16="http://schemas.microsoft.com/office/drawing/2014/main" id="{77555647-F054-45E9-A0A3-FBC69088AA41}"/>
+                <a16:creationId xmlns:a16="http://schemas.microsoft.com/office/drawing/2014/main" id="{2FF72528-D052-4E38-AF9D-11AD55F5629E}"/>
               </a:ext>
             </a:extLst>
           </p:cNvPr>
@@ -5783,7 +5783,7 @@
           <p:cNvPr id="9" name="">
             <a:extLst xmlns:a="http://schemas.openxmlformats.org/drawingml/2006/main">
               <a:ext uri="{FF2B5EF4-FFF2-40B4-BE49-F238E27FC236}">
-                <a16:creationId xmlns:a16="http://schemas.microsoft.com/office/drawing/2014/main" id="{2791591B-8007-4E61-A953-C60C292EF1B1}"/>
+                <a16:creationId xmlns:a16="http://schemas.microsoft.com/office/drawing/2014/main" id="{1CE82FBE-06A9-445B-93C5-87960DFA7062}"/>
               </a:ext>
             </a:extLst>
           </p:cNvPr>
@@ -5867,7 +5867,7 @@
           <p:cNvPr id="10" name="">
             <a:extLst xmlns:a="http://schemas.openxmlformats.org/drawingml/2006/main">
               <a:ext uri="{FF2B5EF4-FFF2-40B4-BE49-F238E27FC236}">
-                <a16:creationId xmlns:a16="http://schemas.microsoft.com/office/drawing/2014/main" id="{C699D08C-738D-4B94-86B7-06408B052E19}"/>
+                <a16:creationId xmlns:a16="http://schemas.microsoft.com/office/drawing/2014/main" id="{00C2D106-9DEB-4ACA-ACB9-4F239969CAD1}"/>
               </a:ext>
             </a:extLst>
           </p:cNvPr>
@@ -5902,7 +5902,7 @@
           <p:cNvPr id="11" name="">
             <a:extLst xmlns:a="http://schemas.openxmlformats.org/drawingml/2006/main">
               <a:ext uri="{FF2B5EF4-FFF2-40B4-BE49-F238E27FC236}">
-                <a16:creationId xmlns:a16="http://schemas.microsoft.com/office/drawing/2014/main" id="{2A97A31B-5C00-40B7-ACF8-76382D13F60B}"/>
+                <a16:creationId xmlns:a16="http://schemas.microsoft.com/office/drawing/2014/main" id="{7D70D3CE-81AC-4484-ADA6-0A6B42A301C9}"/>
               </a:ext>
             </a:extLst>
           </p:cNvPr>
@@ -5952,7 +5952,7 @@
           <p:cNvPr id="12" name="">
             <a:extLst xmlns:a="http://schemas.openxmlformats.org/drawingml/2006/main">
               <a:ext uri="{FF2B5EF4-FFF2-40B4-BE49-F238E27FC236}">
-                <a16:creationId xmlns:a16="http://schemas.microsoft.com/office/drawing/2014/main" id="{AFFFA557-3863-49C4-8DAD-EF0BC1FD0EB9}"/>
+                <a16:creationId xmlns:a16="http://schemas.microsoft.com/office/drawing/2014/main" id="{89BE7332-D2DE-4E56-BB63-3F83E394DF5E}"/>
               </a:ext>
             </a:extLst>
           </p:cNvPr>
@@ -6000,7 +6000,7 @@
     </p:spTree>
     <p:extLst>
       <p:ext uri="{BB962C8B-B14F-4D97-AF65-F5344CB8AC3E}">
-        <p14:creationId xmlns:p14="http://schemas.microsoft.com/office/powerpoint/2010/main" val="2107002189"/>
+        <p14:creationId xmlns:p14="http://schemas.microsoft.com/office/powerpoint/2010/main" val="1905176938"/>
       </p:ext>
     </p:extLst>
   </p:cSld>
@@ -6031,7 +6031,7 @@
           <p:cNvPr id="8" name="">
             <a:extLst xmlns:a="http://schemas.openxmlformats.org/drawingml/2006/main">
               <a:ext uri="{FF2B5EF4-FFF2-40B4-BE49-F238E27FC236}">
-                <a16:creationId xmlns:a16="http://schemas.microsoft.com/office/drawing/2014/main" id="{CA1CAF72-9459-47BD-B5D0-93D5D3265AFB}"/>
+                <a16:creationId xmlns:a16="http://schemas.microsoft.com/office/drawing/2014/main" id="{3C2B9D35-4984-48C0-8333-E5758C321B4C}"/>
               </a:ext>
             </a:extLst>
           </p:cNvPr>
@@ -6081,7 +6081,7 @@
           <p:cNvPr id="2" name="">
             <a:extLst xmlns:a="http://schemas.openxmlformats.org/drawingml/2006/main">
               <a:ext uri="{FF2B5EF4-FFF2-40B4-BE49-F238E27FC236}">
-                <a16:creationId xmlns:a16="http://schemas.microsoft.com/office/drawing/2014/main" id="{61957405-2510-4847-A016-25B24207B3B3}"/>
+                <a16:creationId xmlns:a16="http://schemas.microsoft.com/office/drawing/2014/main" id="{36209492-F9A0-46FE-983C-505D930C95FE}"/>
               </a:ext>
             </a:extLst>
           </p:cNvPr>
@@ -6148,7 +6148,7 @@
           <p:cNvPr id="3" name="">
             <a:extLst xmlns:a="http://schemas.openxmlformats.org/drawingml/2006/main">
               <a:ext uri="{FF2B5EF4-FFF2-40B4-BE49-F238E27FC236}">
-                <a16:creationId xmlns:a16="http://schemas.microsoft.com/office/drawing/2014/main" id="{D8CA87B2-6091-42A6-B94F-7D0A00BF9BFF}"/>
+                <a16:creationId xmlns:a16="http://schemas.microsoft.com/office/drawing/2014/main" id="{489B1E13-C8A1-4F53-AB31-3AF741AA878E}"/>
               </a:ext>
             </a:extLst>
           </p:cNvPr>
@@ -6183,7 +6183,7 @@
           <p:cNvPr id="4" name="">
             <a:extLst xmlns:a="http://schemas.openxmlformats.org/drawingml/2006/main">
               <a:ext uri="{FF2B5EF4-FFF2-40B4-BE49-F238E27FC236}">
-                <a16:creationId xmlns:a16="http://schemas.microsoft.com/office/drawing/2014/main" id="{817131AF-543D-41FF-AE15-70CF7E7B6046}"/>
+                <a16:creationId xmlns:a16="http://schemas.microsoft.com/office/drawing/2014/main" id="{50AF4243-ED00-4A0B-B7C4-BC2943866F8D}"/>
               </a:ext>
             </a:extLst>
           </p:cNvPr>
@@ -6233,7 +6233,7 @@
           <p:cNvPr id="5" name="">
             <a:extLst xmlns:a="http://schemas.openxmlformats.org/drawingml/2006/main">
               <a:ext uri="{FF2B5EF4-FFF2-40B4-BE49-F238E27FC236}">
-                <a16:creationId xmlns:a16="http://schemas.microsoft.com/office/drawing/2014/main" id="{AA86F5FC-CEF2-43F7-8F80-B04A91FCA540}"/>
+                <a16:creationId xmlns:a16="http://schemas.microsoft.com/office/drawing/2014/main" id="{FC84D361-89F2-4C02-BBA3-21D605C83349}"/>
               </a:ext>
             </a:extLst>
           </p:cNvPr>
@@ -6273,7 +6273,7 @@
                   <a:srgbClr val="FFD23F"/>
                 </a:solidFill>
               </a:rPr>
-              <a:t>통합·분류  ·  AI 설명  ·  해지 우선순위  ·  월·1년 절약액</a:t>
+              <a:t>통합·분류  ·  AI 일괄 분석  ·  해지 우선순위  ·  월·1년 절약액</a:t>
             </a:r>
           </a:p>
         </p:txBody>
@@ -6283,7 +6283,7 @@
           <p:cNvPr id="6" name="">
             <a:extLst xmlns:a="http://schemas.openxmlformats.org/drawingml/2006/main">
               <a:ext uri="{FF2B5EF4-FFF2-40B4-BE49-F238E27FC236}">
-                <a16:creationId xmlns:a16="http://schemas.microsoft.com/office/drawing/2014/main" id="{47B16845-926F-4EED-9BAF-F326D0DCA358}"/>
+                <a16:creationId xmlns:a16="http://schemas.microsoft.com/office/drawing/2014/main" id="{91CC9ADC-0CC3-489B-9638-8B1F5CF3EACF}"/>
               </a:ext>
             </a:extLst>
           </p:cNvPr>
@@ -6333,7 +6333,7 @@
           <p:cNvPr id="7" name="">
             <a:extLst xmlns:a="http://schemas.openxmlformats.org/drawingml/2006/main">
               <a:ext uri="{FF2B5EF4-FFF2-40B4-BE49-F238E27FC236}">
-                <a16:creationId xmlns:a16="http://schemas.microsoft.com/office/drawing/2014/main" id="{F935C04D-0428-4240-AE82-BC0A7CA8AA93}"/>
+                <a16:creationId xmlns:a16="http://schemas.microsoft.com/office/drawing/2014/main" id="{F8009C42-4338-4366-9FFC-906DC5EB6C67}"/>
               </a:ext>
             </a:extLst>
           </p:cNvPr>
@@ -6381,7 +6381,7 @@
     </p:spTree>
     <p:extLst>
       <p:ext uri="{BB962C8B-B14F-4D97-AF65-F5344CB8AC3E}">
-        <p14:creationId xmlns:p14="http://schemas.microsoft.com/office/powerpoint/2010/main" val="898429797"/>
+        <p14:creationId xmlns:p14="http://schemas.microsoft.com/office/powerpoint/2010/main" val="625928038"/>
       </p:ext>
     </p:extLst>
   </p:cSld>

</xml_diff>

<commit_message>
Refresh presentation batch analysis wording
</commit_message>
<xml_diff>
--- a/deliverables/subscription-cleaning-wanted-ai-championship-2026.pptx
+++ b/deliverables/subscription-cleaning-wanted-ai-championship-2026.pptx
@@ -2,19 +2,19 @@
 <file path=ppt/presentation.xml><?xml version="1.0" encoding="utf-8"?>
 <p:presentation xmlns:p="http://schemas.openxmlformats.org/presentationml/2006/main">
   <p:sldMasterIdLst>
-    <p:sldMasterId xmlns:r="http://schemas.openxmlformats.org/officeDocument/2006/relationships" id="2147483648" r:id="Ra6ba0bb245ca4ecd"/>
+    <p:sldMasterId xmlns:r="http://schemas.openxmlformats.org/officeDocument/2006/relationships" id="2147483648" r:id="R6dcf5b94dbdc4ea0"/>
   </p:sldMasterIdLst>
   <p:notesMasterIdLst>
-    <p:notesMasterId xmlns:r="http://schemas.openxmlformats.org/officeDocument/2006/relationships" r:id="Rf5ca0f4503a24c83"/>
+    <p:notesMasterId xmlns:r="http://schemas.openxmlformats.org/officeDocument/2006/relationships" r:id="R0ca3092269dd4ac8"/>
   </p:notesMasterIdLst>
   <p:sldIdLst>
-    <p:sldId xmlns:r="http://schemas.openxmlformats.org/officeDocument/2006/relationships" id="256" r:id="Rc49e9e400b324fc6"/>
-    <p:sldId xmlns:r="http://schemas.openxmlformats.org/officeDocument/2006/relationships" id="257" r:id="Re677eb668c8b463d"/>
-    <p:sldId xmlns:r="http://schemas.openxmlformats.org/officeDocument/2006/relationships" id="258" r:id="R72f5d2c9ca2c4ce3"/>
-    <p:sldId xmlns:r="http://schemas.openxmlformats.org/officeDocument/2006/relationships" id="259" r:id="Rdc2781ca200d49ef"/>
-    <p:sldId xmlns:r="http://schemas.openxmlformats.org/officeDocument/2006/relationships" id="260" r:id="Rc13e43d3c16848c8"/>
-    <p:sldId xmlns:r="http://schemas.openxmlformats.org/officeDocument/2006/relationships" id="261" r:id="Reebb75b7f5ed489f"/>
-    <p:sldId xmlns:r="http://schemas.openxmlformats.org/officeDocument/2006/relationships" id="262" r:id="R24df89ed5ae64454"/>
+    <p:sldId xmlns:r="http://schemas.openxmlformats.org/officeDocument/2006/relationships" id="256" r:id="Re3ccde61a013462f"/>
+    <p:sldId xmlns:r="http://schemas.openxmlformats.org/officeDocument/2006/relationships" id="257" r:id="R8cd9e3fbd3b5481a"/>
+    <p:sldId xmlns:r="http://schemas.openxmlformats.org/officeDocument/2006/relationships" id="258" r:id="R28ad3119010d41a2"/>
+    <p:sldId xmlns:r="http://schemas.openxmlformats.org/officeDocument/2006/relationships" id="259" r:id="R29c95dda49444da3"/>
+    <p:sldId xmlns:r="http://schemas.openxmlformats.org/officeDocument/2006/relationships" id="260" r:id="Rb6c235cf07084ff1"/>
+    <p:sldId xmlns:r="http://schemas.openxmlformats.org/officeDocument/2006/relationships" id="261" r:id="R907223f47bad49f2"/>
+    <p:sldId xmlns:r="http://schemas.openxmlformats.org/officeDocument/2006/relationships" id="262" r:id="R61715afb73b84256"/>
   </p:sldIdLst>
   <p:sldSz cx="12192000" cy="6858000"/>
   <p:notesSz cx="6858000" cy="9144000"/>
@@ -718,7 +718,7 @@
           <a:lstStyle xmlns:a="http://schemas.openxmlformats.org/drawingml/2006/main"/>
           <a:p xmlns:a="http://schemas.openxmlformats.org/drawingml/2006/main">
             <a:r>
-              <a:t>시연 화면은 샘플 결제내역을 분석한 실제 로컬 실행 결과입니다. 14건에서 5개 후보가 생성되고, 결제처가 통합·분류됩니다. 분석 버튼을 다시 누르면 전체 후보의 AI 설명을 한 번에 요청합니다.</a:t>
+              <a:t>시연 화면은 샘플 결제내역을 분석한 실제 로컬 실행 결과입니다. 14건에서 5개 후보가 생성되고, 결제처가 통합·분류됩니다. 분석 버튼을 다시 누르면 전체 후보의 AI 분석을 한 번에 요청합니다.</a:t>
             </a:r>
           </a:p>
           <a:p xmlns:a="http://schemas.openxmlformats.org/drawingml/2006/main">
@@ -1111,7 +1111,7 @@
   </p:cSld>
   <p:clrMap bg1="lt1" tx1="dk1" bg2="lt2" tx2="dk2" accent1="accent1" accent2="accent2" accent3="accent3" accent4="accent4" accent5="accent5" accent6="accent6" hlink="hlink" folHlink="folHlink"/>
   <p:sldLayoutIdLst>
-    <p:sldLayoutId xmlns:r="http://schemas.openxmlformats.org/officeDocument/2006/relationships" id="2147483649" r:id="R3cb683abfdd741c0"/>
+    <p:sldLayoutId xmlns:r="http://schemas.openxmlformats.org/officeDocument/2006/relationships" id="2147483649" r:id="R4731c2f3785b47ea"/>
   </p:sldLayoutIdLst>
   <p:txStyles>
     <p:titleStyle>
@@ -1662,7 +1662,7 @@
           <p:cNvPr id="7" name="">
             <a:extLst xmlns:a="http://schemas.openxmlformats.org/drawingml/2006/main">
               <a:ext uri="{FF2B5EF4-FFF2-40B4-BE49-F238E27FC236}">
-                <a16:creationId xmlns:a16="http://schemas.microsoft.com/office/drawing/2014/main" id="{464363B0-3BCB-4232-ACCD-8E4EB8F67CFB}"/>
+                <a16:creationId xmlns:a16="http://schemas.microsoft.com/office/drawing/2014/main" id="{6720B29C-780D-4250-8E7D-B67BD69C73AF}"/>
               </a:ext>
             </a:extLst>
           </p:cNvPr>
@@ -1695,7 +1695,7 @@
           <p:cNvPr id="2" name="">
             <a:extLst xmlns:a="http://schemas.openxmlformats.org/drawingml/2006/main">
               <a:ext uri="{FF2B5EF4-FFF2-40B4-BE49-F238E27FC236}">
-                <a16:creationId xmlns:a16="http://schemas.microsoft.com/office/drawing/2014/main" id="{8958A360-205C-4A30-8963-3211DEAD5C88}"/>
+                <a16:creationId xmlns:a16="http://schemas.microsoft.com/office/drawing/2014/main" id="{4391A357-1B09-4CD2-B2BC-67FABB50923D}"/>
               </a:ext>
             </a:extLst>
           </p:cNvPr>
@@ -1745,7 +1745,7 @@
           <p:cNvPr id="3" name="">
             <a:extLst xmlns:a="http://schemas.openxmlformats.org/drawingml/2006/main">
               <a:ext uri="{FF2B5EF4-FFF2-40B4-BE49-F238E27FC236}">
-                <a16:creationId xmlns:a16="http://schemas.microsoft.com/office/drawing/2014/main" id="{634B4F9D-32A1-4076-83C5-D72D1AFE65A6}"/>
+                <a16:creationId xmlns:a16="http://schemas.microsoft.com/office/drawing/2014/main" id="{41CD4828-D037-4E28-B167-5A249F1E8D4B}"/>
               </a:ext>
             </a:extLst>
           </p:cNvPr>
@@ -1812,7 +1812,7 @@
           <p:cNvPr id="4" name="">
             <a:extLst xmlns:a="http://schemas.openxmlformats.org/drawingml/2006/main">
               <a:ext uri="{FF2B5EF4-FFF2-40B4-BE49-F238E27FC236}">
-                <a16:creationId xmlns:a16="http://schemas.microsoft.com/office/drawing/2014/main" id="{3224ABB8-6863-420A-B757-F1608DFDD5E1}"/>
+                <a16:creationId xmlns:a16="http://schemas.microsoft.com/office/drawing/2014/main" id="{762A57F0-F2AF-498B-959A-B77145C45BD6}"/>
               </a:ext>
             </a:extLst>
           </p:cNvPr>
@@ -1862,7 +1862,7 @@
           <p:cNvPr id="5" name="">
             <a:extLst xmlns:a="http://schemas.openxmlformats.org/drawingml/2006/main">
               <a:ext uri="{FF2B5EF4-FFF2-40B4-BE49-F238E27FC236}">
-                <a16:creationId xmlns:a16="http://schemas.microsoft.com/office/drawing/2014/main" id="{3B60D65D-2085-4C5A-9D62-3F0450F13951}"/>
+                <a16:creationId xmlns:a16="http://schemas.microsoft.com/office/drawing/2014/main" id="{217990E8-31D8-4BC9-912D-AFCC12400E1D}"/>
               </a:ext>
             </a:extLst>
           </p:cNvPr>
@@ -1901,7 +1901,7 @@
           <p:nvPr/>
         </p:nvPicPr>
         <p:blipFill>
-          <a:blip xmlns:r="http://schemas.openxmlformats.org/officeDocument/2006/relationships" xmlns:a="http://schemas.openxmlformats.org/drawingml/2006/main" r:embed="Raaba8cc343594f86"/>
+          <a:blip xmlns:r="http://schemas.openxmlformats.org/officeDocument/2006/relationships" xmlns:a="http://schemas.openxmlformats.org/drawingml/2006/main" r:embed="Rcd2a167556e64c26"/>
           <a:stretch xmlns:a="http://schemas.openxmlformats.org/drawingml/2006/main"/>
         </p:blipFill>
         <p:spPr>
@@ -1919,7 +1919,7 @@
     </p:spTree>
     <p:extLst>
       <p:ext uri="{BB962C8B-B14F-4D97-AF65-F5344CB8AC3E}">
-        <p14:creationId xmlns:p14="http://schemas.microsoft.com/office/powerpoint/2010/main" val="1229725563"/>
+        <p14:creationId xmlns:p14="http://schemas.microsoft.com/office/powerpoint/2010/main" val="1760497975"/>
       </p:ext>
     </p:extLst>
   </p:cSld>
@@ -1950,7 +1950,7 @@
           <p:cNvPr id="15" name="">
             <a:extLst xmlns:a="http://schemas.openxmlformats.org/drawingml/2006/main">
               <a:ext uri="{FF2B5EF4-FFF2-40B4-BE49-F238E27FC236}">
-                <a16:creationId xmlns:a16="http://schemas.microsoft.com/office/drawing/2014/main" id="{0CDACBBE-4D23-47EF-8DB8-8B16357C889E}"/>
+                <a16:creationId xmlns:a16="http://schemas.microsoft.com/office/drawing/2014/main" id="{712AACC6-6F9F-4A22-9100-41D12DFF867D}"/>
               </a:ext>
             </a:extLst>
           </p:cNvPr>
@@ -2000,7 +2000,7 @@
           <p:cNvPr id="2" name="">
             <a:extLst xmlns:a="http://schemas.openxmlformats.org/drawingml/2006/main">
               <a:ext uri="{FF2B5EF4-FFF2-40B4-BE49-F238E27FC236}">
-                <a16:creationId xmlns:a16="http://schemas.microsoft.com/office/drawing/2014/main" id="{A445DAA9-DE18-453B-936B-3927A966BE1F}"/>
+                <a16:creationId xmlns:a16="http://schemas.microsoft.com/office/drawing/2014/main" id="{78C36A20-D03D-4ADA-BB54-B707F044E4E8}"/>
               </a:ext>
             </a:extLst>
           </p:cNvPr>
@@ -2050,7 +2050,7 @@
           <p:cNvPr id="3" name="">
             <a:extLst xmlns:a="http://schemas.openxmlformats.org/drawingml/2006/main">
               <a:ext uri="{FF2B5EF4-FFF2-40B4-BE49-F238E27FC236}">
-                <a16:creationId xmlns:a16="http://schemas.microsoft.com/office/drawing/2014/main" id="{F3523DAC-A0C8-4DE0-B92A-F15B8E705134}"/>
+                <a16:creationId xmlns:a16="http://schemas.microsoft.com/office/drawing/2014/main" id="{AA48F61F-BF92-4F66-849E-F2228DC85CD1}"/>
               </a:ext>
             </a:extLst>
           </p:cNvPr>
@@ -2100,7 +2100,7 @@
           <p:cNvPr id="4" name="">
             <a:extLst xmlns:a="http://schemas.openxmlformats.org/drawingml/2006/main">
               <a:ext uri="{FF2B5EF4-FFF2-40B4-BE49-F238E27FC236}">
-                <a16:creationId xmlns:a16="http://schemas.microsoft.com/office/drawing/2014/main" id="{D8C3D99D-CACC-4929-974E-EA4C5C151E6D}"/>
+                <a16:creationId xmlns:a16="http://schemas.microsoft.com/office/drawing/2014/main" id="{A4AD3826-3CC7-415B-8886-158713CFCD33}"/>
               </a:ext>
             </a:extLst>
           </p:cNvPr>
@@ -2167,7 +2167,7 @@
           <p:cNvPr id="5" name="">
             <a:extLst xmlns:a="http://schemas.openxmlformats.org/drawingml/2006/main">
               <a:ext uri="{FF2B5EF4-FFF2-40B4-BE49-F238E27FC236}">
-                <a16:creationId xmlns:a16="http://schemas.microsoft.com/office/drawing/2014/main" id="{3E2C32F3-E6EA-4DC0-A218-B89022CFB546}"/>
+                <a16:creationId xmlns:a16="http://schemas.microsoft.com/office/drawing/2014/main" id="{23F09404-76C8-4EFE-81C8-4D23C0CCF959}"/>
               </a:ext>
             </a:extLst>
           </p:cNvPr>
@@ -2202,7 +2202,7 @@
           <p:cNvPr id="6" name="">
             <a:extLst xmlns:a="http://schemas.openxmlformats.org/drawingml/2006/main">
               <a:ext uri="{FF2B5EF4-FFF2-40B4-BE49-F238E27FC236}">
-                <a16:creationId xmlns:a16="http://schemas.microsoft.com/office/drawing/2014/main" id="{47763CD2-7B3A-48FA-8CB8-2A61FB794108}"/>
+                <a16:creationId xmlns:a16="http://schemas.microsoft.com/office/drawing/2014/main" id="{86874324-E733-443E-B696-D805DDCDF337}"/>
               </a:ext>
             </a:extLst>
           </p:cNvPr>
@@ -2252,7 +2252,7 @@
           <p:cNvPr id="7" name="">
             <a:extLst xmlns:a="http://schemas.openxmlformats.org/drawingml/2006/main">
               <a:ext uri="{FF2B5EF4-FFF2-40B4-BE49-F238E27FC236}">
-                <a16:creationId xmlns:a16="http://schemas.microsoft.com/office/drawing/2014/main" id="{15D89B25-66E7-4FDC-B40D-F93EF8D1B364}"/>
+                <a16:creationId xmlns:a16="http://schemas.microsoft.com/office/drawing/2014/main" id="{84B71145-F665-42C2-83AA-769517033098}"/>
               </a:ext>
             </a:extLst>
           </p:cNvPr>
@@ -2336,7 +2336,7 @@
           <p:cNvPr id="8" name="">
             <a:extLst xmlns:a="http://schemas.openxmlformats.org/drawingml/2006/main">
               <a:ext uri="{FF2B5EF4-FFF2-40B4-BE49-F238E27FC236}">
-                <a16:creationId xmlns:a16="http://schemas.microsoft.com/office/drawing/2014/main" id="{C0C0171C-E8F7-49CB-8B8F-64970E333BD5}"/>
+                <a16:creationId xmlns:a16="http://schemas.microsoft.com/office/drawing/2014/main" id="{6215D563-517D-4FD9-9AD7-45036BF0908A}"/>
               </a:ext>
             </a:extLst>
           </p:cNvPr>
@@ -2371,7 +2371,7 @@
           <p:cNvPr id="9" name="">
             <a:extLst xmlns:a="http://schemas.openxmlformats.org/drawingml/2006/main">
               <a:ext uri="{FF2B5EF4-FFF2-40B4-BE49-F238E27FC236}">
-                <a16:creationId xmlns:a16="http://schemas.microsoft.com/office/drawing/2014/main" id="{9365ED8C-99B7-4BA0-A840-2D6602C6E510}"/>
+                <a16:creationId xmlns:a16="http://schemas.microsoft.com/office/drawing/2014/main" id="{FBB4B719-108F-4299-A324-FD2C151BB9C1}"/>
               </a:ext>
             </a:extLst>
           </p:cNvPr>
@@ -2421,7 +2421,7 @@
           <p:cNvPr id="10" name="">
             <a:extLst xmlns:a="http://schemas.openxmlformats.org/drawingml/2006/main">
               <a:ext uri="{FF2B5EF4-FFF2-40B4-BE49-F238E27FC236}">
-                <a16:creationId xmlns:a16="http://schemas.microsoft.com/office/drawing/2014/main" id="{6B6B25D6-F012-4DD8-B5EB-1EE162BB01AE}"/>
+                <a16:creationId xmlns:a16="http://schemas.microsoft.com/office/drawing/2014/main" id="{9C117FB8-BB73-4858-B9C6-FE5DE135211F}"/>
               </a:ext>
             </a:extLst>
           </p:cNvPr>
@@ -2505,7 +2505,7 @@
           <p:cNvPr id="11" name="">
             <a:extLst xmlns:a="http://schemas.openxmlformats.org/drawingml/2006/main">
               <a:ext uri="{FF2B5EF4-FFF2-40B4-BE49-F238E27FC236}">
-                <a16:creationId xmlns:a16="http://schemas.microsoft.com/office/drawing/2014/main" id="{8F48B5D5-4D9B-49FC-AE4C-B56DFA75C83C}"/>
+                <a16:creationId xmlns:a16="http://schemas.microsoft.com/office/drawing/2014/main" id="{401154CE-D7E9-48C8-83AA-CFE4BAE36D4D}"/>
               </a:ext>
             </a:extLst>
           </p:cNvPr>
@@ -2540,7 +2540,7 @@
           <p:cNvPr id="12" name="">
             <a:extLst xmlns:a="http://schemas.openxmlformats.org/drawingml/2006/main">
               <a:ext uri="{FF2B5EF4-FFF2-40B4-BE49-F238E27FC236}">
-                <a16:creationId xmlns:a16="http://schemas.microsoft.com/office/drawing/2014/main" id="{9C19DF38-A647-4F35-9353-6C8D3969D3A6}"/>
+                <a16:creationId xmlns:a16="http://schemas.microsoft.com/office/drawing/2014/main" id="{6DC24753-7062-423C-AE78-AEFE33781FA4}"/>
               </a:ext>
             </a:extLst>
           </p:cNvPr>
@@ -2590,7 +2590,7 @@
           <p:cNvPr id="13" name="">
             <a:extLst xmlns:a="http://schemas.openxmlformats.org/drawingml/2006/main">
               <a:ext uri="{FF2B5EF4-FFF2-40B4-BE49-F238E27FC236}">
-                <a16:creationId xmlns:a16="http://schemas.microsoft.com/office/drawing/2014/main" id="{364599A4-E6D1-4ECD-86B6-194A49B2104F}"/>
+                <a16:creationId xmlns:a16="http://schemas.microsoft.com/office/drawing/2014/main" id="{C6084909-8C84-421F-A223-A719F91D7163}"/>
               </a:ext>
             </a:extLst>
           </p:cNvPr>
@@ -2674,7 +2674,7 @@
           <p:cNvPr id="14" name="">
             <a:extLst xmlns:a="http://schemas.openxmlformats.org/drawingml/2006/main">
               <a:ext uri="{FF2B5EF4-FFF2-40B4-BE49-F238E27FC236}">
-                <a16:creationId xmlns:a16="http://schemas.microsoft.com/office/drawing/2014/main" id="{A0865C49-1C36-424B-934D-5E47434B88E0}"/>
+                <a16:creationId xmlns:a16="http://schemas.microsoft.com/office/drawing/2014/main" id="{CF480522-8D47-415E-8494-4C647E9DE973}"/>
               </a:ext>
             </a:extLst>
           </p:cNvPr>
@@ -2722,7 +2722,7 @@
     </p:spTree>
     <p:extLst>
       <p:ext uri="{BB962C8B-B14F-4D97-AF65-F5344CB8AC3E}">
-        <p14:creationId xmlns:p14="http://schemas.microsoft.com/office/powerpoint/2010/main" val="2022928499"/>
+        <p14:creationId xmlns:p14="http://schemas.microsoft.com/office/powerpoint/2010/main" val="6740676"/>
       </p:ext>
     </p:extLst>
   </p:cSld>
@@ -2753,7 +2753,7 @@
           <p:cNvPr id="25" name="">
             <a:extLst xmlns:a="http://schemas.openxmlformats.org/drawingml/2006/main">
               <a:ext uri="{FF2B5EF4-FFF2-40B4-BE49-F238E27FC236}">
-                <a16:creationId xmlns:a16="http://schemas.microsoft.com/office/drawing/2014/main" id="{35E0E739-8A53-4642-9DD0-CED61364DEB6}"/>
+                <a16:creationId xmlns:a16="http://schemas.microsoft.com/office/drawing/2014/main" id="{E344675C-D37A-4618-BDEB-972636ADD24D}"/>
               </a:ext>
             </a:extLst>
           </p:cNvPr>
@@ -2803,7 +2803,7 @@
           <p:cNvPr id="2" name="">
             <a:extLst xmlns:a="http://schemas.openxmlformats.org/drawingml/2006/main">
               <a:ext uri="{FF2B5EF4-FFF2-40B4-BE49-F238E27FC236}">
-                <a16:creationId xmlns:a16="http://schemas.microsoft.com/office/drawing/2014/main" id="{105180A1-CA83-46B0-8F93-99B81F63E725}"/>
+                <a16:creationId xmlns:a16="http://schemas.microsoft.com/office/drawing/2014/main" id="{FF1FB69D-8996-421B-9433-9641AF96C64E}"/>
               </a:ext>
             </a:extLst>
           </p:cNvPr>
@@ -2853,7 +2853,7 @@
           <p:cNvPr id="3" name="">
             <a:extLst xmlns:a="http://schemas.openxmlformats.org/drawingml/2006/main">
               <a:ext uri="{FF2B5EF4-FFF2-40B4-BE49-F238E27FC236}">
-                <a16:creationId xmlns:a16="http://schemas.microsoft.com/office/drawing/2014/main" id="{924A8525-6EC3-4577-B2CE-093B0842D6C9}"/>
+                <a16:creationId xmlns:a16="http://schemas.microsoft.com/office/drawing/2014/main" id="{68060708-58B8-4E56-81C9-D17ECB46026F}"/>
               </a:ext>
             </a:extLst>
           </p:cNvPr>
@@ -2903,7 +2903,7 @@
           <p:cNvPr id="4" name="">
             <a:extLst xmlns:a="http://schemas.openxmlformats.org/drawingml/2006/main">
               <a:ext uri="{FF2B5EF4-FFF2-40B4-BE49-F238E27FC236}">
-                <a16:creationId xmlns:a16="http://schemas.microsoft.com/office/drawing/2014/main" id="{13D41B6B-13DB-47B4-B7E4-3498159E152E}"/>
+                <a16:creationId xmlns:a16="http://schemas.microsoft.com/office/drawing/2014/main" id="{6B9B9235-FF0C-4268-A2F8-CBCDDAC30FA6}"/>
               </a:ext>
             </a:extLst>
           </p:cNvPr>
@@ -2936,7 +2936,7 @@
           <p:cNvPr id="5" name="">
             <a:extLst xmlns:a="http://schemas.openxmlformats.org/drawingml/2006/main">
               <a:ext uri="{FF2B5EF4-FFF2-40B4-BE49-F238E27FC236}">
-                <a16:creationId xmlns:a16="http://schemas.microsoft.com/office/drawing/2014/main" id="{4D49D588-0278-49EF-B37E-4A48EA6DD517}"/>
+                <a16:creationId xmlns:a16="http://schemas.microsoft.com/office/drawing/2014/main" id="{9505C923-7D9B-4CB0-B1B0-04E621B4756B}"/>
               </a:ext>
             </a:extLst>
           </p:cNvPr>
@@ -2971,7 +2971,7 @@
           <p:cNvPr id="6" name="">
             <a:extLst xmlns:a="http://schemas.openxmlformats.org/drawingml/2006/main">
               <a:ext uri="{FF2B5EF4-FFF2-40B4-BE49-F238E27FC236}">
-                <a16:creationId xmlns:a16="http://schemas.microsoft.com/office/drawing/2014/main" id="{936D5F97-075C-4CAD-9D0A-E47F89B87C01}"/>
+                <a16:creationId xmlns:a16="http://schemas.microsoft.com/office/drawing/2014/main" id="{FF56193D-C5A1-4030-AC0B-10BF4E3DCA33}"/>
               </a:ext>
             </a:extLst>
           </p:cNvPr>
@@ -3021,7 +3021,7 @@
           <p:cNvPr id="7" name="">
             <a:extLst xmlns:a="http://schemas.openxmlformats.org/drawingml/2006/main">
               <a:ext uri="{FF2B5EF4-FFF2-40B4-BE49-F238E27FC236}">
-                <a16:creationId xmlns:a16="http://schemas.microsoft.com/office/drawing/2014/main" id="{D954AEF0-0536-496C-86F7-CB45C9B5A6C4}"/>
+                <a16:creationId xmlns:a16="http://schemas.microsoft.com/office/drawing/2014/main" id="{D7ADC147-78B2-424D-AA79-424D98523BB8}"/>
               </a:ext>
             </a:extLst>
           </p:cNvPr>
@@ -3071,7 +3071,7 @@
           <p:cNvPr id="8" name="">
             <a:extLst xmlns:a="http://schemas.openxmlformats.org/drawingml/2006/main">
               <a:ext uri="{FF2B5EF4-FFF2-40B4-BE49-F238E27FC236}">
-                <a16:creationId xmlns:a16="http://schemas.microsoft.com/office/drawing/2014/main" id="{E25779D3-D606-4CAA-83B9-2754556C6B47}"/>
+                <a16:creationId xmlns:a16="http://schemas.microsoft.com/office/drawing/2014/main" id="{75BF7026-AB8D-4A1D-90B3-8639871CF44B}"/>
               </a:ext>
             </a:extLst>
           </p:cNvPr>
@@ -3121,7 +3121,7 @@
           <p:cNvPr id="9" name="">
             <a:extLst xmlns:a="http://schemas.openxmlformats.org/drawingml/2006/main">
               <a:ext uri="{FF2B5EF4-FFF2-40B4-BE49-F238E27FC236}">
-                <a16:creationId xmlns:a16="http://schemas.microsoft.com/office/drawing/2014/main" id="{770BF113-2A70-451A-9ED9-659A778402C6}"/>
+                <a16:creationId xmlns:a16="http://schemas.microsoft.com/office/drawing/2014/main" id="{3DCAF233-848F-44BD-AE7B-E8ED00227253}"/>
               </a:ext>
             </a:extLst>
           </p:cNvPr>
@@ -3154,7 +3154,7 @@
           <p:cNvPr id="10" name="">
             <a:extLst xmlns:a="http://schemas.openxmlformats.org/drawingml/2006/main">
               <a:ext uri="{FF2B5EF4-FFF2-40B4-BE49-F238E27FC236}">
-                <a16:creationId xmlns:a16="http://schemas.microsoft.com/office/drawing/2014/main" id="{AF87BF9B-990F-451F-A92E-2537E0299495}"/>
+                <a16:creationId xmlns:a16="http://schemas.microsoft.com/office/drawing/2014/main" id="{23A77495-DB7A-436B-B821-801F89C1FC18}"/>
               </a:ext>
             </a:extLst>
           </p:cNvPr>
@@ -3189,7 +3189,7 @@
           <p:cNvPr id="11" name="">
             <a:extLst xmlns:a="http://schemas.openxmlformats.org/drawingml/2006/main">
               <a:ext uri="{FF2B5EF4-FFF2-40B4-BE49-F238E27FC236}">
-                <a16:creationId xmlns:a16="http://schemas.microsoft.com/office/drawing/2014/main" id="{84571C7C-93FB-4CAB-929E-3C876A4A9D10}"/>
+                <a16:creationId xmlns:a16="http://schemas.microsoft.com/office/drawing/2014/main" id="{4126AE48-0208-4AE2-B1E3-9A211B8CB47D}"/>
               </a:ext>
             </a:extLst>
           </p:cNvPr>
@@ -3239,7 +3239,7 @@
           <p:cNvPr id="12" name="">
             <a:extLst xmlns:a="http://schemas.openxmlformats.org/drawingml/2006/main">
               <a:ext uri="{FF2B5EF4-FFF2-40B4-BE49-F238E27FC236}">
-                <a16:creationId xmlns:a16="http://schemas.microsoft.com/office/drawing/2014/main" id="{9375E447-D976-42E1-B209-AB48D8BC4018}"/>
+                <a16:creationId xmlns:a16="http://schemas.microsoft.com/office/drawing/2014/main" id="{02E0A50C-00C6-4E5B-9653-F7EE9AA341F5}"/>
               </a:ext>
             </a:extLst>
           </p:cNvPr>
@@ -3289,7 +3289,7 @@
           <p:cNvPr id="13" name="">
             <a:extLst xmlns:a="http://schemas.openxmlformats.org/drawingml/2006/main">
               <a:ext uri="{FF2B5EF4-FFF2-40B4-BE49-F238E27FC236}">
-                <a16:creationId xmlns:a16="http://schemas.microsoft.com/office/drawing/2014/main" id="{7503427A-2C9F-4E43-BCB0-B96F42B8D301}"/>
+                <a16:creationId xmlns:a16="http://schemas.microsoft.com/office/drawing/2014/main" id="{E8E7D4D7-BC86-473F-8517-C7ED430B65FF}"/>
               </a:ext>
             </a:extLst>
           </p:cNvPr>
@@ -3339,7 +3339,7 @@
           <p:cNvPr id="14" name="">
             <a:extLst xmlns:a="http://schemas.openxmlformats.org/drawingml/2006/main">
               <a:ext uri="{FF2B5EF4-FFF2-40B4-BE49-F238E27FC236}">
-                <a16:creationId xmlns:a16="http://schemas.microsoft.com/office/drawing/2014/main" id="{7D1C125F-B6D1-4007-9639-7A041238FC2D}"/>
+                <a16:creationId xmlns:a16="http://schemas.microsoft.com/office/drawing/2014/main" id="{49B7960C-D661-4203-80FF-56AE0D144D3E}"/>
               </a:ext>
             </a:extLst>
           </p:cNvPr>
@@ -3372,7 +3372,7 @@
           <p:cNvPr id="15" name="">
             <a:extLst xmlns:a="http://schemas.openxmlformats.org/drawingml/2006/main">
               <a:ext uri="{FF2B5EF4-FFF2-40B4-BE49-F238E27FC236}">
-                <a16:creationId xmlns:a16="http://schemas.microsoft.com/office/drawing/2014/main" id="{8974FF47-1761-4CD4-B30A-74929498C5A2}"/>
+                <a16:creationId xmlns:a16="http://schemas.microsoft.com/office/drawing/2014/main" id="{951FE632-C6A9-4434-A435-7F125A600434}"/>
               </a:ext>
             </a:extLst>
           </p:cNvPr>
@@ -3407,7 +3407,7 @@
           <p:cNvPr id="16" name="">
             <a:extLst xmlns:a="http://schemas.openxmlformats.org/drawingml/2006/main">
               <a:ext uri="{FF2B5EF4-FFF2-40B4-BE49-F238E27FC236}">
-                <a16:creationId xmlns:a16="http://schemas.microsoft.com/office/drawing/2014/main" id="{81CD48FA-FA70-4DEB-9111-E9308D206157}"/>
+                <a16:creationId xmlns:a16="http://schemas.microsoft.com/office/drawing/2014/main" id="{AA487B30-19F8-4B14-B85D-D98EC6733EC9}"/>
               </a:ext>
             </a:extLst>
           </p:cNvPr>
@@ -3457,7 +3457,7 @@
           <p:cNvPr id="17" name="">
             <a:extLst xmlns:a="http://schemas.openxmlformats.org/drawingml/2006/main">
               <a:ext uri="{FF2B5EF4-FFF2-40B4-BE49-F238E27FC236}">
-                <a16:creationId xmlns:a16="http://schemas.microsoft.com/office/drawing/2014/main" id="{97AF7FFB-739C-488A-A321-7FF4B1C921E7}"/>
+                <a16:creationId xmlns:a16="http://schemas.microsoft.com/office/drawing/2014/main" id="{40F454F4-CDCE-497D-AA01-F5E51D1ABA02}"/>
               </a:ext>
             </a:extLst>
           </p:cNvPr>
@@ -3507,7 +3507,7 @@
           <p:cNvPr id="18" name="">
             <a:extLst xmlns:a="http://schemas.openxmlformats.org/drawingml/2006/main">
               <a:ext uri="{FF2B5EF4-FFF2-40B4-BE49-F238E27FC236}">
-                <a16:creationId xmlns:a16="http://schemas.microsoft.com/office/drawing/2014/main" id="{76E0AD0D-ABE7-4AB4-8E92-FCB7D3EBB215}"/>
+                <a16:creationId xmlns:a16="http://schemas.microsoft.com/office/drawing/2014/main" id="{2139CCC6-36E4-4352-A281-1742D43D84E4}"/>
               </a:ext>
             </a:extLst>
           </p:cNvPr>
@@ -3557,7 +3557,7 @@
           <p:cNvPr id="19" name="">
             <a:extLst xmlns:a="http://schemas.openxmlformats.org/drawingml/2006/main">
               <a:ext uri="{FF2B5EF4-FFF2-40B4-BE49-F238E27FC236}">
-                <a16:creationId xmlns:a16="http://schemas.microsoft.com/office/drawing/2014/main" id="{EA7744AF-D6FB-4D52-B3C7-0915E99FBC5B}"/>
+                <a16:creationId xmlns:a16="http://schemas.microsoft.com/office/drawing/2014/main" id="{012A5A41-1073-4D83-9D4E-62D184016880}"/>
               </a:ext>
             </a:extLst>
           </p:cNvPr>
@@ -3592,7 +3592,7 @@
           <p:cNvPr id="20" name="">
             <a:extLst xmlns:a="http://schemas.openxmlformats.org/drawingml/2006/main">
               <a:ext uri="{FF2B5EF4-FFF2-40B4-BE49-F238E27FC236}">
-                <a16:creationId xmlns:a16="http://schemas.microsoft.com/office/drawing/2014/main" id="{D7D7BFA0-E1E2-45DA-8579-CBADC6E80FC3}"/>
+                <a16:creationId xmlns:a16="http://schemas.microsoft.com/office/drawing/2014/main" id="{0CEB6B3B-0853-4D2F-9C42-4DA9E6E310E7}"/>
               </a:ext>
             </a:extLst>
           </p:cNvPr>
@@ -3642,7 +3642,7 @@
           <p:cNvPr id="21" name="">
             <a:extLst xmlns:a="http://schemas.openxmlformats.org/drawingml/2006/main">
               <a:ext uri="{FF2B5EF4-FFF2-40B4-BE49-F238E27FC236}">
-                <a16:creationId xmlns:a16="http://schemas.microsoft.com/office/drawing/2014/main" id="{D9466179-1522-4B46-886D-E8ADEC205377}"/>
+                <a16:creationId xmlns:a16="http://schemas.microsoft.com/office/drawing/2014/main" id="{03820BBA-C80B-437B-B2CC-9B9E69D60DCF}"/>
               </a:ext>
             </a:extLst>
           </p:cNvPr>
@@ -3692,7 +3692,7 @@
           <p:cNvPr id="22" name="">
             <a:extLst xmlns:a="http://schemas.openxmlformats.org/drawingml/2006/main">
               <a:ext uri="{FF2B5EF4-FFF2-40B4-BE49-F238E27FC236}">
-                <a16:creationId xmlns:a16="http://schemas.microsoft.com/office/drawing/2014/main" id="{8FAD2792-C5E7-4630-8EBE-6DCF8423986E}"/>
+                <a16:creationId xmlns:a16="http://schemas.microsoft.com/office/drawing/2014/main" id="{D1758A19-9891-4DAA-9E01-2BD8E97DB3CF}"/>
               </a:ext>
             </a:extLst>
           </p:cNvPr>
@@ -3742,7 +3742,7 @@
           <p:cNvPr id="23" name="">
             <a:extLst xmlns:a="http://schemas.openxmlformats.org/drawingml/2006/main">
               <a:ext uri="{FF2B5EF4-FFF2-40B4-BE49-F238E27FC236}">
-                <a16:creationId xmlns:a16="http://schemas.microsoft.com/office/drawing/2014/main" id="{F5ECECDD-F5E8-4A80-A485-9F8F6B9259D4}"/>
+                <a16:creationId xmlns:a16="http://schemas.microsoft.com/office/drawing/2014/main" id="{F4092D96-EF20-4D3E-970A-4126FEE1CE21}"/>
               </a:ext>
             </a:extLst>
           </p:cNvPr>
@@ -3792,7 +3792,7 @@
           <p:cNvPr id="24" name="">
             <a:extLst xmlns:a="http://schemas.openxmlformats.org/drawingml/2006/main">
               <a:ext uri="{FF2B5EF4-FFF2-40B4-BE49-F238E27FC236}">
-                <a16:creationId xmlns:a16="http://schemas.microsoft.com/office/drawing/2014/main" id="{C1C53D69-EEE2-485B-AAE6-14C1A2924A07}"/>
+                <a16:creationId xmlns:a16="http://schemas.microsoft.com/office/drawing/2014/main" id="{B81FC09D-48A7-4555-A61D-5016F03AC3D0}"/>
               </a:ext>
             </a:extLst>
           </p:cNvPr>
@@ -3840,7 +3840,7 @@
     </p:spTree>
     <p:extLst>
       <p:ext uri="{BB962C8B-B14F-4D97-AF65-F5344CB8AC3E}">
-        <p14:creationId xmlns:p14="http://schemas.microsoft.com/office/powerpoint/2010/main" val="1037964823"/>
+        <p14:creationId xmlns:p14="http://schemas.microsoft.com/office/powerpoint/2010/main" val="1021574056"/>
       </p:ext>
     </p:extLst>
   </p:cSld>
@@ -3871,7 +3871,7 @@
           <p:cNvPr id="13" name="">
             <a:extLst xmlns:a="http://schemas.openxmlformats.org/drawingml/2006/main">
               <a:ext uri="{FF2B5EF4-FFF2-40B4-BE49-F238E27FC236}">
-                <a16:creationId xmlns:a16="http://schemas.microsoft.com/office/drawing/2014/main" id="{89F19913-EB1C-4121-9D46-9D78F01B43BA}"/>
+                <a16:creationId xmlns:a16="http://schemas.microsoft.com/office/drawing/2014/main" id="{3AE24E54-EEC6-4792-BCF2-0FBA9A5226CF}"/>
               </a:ext>
             </a:extLst>
           </p:cNvPr>
@@ -3921,7 +3921,7 @@
           <p:cNvPr id="2" name="">
             <a:extLst xmlns:a="http://schemas.openxmlformats.org/drawingml/2006/main">
               <a:ext uri="{FF2B5EF4-FFF2-40B4-BE49-F238E27FC236}">
-                <a16:creationId xmlns:a16="http://schemas.microsoft.com/office/drawing/2014/main" id="{CAA3A73C-B9A5-427B-82B5-637D8D13E101}"/>
+                <a16:creationId xmlns:a16="http://schemas.microsoft.com/office/drawing/2014/main" id="{E71A9FF1-0D14-47D4-8A18-2DC335F107FF}"/>
               </a:ext>
             </a:extLst>
           </p:cNvPr>
@@ -3971,7 +3971,7 @@
           <p:cNvPr id="3" name="">
             <a:extLst xmlns:a="http://schemas.openxmlformats.org/drawingml/2006/main">
               <a:ext uri="{FF2B5EF4-FFF2-40B4-BE49-F238E27FC236}">
-                <a16:creationId xmlns:a16="http://schemas.microsoft.com/office/drawing/2014/main" id="{50600BAE-2A2F-4D21-BBD5-1B48482E84C3}"/>
+                <a16:creationId xmlns:a16="http://schemas.microsoft.com/office/drawing/2014/main" id="{8C22F8B7-FA15-4314-960D-7CC84B99544F}"/>
               </a:ext>
             </a:extLst>
           </p:cNvPr>
@@ -4021,7 +4021,7 @@
           <p:cNvPr id="4" name="">
             <a:extLst xmlns:a="http://schemas.openxmlformats.org/drawingml/2006/main">
               <a:ext uri="{FF2B5EF4-FFF2-40B4-BE49-F238E27FC236}">
-                <a16:creationId xmlns:a16="http://schemas.microsoft.com/office/drawing/2014/main" id="{7C72893F-C8D6-41B2-93C7-42216F012E8E}"/>
+                <a16:creationId xmlns:a16="http://schemas.microsoft.com/office/drawing/2014/main" id="{B935DC27-9F72-47AF-A0D0-8DA7A31B4F05}"/>
               </a:ext>
             </a:extLst>
           </p:cNvPr>
@@ -4071,7 +4071,7 @@
           <p:cNvPr id="5" name="">
             <a:extLst xmlns:a="http://schemas.openxmlformats.org/drawingml/2006/main">
               <a:ext uri="{FF2B5EF4-FFF2-40B4-BE49-F238E27FC236}">
-                <a16:creationId xmlns:a16="http://schemas.microsoft.com/office/drawing/2014/main" id="{0FDCD989-62AF-4B20-8A4C-276DB6D584B4}"/>
+                <a16:creationId xmlns:a16="http://schemas.microsoft.com/office/drawing/2014/main" id="{AE356243-7A2D-4257-A861-9F466165C3AA}"/>
               </a:ext>
             </a:extLst>
           </p:cNvPr>
@@ -4121,7 +4121,7 @@
           <p:cNvPr id="6" name="">
             <a:extLst xmlns:a="http://schemas.openxmlformats.org/drawingml/2006/main">
               <a:ext uri="{FF2B5EF4-FFF2-40B4-BE49-F238E27FC236}">
-                <a16:creationId xmlns:a16="http://schemas.microsoft.com/office/drawing/2014/main" id="{CB205F65-7861-404A-86CC-5200B16D9D67}"/>
+                <a16:creationId xmlns:a16="http://schemas.microsoft.com/office/drawing/2014/main" id="{D09BA472-6DB6-4FB3-890C-0D2A3CFA647A}"/>
               </a:ext>
             </a:extLst>
           </p:cNvPr>
@@ -4188,7 +4188,7 @@
           <p:cNvPr id="7" name="">
             <a:extLst xmlns:a="http://schemas.openxmlformats.org/drawingml/2006/main">
               <a:ext uri="{FF2B5EF4-FFF2-40B4-BE49-F238E27FC236}">
-                <a16:creationId xmlns:a16="http://schemas.microsoft.com/office/drawing/2014/main" id="{6F2BD744-29A2-4958-977D-A7B4B7621807}"/>
+                <a16:creationId xmlns:a16="http://schemas.microsoft.com/office/drawing/2014/main" id="{5300F67B-948E-4AB5-9C76-DC2801D53CCD}"/>
               </a:ext>
             </a:extLst>
           </p:cNvPr>
@@ -4223,7 +4223,7 @@
           <p:cNvPr id="8" name="">
             <a:extLst xmlns:a="http://schemas.openxmlformats.org/drawingml/2006/main">
               <a:ext uri="{FF2B5EF4-FFF2-40B4-BE49-F238E27FC236}">
-                <a16:creationId xmlns:a16="http://schemas.microsoft.com/office/drawing/2014/main" id="{0F940265-D472-4141-981D-381F4ECF42B2}"/>
+                <a16:creationId xmlns:a16="http://schemas.microsoft.com/office/drawing/2014/main" id="{D3A7EBBA-2EA2-4E17-82D9-E7CE1896DFBD}"/>
               </a:ext>
             </a:extLst>
           </p:cNvPr>
@@ -4273,7 +4273,7 @@
           <p:cNvPr id="9" name="">
             <a:extLst xmlns:a="http://schemas.openxmlformats.org/drawingml/2006/main">
               <a:ext uri="{FF2B5EF4-FFF2-40B4-BE49-F238E27FC236}">
-                <a16:creationId xmlns:a16="http://schemas.microsoft.com/office/drawing/2014/main" id="{F112F549-A295-4328-BD96-64E9AEDF249A}"/>
+                <a16:creationId xmlns:a16="http://schemas.microsoft.com/office/drawing/2014/main" id="{E40502D9-2334-47CD-826E-A9ABC7C5CF6B}"/>
               </a:ext>
             </a:extLst>
           </p:cNvPr>
@@ -4323,7 +4323,7 @@
           <p:cNvPr id="10" name="">
             <a:extLst xmlns:a="http://schemas.openxmlformats.org/drawingml/2006/main">
               <a:ext uri="{FF2B5EF4-FFF2-40B4-BE49-F238E27FC236}">
-                <a16:creationId xmlns:a16="http://schemas.microsoft.com/office/drawing/2014/main" id="{0A10C2B8-4AE0-4403-9B72-61EEFAF01625}"/>
+                <a16:creationId xmlns:a16="http://schemas.microsoft.com/office/drawing/2014/main" id="{2F5BDA1D-FF39-4E0B-8D35-473D5EAFD7EE}"/>
               </a:ext>
             </a:extLst>
           </p:cNvPr>
@@ -4362,7 +4362,7 @@
           <p:nvPr/>
         </p:nvPicPr>
         <p:blipFill>
-          <a:blip xmlns:r="http://schemas.openxmlformats.org/officeDocument/2006/relationships" xmlns:a="http://schemas.openxmlformats.org/drawingml/2006/main" r:embed="R9757a93e81e64c38"/>
+          <a:blip xmlns:r="http://schemas.openxmlformats.org/officeDocument/2006/relationships" xmlns:a="http://schemas.openxmlformats.org/drawingml/2006/main" r:embed="R3da3a78e3ca14d7e"/>
           <a:stretch xmlns:a="http://schemas.openxmlformats.org/drawingml/2006/main"/>
         </p:blipFill>
         <p:spPr>
@@ -4382,7 +4382,7 @@
           <p:cNvPr id="12" name="">
             <a:extLst xmlns:a="http://schemas.openxmlformats.org/drawingml/2006/main">
               <a:ext uri="{FF2B5EF4-FFF2-40B4-BE49-F238E27FC236}">
-                <a16:creationId xmlns:a16="http://schemas.microsoft.com/office/drawing/2014/main" id="{60A14D22-3DA4-46B1-861D-29AC399EEA19}"/>
+                <a16:creationId xmlns:a16="http://schemas.microsoft.com/office/drawing/2014/main" id="{1969C018-1A7F-4D38-9BB6-6F692A9009DD}"/>
               </a:ext>
             </a:extLst>
           </p:cNvPr>
@@ -4430,7 +4430,7 @@
     </p:spTree>
     <p:extLst>
       <p:ext uri="{BB962C8B-B14F-4D97-AF65-F5344CB8AC3E}">
-        <p14:creationId xmlns:p14="http://schemas.microsoft.com/office/powerpoint/2010/main" val="591791563"/>
+        <p14:creationId xmlns:p14="http://schemas.microsoft.com/office/powerpoint/2010/main" val="741113632"/>
       </p:ext>
     </p:extLst>
   </p:cSld>
@@ -4461,7 +4461,7 @@
           <p:cNvPr id="17" name="">
             <a:extLst xmlns:a="http://schemas.openxmlformats.org/drawingml/2006/main">
               <a:ext uri="{FF2B5EF4-FFF2-40B4-BE49-F238E27FC236}">
-                <a16:creationId xmlns:a16="http://schemas.microsoft.com/office/drawing/2014/main" id="{7F67489E-E129-4B08-99DF-0B6397B191A9}"/>
+                <a16:creationId xmlns:a16="http://schemas.microsoft.com/office/drawing/2014/main" id="{E3F5F057-E21B-4E83-92A9-9AA625CCB6B9}"/>
               </a:ext>
             </a:extLst>
           </p:cNvPr>
@@ -4511,7 +4511,7 @@
           <p:cNvPr id="2" name="">
             <a:extLst xmlns:a="http://schemas.openxmlformats.org/drawingml/2006/main">
               <a:ext uri="{FF2B5EF4-FFF2-40B4-BE49-F238E27FC236}">
-                <a16:creationId xmlns:a16="http://schemas.microsoft.com/office/drawing/2014/main" id="{2046B3A3-F8AF-47E1-858A-A860CE33F806}"/>
+                <a16:creationId xmlns:a16="http://schemas.microsoft.com/office/drawing/2014/main" id="{2CEAF55D-F4ED-47E7-AFFF-2B61D0B8C5EE}"/>
               </a:ext>
             </a:extLst>
           </p:cNvPr>
@@ -4561,7 +4561,7 @@
           <p:cNvPr id="3" name="">
             <a:extLst xmlns:a="http://schemas.openxmlformats.org/drawingml/2006/main">
               <a:ext uri="{FF2B5EF4-FFF2-40B4-BE49-F238E27FC236}">
-                <a16:creationId xmlns:a16="http://schemas.microsoft.com/office/drawing/2014/main" id="{9D0E9E45-91E9-4146-8F66-A089C8BE9613}"/>
+                <a16:creationId xmlns:a16="http://schemas.microsoft.com/office/drawing/2014/main" id="{971C83A3-2570-40FE-A5AE-9C2EA3A983D3}"/>
               </a:ext>
             </a:extLst>
           </p:cNvPr>
@@ -4611,7 +4611,7 @@
           <p:cNvPr id="4" name="">
             <a:extLst xmlns:a="http://schemas.openxmlformats.org/drawingml/2006/main">
               <a:ext uri="{FF2B5EF4-FFF2-40B4-BE49-F238E27FC236}">
-                <a16:creationId xmlns:a16="http://schemas.microsoft.com/office/drawing/2014/main" id="{706E6E9D-46E6-453C-A54D-E1558C5DC6B4}"/>
+                <a16:creationId xmlns:a16="http://schemas.microsoft.com/office/drawing/2014/main" id="{359B9BB4-E73C-455B-A6CE-3D90DD7E398C}"/>
               </a:ext>
             </a:extLst>
           </p:cNvPr>
@@ -4646,7 +4646,7 @@
           <p:cNvPr id="5" name="">
             <a:extLst xmlns:a="http://schemas.openxmlformats.org/drawingml/2006/main">
               <a:ext uri="{FF2B5EF4-FFF2-40B4-BE49-F238E27FC236}">
-                <a16:creationId xmlns:a16="http://schemas.microsoft.com/office/drawing/2014/main" id="{7B3FE6EA-FC43-4804-8C47-323E9F40997E}"/>
+                <a16:creationId xmlns:a16="http://schemas.microsoft.com/office/drawing/2014/main" id="{4463F7C5-C26F-43DF-BF9E-4B0BEE176CE7}"/>
               </a:ext>
             </a:extLst>
           </p:cNvPr>
@@ -4696,7 +4696,7 @@
           <p:cNvPr id="6" name="">
             <a:extLst xmlns:a="http://schemas.openxmlformats.org/drawingml/2006/main">
               <a:ext uri="{FF2B5EF4-FFF2-40B4-BE49-F238E27FC236}">
-                <a16:creationId xmlns:a16="http://schemas.microsoft.com/office/drawing/2014/main" id="{688AE15C-4D87-47AA-B644-E7C87C715EB0}"/>
+                <a16:creationId xmlns:a16="http://schemas.microsoft.com/office/drawing/2014/main" id="{C9B2E4FA-05E6-4642-835C-23E563E75AED}"/>
               </a:ext>
             </a:extLst>
           </p:cNvPr>
@@ -4780,7 +4780,7 @@
           <p:cNvPr id="7" name="">
             <a:extLst xmlns:a="http://schemas.openxmlformats.org/drawingml/2006/main">
               <a:ext uri="{FF2B5EF4-FFF2-40B4-BE49-F238E27FC236}">
-                <a16:creationId xmlns:a16="http://schemas.microsoft.com/office/drawing/2014/main" id="{07F9C61E-FB86-4FA7-9AF6-5338BFD88CC5}"/>
+                <a16:creationId xmlns:a16="http://schemas.microsoft.com/office/drawing/2014/main" id="{AC5F2B49-D608-4493-8C41-E4E16BCE4365}"/>
               </a:ext>
             </a:extLst>
           </p:cNvPr>
@@ -4815,7 +4815,7 @@
           <p:cNvPr id="8" name="">
             <a:extLst xmlns:a="http://schemas.openxmlformats.org/drawingml/2006/main">
               <a:ext uri="{FF2B5EF4-FFF2-40B4-BE49-F238E27FC236}">
-                <a16:creationId xmlns:a16="http://schemas.microsoft.com/office/drawing/2014/main" id="{5265B832-85FD-45B5-A32F-364CB0A72DCC}"/>
+                <a16:creationId xmlns:a16="http://schemas.microsoft.com/office/drawing/2014/main" id="{15B814A6-0B2B-462C-93B8-64572EB0ABB9}"/>
               </a:ext>
             </a:extLst>
           </p:cNvPr>
@@ -4865,7 +4865,7 @@
           <p:cNvPr id="9" name="">
             <a:extLst xmlns:a="http://schemas.openxmlformats.org/drawingml/2006/main">
               <a:ext uri="{FF2B5EF4-FFF2-40B4-BE49-F238E27FC236}">
-                <a16:creationId xmlns:a16="http://schemas.microsoft.com/office/drawing/2014/main" id="{B4488DA2-A6C4-4C2D-9014-784C379A3CAF}"/>
+                <a16:creationId xmlns:a16="http://schemas.microsoft.com/office/drawing/2014/main" id="{0A85D7C6-081B-48AA-BB7F-98A83218B665}"/>
               </a:ext>
             </a:extLst>
           </p:cNvPr>
@@ -4949,7 +4949,7 @@
           <p:cNvPr id="10" name="">
             <a:extLst xmlns:a="http://schemas.openxmlformats.org/drawingml/2006/main">
               <a:ext uri="{FF2B5EF4-FFF2-40B4-BE49-F238E27FC236}">
-                <a16:creationId xmlns:a16="http://schemas.microsoft.com/office/drawing/2014/main" id="{C1688C4B-3F34-4179-8838-22182DD10D4C}"/>
+                <a16:creationId xmlns:a16="http://schemas.microsoft.com/office/drawing/2014/main" id="{53C1FC16-480C-4ABE-A1CD-DE5AA47D5ED5}"/>
               </a:ext>
             </a:extLst>
           </p:cNvPr>
@@ -4984,7 +4984,7 @@
           <p:cNvPr id="11" name="">
             <a:extLst xmlns:a="http://schemas.openxmlformats.org/drawingml/2006/main">
               <a:ext uri="{FF2B5EF4-FFF2-40B4-BE49-F238E27FC236}">
-                <a16:creationId xmlns:a16="http://schemas.microsoft.com/office/drawing/2014/main" id="{755125CC-D9C2-467F-8D77-9CADAA4D662E}"/>
+                <a16:creationId xmlns:a16="http://schemas.microsoft.com/office/drawing/2014/main" id="{DB2E6908-C145-472E-94BF-3A22CAC821C9}"/>
               </a:ext>
             </a:extLst>
           </p:cNvPr>
@@ -5034,7 +5034,7 @@
           <p:cNvPr id="12" name="">
             <a:extLst xmlns:a="http://schemas.openxmlformats.org/drawingml/2006/main">
               <a:ext uri="{FF2B5EF4-FFF2-40B4-BE49-F238E27FC236}">
-                <a16:creationId xmlns:a16="http://schemas.microsoft.com/office/drawing/2014/main" id="{D38F5E87-6840-48C0-A79C-2A9F6AE0922D}"/>
+                <a16:creationId xmlns:a16="http://schemas.microsoft.com/office/drawing/2014/main" id="{64CF7B8D-BA00-48FC-B47B-5AE0BE99811D}"/>
               </a:ext>
             </a:extLst>
           </p:cNvPr>
@@ -5118,7 +5118,7 @@
           <p:cNvPr id="13" name="">
             <a:extLst xmlns:a="http://schemas.openxmlformats.org/drawingml/2006/main">
               <a:ext uri="{FF2B5EF4-FFF2-40B4-BE49-F238E27FC236}">
-                <a16:creationId xmlns:a16="http://schemas.microsoft.com/office/drawing/2014/main" id="{3C321DBB-F61B-49D5-A77F-662621D9ADAA}"/>
+                <a16:creationId xmlns:a16="http://schemas.microsoft.com/office/drawing/2014/main" id="{459D4F66-4106-40B1-89A0-CD85690870D3}"/>
               </a:ext>
             </a:extLst>
           </p:cNvPr>
@@ -5168,7 +5168,7 @@
           <p:cNvPr id="14" name="">
             <a:extLst xmlns:a="http://schemas.openxmlformats.org/drawingml/2006/main">
               <a:ext uri="{FF2B5EF4-FFF2-40B4-BE49-F238E27FC236}">
-                <a16:creationId xmlns:a16="http://schemas.microsoft.com/office/drawing/2014/main" id="{4DEF63C1-A79B-4E4D-BDCD-557B79BDAF43}"/>
+                <a16:creationId xmlns:a16="http://schemas.microsoft.com/office/drawing/2014/main" id="{CCAB29F8-3839-4C0F-85A6-EF612E0AEE63}"/>
               </a:ext>
             </a:extLst>
           </p:cNvPr>
@@ -5218,7 +5218,7 @@
           <p:cNvPr id="15" name="">
             <a:extLst xmlns:a="http://schemas.openxmlformats.org/drawingml/2006/main">
               <a:ext uri="{FF2B5EF4-FFF2-40B4-BE49-F238E27FC236}">
-                <a16:creationId xmlns:a16="http://schemas.microsoft.com/office/drawing/2014/main" id="{B4EF68C9-B267-403E-8EA2-CEED481E445F}"/>
+                <a16:creationId xmlns:a16="http://schemas.microsoft.com/office/drawing/2014/main" id="{DB18EA21-A7D1-4980-A9E7-4A63BBEF7AB7}"/>
               </a:ext>
             </a:extLst>
           </p:cNvPr>
@@ -5268,7 +5268,7 @@
           <p:cNvPr id="16" name="">
             <a:extLst xmlns:a="http://schemas.openxmlformats.org/drawingml/2006/main">
               <a:ext uri="{FF2B5EF4-FFF2-40B4-BE49-F238E27FC236}">
-                <a16:creationId xmlns:a16="http://schemas.microsoft.com/office/drawing/2014/main" id="{C526217C-013C-4180-87E7-830FD094FD78}"/>
+                <a16:creationId xmlns:a16="http://schemas.microsoft.com/office/drawing/2014/main" id="{0848CF01-F855-41C2-8DD6-1305F5F45694}"/>
               </a:ext>
             </a:extLst>
           </p:cNvPr>
@@ -5316,7 +5316,7 @@
     </p:spTree>
     <p:extLst>
       <p:ext uri="{BB962C8B-B14F-4D97-AF65-F5344CB8AC3E}">
-        <p14:creationId xmlns:p14="http://schemas.microsoft.com/office/powerpoint/2010/main" val="1732974834"/>
+        <p14:creationId xmlns:p14="http://schemas.microsoft.com/office/powerpoint/2010/main" val="920878667"/>
       </p:ext>
     </p:extLst>
   </p:cSld>
@@ -5347,7 +5347,7 @@
           <p:cNvPr id="13" name="">
             <a:extLst xmlns:a="http://schemas.openxmlformats.org/drawingml/2006/main">
               <a:ext uri="{FF2B5EF4-FFF2-40B4-BE49-F238E27FC236}">
-                <a16:creationId xmlns:a16="http://schemas.microsoft.com/office/drawing/2014/main" id="{C0FBF48C-D986-4A56-A13E-B10FADD0E817}"/>
+                <a16:creationId xmlns:a16="http://schemas.microsoft.com/office/drawing/2014/main" id="{A6E8BA05-0CDB-4D23-86C1-425EC01E2BC9}"/>
               </a:ext>
             </a:extLst>
           </p:cNvPr>
@@ -5397,7 +5397,7 @@
           <p:cNvPr id="2" name="">
             <a:extLst xmlns:a="http://schemas.openxmlformats.org/drawingml/2006/main">
               <a:ext uri="{FF2B5EF4-FFF2-40B4-BE49-F238E27FC236}">
-                <a16:creationId xmlns:a16="http://schemas.microsoft.com/office/drawing/2014/main" id="{44F424E7-6DED-43A2-8BE6-4F56457BC8BD}"/>
+                <a16:creationId xmlns:a16="http://schemas.microsoft.com/office/drawing/2014/main" id="{90A6B022-D8F4-4647-BB32-4DE80285351F}"/>
               </a:ext>
             </a:extLst>
           </p:cNvPr>
@@ -5447,7 +5447,7 @@
           <p:cNvPr id="3" name="">
             <a:extLst xmlns:a="http://schemas.openxmlformats.org/drawingml/2006/main">
               <a:ext uri="{FF2B5EF4-FFF2-40B4-BE49-F238E27FC236}">
-                <a16:creationId xmlns:a16="http://schemas.microsoft.com/office/drawing/2014/main" id="{2920036F-75DE-4586-B209-79390F1FCE2B}"/>
+                <a16:creationId xmlns:a16="http://schemas.microsoft.com/office/drawing/2014/main" id="{7DFCF1A7-FFB8-4992-8045-3166BD147A3C}"/>
               </a:ext>
             </a:extLst>
           </p:cNvPr>
@@ -5497,7 +5497,7 @@
           <p:cNvPr id="4" name="">
             <a:extLst xmlns:a="http://schemas.openxmlformats.org/drawingml/2006/main">
               <a:ext uri="{FF2B5EF4-FFF2-40B4-BE49-F238E27FC236}">
-                <a16:creationId xmlns:a16="http://schemas.microsoft.com/office/drawing/2014/main" id="{D82C53DC-5123-422C-966C-F017307A8C29}"/>
+                <a16:creationId xmlns:a16="http://schemas.microsoft.com/office/drawing/2014/main" id="{5066A03E-6442-4207-B2DD-2EA501880683}"/>
               </a:ext>
             </a:extLst>
           </p:cNvPr>
@@ -5532,7 +5532,7 @@
           <p:cNvPr id="5" name="">
             <a:extLst xmlns:a="http://schemas.openxmlformats.org/drawingml/2006/main">
               <a:ext uri="{FF2B5EF4-FFF2-40B4-BE49-F238E27FC236}">
-                <a16:creationId xmlns:a16="http://schemas.microsoft.com/office/drawing/2014/main" id="{5492C05F-7ADE-49E8-8C48-9589AC4282E3}"/>
+                <a16:creationId xmlns:a16="http://schemas.microsoft.com/office/drawing/2014/main" id="{4E46AC63-78D7-447D-87D0-848363AD5C3B}"/>
               </a:ext>
             </a:extLst>
           </p:cNvPr>
@@ -5582,7 +5582,7 @@
           <p:cNvPr id="6" name="">
             <a:extLst xmlns:a="http://schemas.openxmlformats.org/drawingml/2006/main">
               <a:ext uri="{FF2B5EF4-FFF2-40B4-BE49-F238E27FC236}">
-                <a16:creationId xmlns:a16="http://schemas.microsoft.com/office/drawing/2014/main" id="{ED3FBE4E-74D1-4033-8FF4-3F7C758668ED}"/>
+                <a16:creationId xmlns:a16="http://schemas.microsoft.com/office/drawing/2014/main" id="{2DC2E1B5-12EB-4A3F-9A02-F270F8205FEF}"/>
               </a:ext>
             </a:extLst>
           </p:cNvPr>
@@ -5683,7 +5683,7 @@
           <p:cNvPr id="7" name="">
             <a:extLst xmlns:a="http://schemas.openxmlformats.org/drawingml/2006/main">
               <a:ext uri="{FF2B5EF4-FFF2-40B4-BE49-F238E27FC236}">
-                <a16:creationId xmlns:a16="http://schemas.microsoft.com/office/drawing/2014/main" id="{194F03AC-19C0-4E38-9575-F0183955ED03}"/>
+                <a16:creationId xmlns:a16="http://schemas.microsoft.com/office/drawing/2014/main" id="{ECBDB7A5-B1A8-45EB-8E37-9123471651C0}"/>
               </a:ext>
             </a:extLst>
           </p:cNvPr>
@@ -5733,7 +5733,7 @@
           <p:cNvPr id="8" name="">
             <a:extLst xmlns:a="http://schemas.openxmlformats.org/drawingml/2006/main">
               <a:ext uri="{FF2B5EF4-FFF2-40B4-BE49-F238E27FC236}">
-                <a16:creationId xmlns:a16="http://schemas.microsoft.com/office/drawing/2014/main" id="{2FF72528-D052-4E38-AF9D-11AD55F5629E}"/>
+                <a16:creationId xmlns:a16="http://schemas.microsoft.com/office/drawing/2014/main" id="{05FA36E3-6A48-4166-97C7-70CEFD18AF3F}"/>
               </a:ext>
             </a:extLst>
           </p:cNvPr>
@@ -5783,7 +5783,7 @@
           <p:cNvPr id="9" name="">
             <a:extLst xmlns:a="http://schemas.openxmlformats.org/drawingml/2006/main">
               <a:ext uri="{FF2B5EF4-FFF2-40B4-BE49-F238E27FC236}">
-                <a16:creationId xmlns:a16="http://schemas.microsoft.com/office/drawing/2014/main" id="{1CE82FBE-06A9-445B-93C5-87960DFA7062}"/>
+                <a16:creationId xmlns:a16="http://schemas.microsoft.com/office/drawing/2014/main" id="{00A9AD05-0383-4CBF-8257-A0F947B61B43}"/>
               </a:ext>
             </a:extLst>
           </p:cNvPr>
@@ -5867,7 +5867,7 @@
           <p:cNvPr id="10" name="">
             <a:extLst xmlns:a="http://schemas.openxmlformats.org/drawingml/2006/main">
               <a:ext uri="{FF2B5EF4-FFF2-40B4-BE49-F238E27FC236}">
-                <a16:creationId xmlns:a16="http://schemas.microsoft.com/office/drawing/2014/main" id="{00C2D106-9DEB-4ACA-ACB9-4F239969CAD1}"/>
+                <a16:creationId xmlns:a16="http://schemas.microsoft.com/office/drawing/2014/main" id="{856C8A7D-4DB2-414B-903B-54B3D0589B20}"/>
               </a:ext>
             </a:extLst>
           </p:cNvPr>
@@ -5902,7 +5902,7 @@
           <p:cNvPr id="11" name="">
             <a:extLst xmlns:a="http://schemas.openxmlformats.org/drawingml/2006/main">
               <a:ext uri="{FF2B5EF4-FFF2-40B4-BE49-F238E27FC236}">
-                <a16:creationId xmlns:a16="http://schemas.microsoft.com/office/drawing/2014/main" id="{7D70D3CE-81AC-4484-ADA6-0A6B42A301C9}"/>
+                <a16:creationId xmlns:a16="http://schemas.microsoft.com/office/drawing/2014/main" id="{0CDB3665-84C4-4E05-82E1-D6889206BF42}"/>
               </a:ext>
             </a:extLst>
           </p:cNvPr>
@@ -5952,7 +5952,7 @@
           <p:cNvPr id="12" name="">
             <a:extLst xmlns:a="http://schemas.openxmlformats.org/drawingml/2006/main">
               <a:ext uri="{FF2B5EF4-FFF2-40B4-BE49-F238E27FC236}">
-                <a16:creationId xmlns:a16="http://schemas.microsoft.com/office/drawing/2014/main" id="{89BE7332-D2DE-4E56-BB63-3F83E394DF5E}"/>
+                <a16:creationId xmlns:a16="http://schemas.microsoft.com/office/drawing/2014/main" id="{E6248D1E-4571-41C2-BAD3-CF1FDE16269F}"/>
               </a:ext>
             </a:extLst>
           </p:cNvPr>
@@ -6000,7 +6000,7 @@
     </p:spTree>
     <p:extLst>
       <p:ext uri="{BB962C8B-B14F-4D97-AF65-F5344CB8AC3E}">
-        <p14:creationId xmlns:p14="http://schemas.microsoft.com/office/powerpoint/2010/main" val="1905176938"/>
+        <p14:creationId xmlns:p14="http://schemas.microsoft.com/office/powerpoint/2010/main" val="1338036393"/>
       </p:ext>
     </p:extLst>
   </p:cSld>
@@ -6031,7 +6031,7 @@
           <p:cNvPr id="8" name="">
             <a:extLst xmlns:a="http://schemas.openxmlformats.org/drawingml/2006/main">
               <a:ext uri="{FF2B5EF4-FFF2-40B4-BE49-F238E27FC236}">
-                <a16:creationId xmlns:a16="http://schemas.microsoft.com/office/drawing/2014/main" id="{3C2B9D35-4984-48C0-8333-E5758C321B4C}"/>
+                <a16:creationId xmlns:a16="http://schemas.microsoft.com/office/drawing/2014/main" id="{A56F1C97-27DD-490A-998A-18D58CFA9367}"/>
               </a:ext>
             </a:extLst>
           </p:cNvPr>
@@ -6081,7 +6081,7 @@
           <p:cNvPr id="2" name="">
             <a:extLst xmlns:a="http://schemas.openxmlformats.org/drawingml/2006/main">
               <a:ext uri="{FF2B5EF4-FFF2-40B4-BE49-F238E27FC236}">
-                <a16:creationId xmlns:a16="http://schemas.microsoft.com/office/drawing/2014/main" id="{36209492-F9A0-46FE-983C-505D930C95FE}"/>
+                <a16:creationId xmlns:a16="http://schemas.microsoft.com/office/drawing/2014/main" id="{01A1E6EB-0BF6-4200-918A-94C50052E2C0}"/>
               </a:ext>
             </a:extLst>
           </p:cNvPr>
@@ -6148,7 +6148,7 @@
           <p:cNvPr id="3" name="">
             <a:extLst xmlns:a="http://schemas.openxmlformats.org/drawingml/2006/main">
               <a:ext uri="{FF2B5EF4-FFF2-40B4-BE49-F238E27FC236}">
-                <a16:creationId xmlns:a16="http://schemas.microsoft.com/office/drawing/2014/main" id="{489B1E13-C8A1-4F53-AB31-3AF741AA878E}"/>
+                <a16:creationId xmlns:a16="http://schemas.microsoft.com/office/drawing/2014/main" id="{9D565098-9F47-46A5-A4EE-5126C5C5E26B}"/>
               </a:ext>
             </a:extLst>
           </p:cNvPr>
@@ -6183,7 +6183,7 @@
           <p:cNvPr id="4" name="">
             <a:extLst xmlns:a="http://schemas.openxmlformats.org/drawingml/2006/main">
               <a:ext uri="{FF2B5EF4-FFF2-40B4-BE49-F238E27FC236}">
-                <a16:creationId xmlns:a16="http://schemas.microsoft.com/office/drawing/2014/main" id="{50AF4243-ED00-4A0B-B7C4-BC2943866F8D}"/>
+                <a16:creationId xmlns:a16="http://schemas.microsoft.com/office/drawing/2014/main" id="{68BA5EF4-69A0-4022-9E98-4DC17FC1B846}"/>
               </a:ext>
             </a:extLst>
           </p:cNvPr>
@@ -6233,7 +6233,7 @@
           <p:cNvPr id="5" name="">
             <a:extLst xmlns:a="http://schemas.openxmlformats.org/drawingml/2006/main">
               <a:ext uri="{FF2B5EF4-FFF2-40B4-BE49-F238E27FC236}">
-                <a16:creationId xmlns:a16="http://schemas.microsoft.com/office/drawing/2014/main" id="{FC84D361-89F2-4C02-BBA3-21D605C83349}"/>
+                <a16:creationId xmlns:a16="http://schemas.microsoft.com/office/drawing/2014/main" id="{FFD6E062-30E6-4F51-AA06-E78A0122EEE4}"/>
               </a:ext>
             </a:extLst>
           </p:cNvPr>
@@ -6283,7 +6283,7 @@
           <p:cNvPr id="6" name="">
             <a:extLst xmlns:a="http://schemas.openxmlformats.org/drawingml/2006/main">
               <a:ext uri="{FF2B5EF4-FFF2-40B4-BE49-F238E27FC236}">
-                <a16:creationId xmlns:a16="http://schemas.microsoft.com/office/drawing/2014/main" id="{91CC9ADC-0CC3-489B-9638-8B1F5CF3EACF}"/>
+                <a16:creationId xmlns:a16="http://schemas.microsoft.com/office/drawing/2014/main" id="{53EC7D46-3D13-428E-95A1-65FA30A50CD4}"/>
               </a:ext>
             </a:extLst>
           </p:cNvPr>
@@ -6333,7 +6333,7 @@
           <p:cNvPr id="7" name="">
             <a:extLst xmlns:a="http://schemas.openxmlformats.org/drawingml/2006/main">
               <a:ext uri="{FF2B5EF4-FFF2-40B4-BE49-F238E27FC236}">
-                <a16:creationId xmlns:a16="http://schemas.microsoft.com/office/drawing/2014/main" id="{F8009C42-4338-4366-9FFC-906DC5EB6C67}"/>
+                <a16:creationId xmlns:a16="http://schemas.microsoft.com/office/drawing/2014/main" id="{677B91C9-4EC2-4210-BAF9-41D475683A0C}"/>
               </a:ext>
             </a:extLst>
           </p:cNvPr>
@@ -6381,7 +6381,7 @@
     </p:spTree>
     <p:extLst>
       <p:ext uri="{BB962C8B-B14F-4D97-AF65-F5344CB8AC3E}">
-        <p14:creationId xmlns:p14="http://schemas.microsoft.com/office/powerpoint/2010/main" val="625928038"/>
+        <p14:creationId xmlns:p14="http://schemas.microsoft.com/office/powerpoint/2010/main" val="1279958890"/>
       </p:ext>
     </p:extLst>
   </p:cSld>

</xml_diff>

<commit_message>
Simplify contest presentation narrative
</commit_message>
<xml_diff>
--- a/deliverables/subscription-cleaning-wanted-ai-championship-2026.pptx
+++ b/deliverables/subscription-cleaning-wanted-ai-championship-2026.pptx
@@ -2,19 +2,19 @@
 <file path=ppt/presentation.xml><?xml version="1.0" encoding="utf-8"?>
 <p:presentation xmlns:p="http://schemas.openxmlformats.org/presentationml/2006/main">
   <p:sldMasterIdLst>
-    <p:sldMasterId xmlns:r="http://schemas.openxmlformats.org/officeDocument/2006/relationships" id="2147483648" r:id="R6dcf5b94dbdc4ea0"/>
+    <p:sldMasterId xmlns:r="http://schemas.openxmlformats.org/officeDocument/2006/relationships" id="2147483648" r:id="R9b53734a8455465f"/>
   </p:sldMasterIdLst>
   <p:notesMasterIdLst>
-    <p:notesMasterId xmlns:r="http://schemas.openxmlformats.org/officeDocument/2006/relationships" r:id="R0ca3092269dd4ac8"/>
+    <p:notesMasterId xmlns:r="http://schemas.openxmlformats.org/officeDocument/2006/relationships" r:id="R2aa2896f999b4027"/>
   </p:notesMasterIdLst>
   <p:sldIdLst>
-    <p:sldId xmlns:r="http://schemas.openxmlformats.org/officeDocument/2006/relationships" id="256" r:id="Re3ccde61a013462f"/>
-    <p:sldId xmlns:r="http://schemas.openxmlformats.org/officeDocument/2006/relationships" id="257" r:id="R8cd9e3fbd3b5481a"/>
-    <p:sldId xmlns:r="http://schemas.openxmlformats.org/officeDocument/2006/relationships" id="258" r:id="R28ad3119010d41a2"/>
-    <p:sldId xmlns:r="http://schemas.openxmlformats.org/officeDocument/2006/relationships" id="259" r:id="R29c95dda49444da3"/>
-    <p:sldId xmlns:r="http://schemas.openxmlformats.org/officeDocument/2006/relationships" id="260" r:id="Rb6c235cf07084ff1"/>
-    <p:sldId xmlns:r="http://schemas.openxmlformats.org/officeDocument/2006/relationships" id="261" r:id="R907223f47bad49f2"/>
-    <p:sldId xmlns:r="http://schemas.openxmlformats.org/officeDocument/2006/relationships" id="262" r:id="R61715afb73b84256"/>
+    <p:sldId xmlns:r="http://schemas.openxmlformats.org/officeDocument/2006/relationships" id="256" r:id="R39c172f7de39451c"/>
+    <p:sldId xmlns:r="http://schemas.openxmlformats.org/officeDocument/2006/relationships" id="257" r:id="R691e820b9e4a4662"/>
+    <p:sldId xmlns:r="http://schemas.openxmlformats.org/officeDocument/2006/relationships" id="258" r:id="R2881423db3d9470b"/>
+    <p:sldId xmlns:r="http://schemas.openxmlformats.org/officeDocument/2006/relationships" id="259" r:id="R418385a968e84c9b"/>
+    <p:sldId xmlns:r="http://schemas.openxmlformats.org/officeDocument/2006/relationships" id="260" r:id="R1e18d7581f484c83"/>
+    <p:sldId xmlns:r="http://schemas.openxmlformats.org/officeDocument/2006/relationships" id="261" r:id="R13bc1fb7765947ab"/>
+    <p:sldId xmlns:r="http://schemas.openxmlformats.org/officeDocument/2006/relationships" id="262" r:id="R8bf0c40316aa4194"/>
   </p:sldIdLst>
   <p:sldSz cx="12192000" cy="6858000"/>
   <p:notesSz cx="6858000" cy="9144000"/>
@@ -808,7 +808,7 @@
           <a:lstStyle xmlns:a="http://schemas.openxmlformats.org/drawingml/2006/main"/>
           <a:p xmlns:a="http://schemas.openxmlformats.org/drawingml/2006/main">
             <a:r>
-              <a:t>AI 기능의 핵심은 데이터를 더 많이 보내는 것이 아니라, 필요한 정보만 구조화해서 보내는 것입니다. Google Gemini API 호출은 Vercel 서버 함수에서 수행하고, 연결이 없을 때도 시연 가능한 대체 설명을 둡니다.</a:t>
+              <a:t>실행 중 AI는 Google Gemini API입니다. 브라우저에서 결제내역을 먼저 정리하고, 사용자가 분석을 눌렀을 때 필요한 요약값만 한 번에 살펴봅니다. 반복 결제인 이유, 해지 우선순위, 월·1년 예상 절약액과 다음 행동을 알려줍니다. 원문과 민감정보는 보내지 않으며, 하루 7회 제한과 기본 분석 전환을 제공합니다.</a:t>
             </a:r>
           </a:p>
           <a:p xmlns:a="http://schemas.openxmlformats.org/drawingml/2006/main">
@@ -1111,7 +1111,7 @@
   </p:cSld>
   <p:clrMap bg1="lt1" tx1="dk1" bg2="lt2" tx2="dk2" accent1="accent1" accent2="accent2" accent3="accent3" accent4="accent4" accent5="accent5" accent6="accent6" hlink="hlink" folHlink="folHlink"/>
   <p:sldLayoutIdLst>
-    <p:sldLayoutId xmlns:r="http://schemas.openxmlformats.org/officeDocument/2006/relationships" id="2147483649" r:id="R4731c2f3785b47ea"/>
+    <p:sldLayoutId xmlns:r="http://schemas.openxmlformats.org/officeDocument/2006/relationships" id="2147483649" r:id="R5b5494a00c2c437e"/>
   </p:sldLayoutIdLst>
   <p:txStyles>
     <p:titleStyle>
@@ -1662,7 +1662,7 @@
           <p:cNvPr id="7" name="">
             <a:extLst xmlns:a="http://schemas.openxmlformats.org/drawingml/2006/main">
               <a:ext uri="{FF2B5EF4-FFF2-40B4-BE49-F238E27FC236}">
-                <a16:creationId xmlns:a16="http://schemas.microsoft.com/office/drawing/2014/main" id="{6720B29C-780D-4250-8E7D-B67BD69C73AF}"/>
+                <a16:creationId xmlns:a16="http://schemas.microsoft.com/office/drawing/2014/main" id="{E263E8E3-B30E-4547-99A0-3618DD532007}"/>
               </a:ext>
             </a:extLst>
           </p:cNvPr>
@@ -1695,7 +1695,7 @@
           <p:cNvPr id="2" name="">
             <a:extLst xmlns:a="http://schemas.openxmlformats.org/drawingml/2006/main">
               <a:ext uri="{FF2B5EF4-FFF2-40B4-BE49-F238E27FC236}">
-                <a16:creationId xmlns:a16="http://schemas.microsoft.com/office/drawing/2014/main" id="{4391A357-1B09-4CD2-B2BC-67FABB50923D}"/>
+                <a16:creationId xmlns:a16="http://schemas.microsoft.com/office/drawing/2014/main" id="{6C832CF1-2D34-47B4-AE48-7647E49280AB}"/>
               </a:ext>
             </a:extLst>
           </p:cNvPr>
@@ -1745,7 +1745,7 @@
           <p:cNvPr id="3" name="">
             <a:extLst xmlns:a="http://schemas.openxmlformats.org/drawingml/2006/main">
               <a:ext uri="{FF2B5EF4-FFF2-40B4-BE49-F238E27FC236}">
-                <a16:creationId xmlns:a16="http://schemas.microsoft.com/office/drawing/2014/main" id="{41CD4828-D037-4E28-B167-5A249F1E8D4B}"/>
+                <a16:creationId xmlns:a16="http://schemas.microsoft.com/office/drawing/2014/main" id="{7D64A216-BACF-4649-AB75-151A83913367}"/>
               </a:ext>
             </a:extLst>
           </p:cNvPr>
@@ -1812,7 +1812,7 @@
           <p:cNvPr id="4" name="">
             <a:extLst xmlns:a="http://schemas.openxmlformats.org/drawingml/2006/main">
               <a:ext uri="{FF2B5EF4-FFF2-40B4-BE49-F238E27FC236}">
-                <a16:creationId xmlns:a16="http://schemas.microsoft.com/office/drawing/2014/main" id="{762A57F0-F2AF-498B-959A-B77145C45BD6}"/>
+                <a16:creationId xmlns:a16="http://schemas.microsoft.com/office/drawing/2014/main" id="{461FF2B5-2D02-47A4-B107-49A20949A69C}"/>
               </a:ext>
             </a:extLst>
           </p:cNvPr>
@@ -1862,7 +1862,7 @@
           <p:cNvPr id="5" name="">
             <a:extLst xmlns:a="http://schemas.openxmlformats.org/drawingml/2006/main">
               <a:ext uri="{FF2B5EF4-FFF2-40B4-BE49-F238E27FC236}">
-                <a16:creationId xmlns:a16="http://schemas.microsoft.com/office/drawing/2014/main" id="{217990E8-31D8-4BC9-912D-AFCC12400E1D}"/>
+                <a16:creationId xmlns:a16="http://schemas.microsoft.com/office/drawing/2014/main" id="{AFA9F50D-85E8-440E-B804-B058C39376D0}"/>
               </a:ext>
             </a:extLst>
           </p:cNvPr>
@@ -1901,7 +1901,7 @@
           <p:nvPr/>
         </p:nvPicPr>
         <p:blipFill>
-          <a:blip xmlns:r="http://schemas.openxmlformats.org/officeDocument/2006/relationships" xmlns:a="http://schemas.openxmlformats.org/drawingml/2006/main" r:embed="Rcd2a167556e64c26"/>
+          <a:blip xmlns:r="http://schemas.openxmlformats.org/officeDocument/2006/relationships" xmlns:a="http://schemas.openxmlformats.org/drawingml/2006/main" r:embed="Rba95b09c678d47d5"/>
           <a:stretch xmlns:a="http://schemas.openxmlformats.org/drawingml/2006/main"/>
         </p:blipFill>
         <p:spPr>
@@ -1919,7 +1919,7 @@
     </p:spTree>
     <p:extLst>
       <p:ext uri="{BB962C8B-B14F-4D97-AF65-F5344CB8AC3E}">
-        <p14:creationId xmlns:p14="http://schemas.microsoft.com/office/powerpoint/2010/main" val="1760497975"/>
+        <p14:creationId xmlns:p14="http://schemas.microsoft.com/office/powerpoint/2010/main" val="1241730328"/>
       </p:ext>
     </p:extLst>
   </p:cSld>
@@ -1950,7 +1950,7 @@
           <p:cNvPr id="15" name="">
             <a:extLst xmlns:a="http://schemas.openxmlformats.org/drawingml/2006/main">
               <a:ext uri="{FF2B5EF4-FFF2-40B4-BE49-F238E27FC236}">
-                <a16:creationId xmlns:a16="http://schemas.microsoft.com/office/drawing/2014/main" id="{712AACC6-6F9F-4A22-9100-41D12DFF867D}"/>
+                <a16:creationId xmlns:a16="http://schemas.microsoft.com/office/drawing/2014/main" id="{3DABB559-FD84-4E28-B744-9F48F541DA07}"/>
               </a:ext>
             </a:extLst>
           </p:cNvPr>
@@ -2000,7 +2000,7 @@
           <p:cNvPr id="2" name="">
             <a:extLst xmlns:a="http://schemas.openxmlformats.org/drawingml/2006/main">
               <a:ext uri="{FF2B5EF4-FFF2-40B4-BE49-F238E27FC236}">
-                <a16:creationId xmlns:a16="http://schemas.microsoft.com/office/drawing/2014/main" id="{78C36A20-D03D-4ADA-BB54-B707F044E4E8}"/>
+                <a16:creationId xmlns:a16="http://schemas.microsoft.com/office/drawing/2014/main" id="{A1158D78-71EC-49E8-B061-242D28FAAF78}"/>
               </a:ext>
             </a:extLst>
           </p:cNvPr>
@@ -2050,7 +2050,7 @@
           <p:cNvPr id="3" name="">
             <a:extLst xmlns:a="http://schemas.openxmlformats.org/drawingml/2006/main">
               <a:ext uri="{FF2B5EF4-FFF2-40B4-BE49-F238E27FC236}">
-                <a16:creationId xmlns:a16="http://schemas.microsoft.com/office/drawing/2014/main" id="{AA48F61F-BF92-4F66-849E-F2228DC85CD1}"/>
+                <a16:creationId xmlns:a16="http://schemas.microsoft.com/office/drawing/2014/main" id="{DDC4A5F4-94CB-48B4-B39D-80ED3B38DEB1}"/>
               </a:ext>
             </a:extLst>
           </p:cNvPr>
@@ -2100,7 +2100,7 @@
           <p:cNvPr id="4" name="">
             <a:extLst xmlns:a="http://schemas.openxmlformats.org/drawingml/2006/main">
               <a:ext uri="{FF2B5EF4-FFF2-40B4-BE49-F238E27FC236}">
-                <a16:creationId xmlns:a16="http://schemas.microsoft.com/office/drawing/2014/main" id="{A4AD3826-3CC7-415B-8886-158713CFCD33}"/>
+                <a16:creationId xmlns:a16="http://schemas.microsoft.com/office/drawing/2014/main" id="{DD01FDD2-4F44-4B0F-A7A6-FA2154637C91}"/>
               </a:ext>
             </a:extLst>
           </p:cNvPr>
@@ -2167,7 +2167,7 @@
           <p:cNvPr id="5" name="">
             <a:extLst xmlns:a="http://schemas.openxmlformats.org/drawingml/2006/main">
               <a:ext uri="{FF2B5EF4-FFF2-40B4-BE49-F238E27FC236}">
-                <a16:creationId xmlns:a16="http://schemas.microsoft.com/office/drawing/2014/main" id="{23F09404-76C8-4EFE-81C8-4D23C0CCF959}"/>
+                <a16:creationId xmlns:a16="http://schemas.microsoft.com/office/drawing/2014/main" id="{85DFA77C-7C2F-46D2-ABD0-84A18638A047}"/>
               </a:ext>
             </a:extLst>
           </p:cNvPr>
@@ -2202,7 +2202,7 @@
           <p:cNvPr id="6" name="">
             <a:extLst xmlns:a="http://schemas.openxmlformats.org/drawingml/2006/main">
               <a:ext uri="{FF2B5EF4-FFF2-40B4-BE49-F238E27FC236}">
-                <a16:creationId xmlns:a16="http://schemas.microsoft.com/office/drawing/2014/main" id="{86874324-E733-443E-B696-D805DDCDF337}"/>
+                <a16:creationId xmlns:a16="http://schemas.microsoft.com/office/drawing/2014/main" id="{6584DE16-7162-486B-87FB-D2D7D2566C34}"/>
               </a:ext>
             </a:extLst>
           </p:cNvPr>
@@ -2252,7 +2252,7 @@
           <p:cNvPr id="7" name="">
             <a:extLst xmlns:a="http://schemas.openxmlformats.org/drawingml/2006/main">
               <a:ext uri="{FF2B5EF4-FFF2-40B4-BE49-F238E27FC236}">
-                <a16:creationId xmlns:a16="http://schemas.microsoft.com/office/drawing/2014/main" id="{84B71145-F665-42C2-83AA-769517033098}"/>
+                <a16:creationId xmlns:a16="http://schemas.microsoft.com/office/drawing/2014/main" id="{53F2306A-13B3-46E4-A423-6E83A9787CDF}"/>
               </a:ext>
             </a:extLst>
           </p:cNvPr>
@@ -2336,7 +2336,7 @@
           <p:cNvPr id="8" name="">
             <a:extLst xmlns:a="http://schemas.openxmlformats.org/drawingml/2006/main">
               <a:ext uri="{FF2B5EF4-FFF2-40B4-BE49-F238E27FC236}">
-                <a16:creationId xmlns:a16="http://schemas.microsoft.com/office/drawing/2014/main" id="{6215D563-517D-4FD9-9AD7-45036BF0908A}"/>
+                <a16:creationId xmlns:a16="http://schemas.microsoft.com/office/drawing/2014/main" id="{E020217C-9048-4D54-A960-FA8235EE3B20}"/>
               </a:ext>
             </a:extLst>
           </p:cNvPr>
@@ -2371,7 +2371,7 @@
           <p:cNvPr id="9" name="">
             <a:extLst xmlns:a="http://schemas.openxmlformats.org/drawingml/2006/main">
               <a:ext uri="{FF2B5EF4-FFF2-40B4-BE49-F238E27FC236}">
-                <a16:creationId xmlns:a16="http://schemas.microsoft.com/office/drawing/2014/main" id="{FBB4B719-108F-4299-A324-FD2C151BB9C1}"/>
+                <a16:creationId xmlns:a16="http://schemas.microsoft.com/office/drawing/2014/main" id="{C916CFAA-B8FE-4A5C-9595-A0D802FDA1E2}"/>
               </a:ext>
             </a:extLst>
           </p:cNvPr>
@@ -2421,7 +2421,7 @@
           <p:cNvPr id="10" name="">
             <a:extLst xmlns:a="http://schemas.openxmlformats.org/drawingml/2006/main">
               <a:ext uri="{FF2B5EF4-FFF2-40B4-BE49-F238E27FC236}">
-                <a16:creationId xmlns:a16="http://schemas.microsoft.com/office/drawing/2014/main" id="{9C117FB8-BB73-4858-B9C6-FE5DE135211F}"/>
+                <a16:creationId xmlns:a16="http://schemas.microsoft.com/office/drawing/2014/main" id="{0AF0F694-AE52-4115-8C92-9F0ACA20AE6F}"/>
               </a:ext>
             </a:extLst>
           </p:cNvPr>
@@ -2505,7 +2505,7 @@
           <p:cNvPr id="11" name="">
             <a:extLst xmlns:a="http://schemas.openxmlformats.org/drawingml/2006/main">
               <a:ext uri="{FF2B5EF4-FFF2-40B4-BE49-F238E27FC236}">
-                <a16:creationId xmlns:a16="http://schemas.microsoft.com/office/drawing/2014/main" id="{401154CE-D7E9-48C8-83AA-CFE4BAE36D4D}"/>
+                <a16:creationId xmlns:a16="http://schemas.microsoft.com/office/drawing/2014/main" id="{3285EE7C-6B47-4EC8-91BC-12B0CE7D1AAB}"/>
               </a:ext>
             </a:extLst>
           </p:cNvPr>
@@ -2540,7 +2540,7 @@
           <p:cNvPr id="12" name="">
             <a:extLst xmlns:a="http://schemas.openxmlformats.org/drawingml/2006/main">
               <a:ext uri="{FF2B5EF4-FFF2-40B4-BE49-F238E27FC236}">
-                <a16:creationId xmlns:a16="http://schemas.microsoft.com/office/drawing/2014/main" id="{6DC24753-7062-423C-AE78-AEFE33781FA4}"/>
+                <a16:creationId xmlns:a16="http://schemas.microsoft.com/office/drawing/2014/main" id="{CFD7D46A-18CE-4EFA-9C76-A4DDD623A4F4}"/>
               </a:ext>
             </a:extLst>
           </p:cNvPr>
@@ -2590,7 +2590,7 @@
           <p:cNvPr id="13" name="">
             <a:extLst xmlns:a="http://schemas.openxmlformats.org/drawingml/2006/main">
               <a:ext uri="{FF2B5EF4-FFF2-40B4-BE49-F238E27FC236}">
-                <a16:creationId xmlns:a16="http://schemas.microsoft.com/office/drawing/2014/main" id="{C6084909-8C84-421F-A223-A719F91D7163}"/>
+                <a16:creationId xmlns:a16="http://schemas.microsoft.com/office/drawing/2014/main" id="{DBC3769B-83F9-4F19-8E20-E5A18B4D8F83}"/>
               </a:ext>
             </a:extLst>
           </p:cNvPr>
@@ -2674,7 +2674,7 @@
           <p:cNvPr id="14" name="">
             <a:extLst xmlns:a="http://schemas.openxmlformats.org/drawingml/2006/main">
               <a:ext uri="{FF2B5EF4-FFF2-40B4-BE49-F238E27FC236}">
-                <a16:creationId xmlns:a16="http://schemas.microsoft.com/office/drawing/2014/main" id="{CF480522-8D47-415E-8494-4C647E9DE973}"/>
+                <a16:creationId xmlns:a16="http://schemas.microsoft.com/office/drawing/2014/main" id="{93A78032-4C20-462D-9E50-027635CCD1EE}"/>
               </a:ext>
             </a:extLst>
           </p:cNvPr>
@@ -2722,7 +2722,7 @@
     </p:spTree>
     <p:extLst>
       <p:ext uri="{BB962C8B-B14F-4D97-AF65-F5344CB8AC3E}">
-        <p14:creationId xmlns:p14="http://schemas.microsoft.com/office/powerpoint/2010/main" val="6740676"/>
+        <p14:creationId xmlns:p14="http://schemas.microsoft.com/office/powerpoint/2010/main" val="1100279066"/>
       </p:ext>
     </p:extLst>
   </p:cSld>
@@ -2753,7 +2753,7 @@
           <p:cNvPr id="25" name="">
             <a:extLst xmlns:a="http://schemas.openxmlformats.org/drawingml/2006/main">
               <a:ext uri="{FF2B5EF4-FFF2-40B4-BE49-F238E27FC236}">
-                <a16:creationId xmlns:a16="http://schemas.microsoft.com/office/drawing/2014/main" id="{E344675C-D37A-4618-BDEB-972636ADD24D}"/>
+                <a16:creationId xmlns:a16="http://schemas.microsoft.com/office/drawing/2014/main" id="{9B12C5B1-82FE-47D6-8644-4B4A87017F86}"/>
               </a:ext>
             </a:extLst>
           </p:cNvPr>
@@ -2803,7 +2803,7 @@
           <p:cNvPr id="2" name="">
             <a:extLst xmlns:a="http://schemas.openxmlformats.org/drawingml/2006/main">
               <a:ext uri="{FF2B5EF4-FFF2-40B4-BE49-F238E27FC236}">
-                <a16:creationId xmlns:a16="http://schemas.microsoft.com/office/drawing/2014/main" id="{FF1FB69D-8996-421B-9433-9641AF96C64E}"/>
+                <a16:creationId xmlns:a16="http://schemas.microsoft.com/office/drawing/2014/main" id="{92B85212-FCB4-4B2D-A59A-1DD66E6157D9}"/>
               </a:ext>
             </a:extLst>
           </p:cNvPr>
@@ -2853,7 +2853,7 @@
           <p:cNvPr id="3" name="">
             <a:extLst xmlns:a="http://schemas.openxmlformats.org/drawingml/2006/main">
               <a:ext uri="{FF2B5EF4-FFF2-40B4-BE49-F238E27FC236}">
-                <a16:creationId xmlns:a16="http://schemas.microsoft.com/office/drawing/2014/main" id="{68060708-58B8-4E56-81C9-D17ECB46026F}"/>
+                <a16:creationId xmlns:a16="http://schemas.microsoft.com/office/drawing/2014/main" id="{94803A7B-B61E-4512-B499-09D9F9A6FB36}"/>
               </a:ext>
             </a:extLst>
           </p:cNvPr>
@@ -2903,7 +2903,7 @@
           <p:cNvPr id="4" name="">
             <a:extLst xmlns:a="http://schemas.openxmlformats.org/drawingml/2006/main">
               <a:ext uri="{FF2B5EF4-FFF2-40B4-BE49-F238E27FC236}">
-                <a16:creationId xmlns:a16="http://schemas.microsoft.com/office/drawing/2014/main" id="{6B9B9235-FF0C-4268-A2F8-CBCDDAC30FA6}"/>
+                <a16:creationId xmlns:a16="http://schemas.microsoft.com/office/drawing/2014/main" id="{F1E71731-96E8-44AF-9B55-66E75F6E2434}"/>
               </a:ext>
             </a:extLst>
           </p:cNvPr>
@@ -2936,7 +2936,7 @@
           <p:cNvPr id="5" name="">
             <a:extLst xmlns:a="http://schemas.openxmlformats.org/drawingml/2006/main">
               <a:ext uri="{FF2B5EF4-FFF2-40B4-BE49-F238E27FC236}">
-                <a16:creationId xmlns:a16="http://schemas.microsoft.com/office/drawing/2014/main" id="{9505C923-7D9B-4CB0-B1B0-04E621B4756B}"/>
+                <a16:creationId xmlns:a16="http://schemas.microsoft.com/office/drawing/2014/main" id="{4591E979-829C-4BDF-936E-8F1F96ED2DE2}"/>
               </a:ext>
             </a:extLst>
           </p:cNvPr>
@@ -2971,7 +2971,7 @@
           <p:cNvPr id="6" name="">
             <a:extLst xmlns:a="http://schemas.openxmlformats.org/drawingml/2006/main">
               <a:ext uri="{FF2B5EF4-FFF2-40B4-BE49-F238E27FC236}">
-                <a16:creationId xmlns:a16="http://schemas.microsoft.com/office/drawing/2014/main" id="{FF56193D-C5A1-4030-AC0B-10BF4E3DCA33}"/>
+                <a16:creationId xmlns:a16="http://schemas.microsoft.com/office/drawing/2014/main" id="{C7C01EB6-599E-4F99-BD47-9F0D180A5DA9}"/>
               </a:ext>
             </a:extLst>
           </p:cNvPr>
@@ -3021,7 +3021,7 @@
           <p:cNvPr id="7" name="">
             <a:extLst xmlns:a="http://schemas.openxmlformats.org/drawingml/2006/main">
               <a:ext uri="{FF2B5EF4-FFF2-40B4-BE49-F238E27FC236}">
-                <a16:creationId xmlns:a16="http://schemas.microsoft.com/office/drawing/2014/main" id="{D7ADC147-78B2-424D-AA79-424D98523BB8}"/>
+                <a16:creationId xmlns:a16="http://schemas.microsoft.com/office/drawing/2014/main" id="{8118AC76-0892-4D68-A43B-2B4938A87A81}"/>
               </a:ext>
             </a:extLst>
           </p:cNvPr>
@@ -3071,7 +3071,7 @@
           <p:cNvPr id="8" name="">
             <a:extLst xmlns:a="http://schemas.openxmlformats.org/drawingml/2006/main">
               <a:ext uri="{FF2B5EF4-FFF2-40B4-BE49-F238E27FC236}">
-                <a16:creationId xmlns:a16="http://schemas.microsoft.com/office/drawing/2014/main" id="{75BF7026-AB8D-4A1D-90B3-8639871CF44B}"/>
+                <a16:creationId xmlns:a16="http://schemas.microsoft.com/office/drawing/2014/main" id="{B0DD54C7-EE24-497B-96CE-D19527EB284A}"/>
               </a:ext>
             </a:extLst>
           </p:cNvPr>
@@ -3121,7 +3121,7 @@
           <p:cNvPr id="9" name="">
             <a:extLst xmlns:a="http://schemas.openxmlformats.org/drawingml/2006/main">
               <a:ext uri="{FF2B5EF4-FFF2-40B4-BE49-F238E27FC236}">
-                <a16:creationId xmlns:a16="http://schemas.microsoft.com/office/drawing/2014/main" id="{3DCAF233-848F-44BD-AE7B-E8ED00227253}"/>
+                <a16:creationId xmlns:a16="http://schemas.microsoft.com/office/drawing/2014/main" id="{1C2C2473-0DDF-4A51-AF4F-E15115050955}"/>
               </a:ext>
             </a:extLst>
           </p:cNvPr>
@@ -3154,7 +3154,7 @@
           <p:cNvPr id="10" name="">
             <a:extLst xmlns:a="http://schemas.openxmlformats.org/drawingml/2006/main">
               <a:ext uri="{FF2B5EF4-FFF2-40B4-BE49-F238E27FC236}">
-                <a16:creationId xmlns:a16="http://schemas.microsoft.com/office/drawing/2014/main" id="{23A77495-DB7A-436B-B821-801F89C1FC18}"/>
+                <a16:creationId xmlns:a16="http://schemas.microsoft.com/office/drawing/2014/main" id="{2BB7DA15-6A33-450F-8FD9-BEA2B405F539}"/>
               </a:ext>
             </a:extLst>
           </p:cNvPr>
@@ -3189,7 +3189,7 @@
           <p:cNvPr id="11" name="">
             <a:extLst xmlns:a="http://schemas.openxmlformats.org/drawingml/2006/main">
               <a:ext uri="{FF2B5EF4-FFF2-40B4-BE49-F238E27FC236}">
-                <a16:creationId xmlns:a16="http://schemas.microsoft.com/office/drawing/2014/main" id="{4126AE48-0208-4AE2-B1E3-9A211B8CB47D}"/>
+                <a16:creationId xmlns:a16="http://schemas.microsoft.com/office/drawing/2014/main" id="{C46CF5CF-89EA-46D6-B0EA-978886F71AEE}"/>
               </a:ext>
             </a:extLst>
           </p:cNvPr>
@@ -3239,7 +3239,7 @@
           <p:cNvPr id="12" name="">
             <a:extLst xmlns:a="http://schemas.openxmlformats.org/drawingml/2006/main">
               <a:ext uri="{FF2B5EF4-FFF2-40B4-BE49-F238E27FC236}">
-                <a16:creationId xmlns:a16="http://schemas.microsoft.com/office/drawing/2014/main" id="{02E0A50C-00C6-4E5B-9653-F7EE9AA341F5}"/>
+                <a16:creationId xmlns:a16="http://schemas.microsoft.com/office/drawing/2014/main" id="{FEA60502-B31A-4AC2-B84D-11531F050269}"/>
               </a:ext>
             </a:extLst>
           </p:cNvPr>
@@ -3289,7 +3289,7 @@
           <p:cNvPr id="13" name="">
             <a:extLst xmlns:a="http://schemas.openxmlformats.org/drawingml/2006/main">
               <a:ext uri="{FF2B5EF4-FFF2-40B4-BE49-F238E27FC236}">
-                <a16:creationId xmlns:a16="http://schemas.microsoft.com/office/drawing/2014/main" id="{E8E7D4D7-BC86-473F-8517-C7ED430B65FF}"/>
+                <a16:creationId xmlns:a16="http://schemas.microsoft.com/office/drawing/2014/main" id="{D423190E-945F-4927-A78B-7F6A30651FE7}"/>
               </a:ext>
             </a:extLst>
           </p:cNvPr>
@@ -3339,7 +3339,7 @@
           <p:cNvPr id="14" name="">
             <a:extLst xmlns:a="http://schemas.openxmlformats.org/drawingml/2006/main">
               <a:ext uri="{FF2B5EF4-FFF2-40B4-BE49-F238E27FC236}">
-                <a16:creationId xmlns:a16="http://schemas.microsoft.com/office/drawing/2014/main" id="{49B7960C-D661-4203-80FF-56AE0D144D3E}"/>
+                <a16:creationId xmlns:a16="http://schemas.microsoft.com/office/drawing/2014/main" id="{AB102E4C-DF01-43E7-A924-9B39A8717AEB}"/>
               </a:ext>
             </a:extLst>
           </p:cNvPr>
@@ -3372,7 +3372,7 @@
           <p:cNvPr id="15" name="">
             <a:extLst xmlns:a="http://schemas.openxmlformats.org/drawingml/2006/main">
               <a:ext uri="{FF2B5EF4-FFF2-40B4-BE49-F238E27FC236}">
-                <a16:creationId xmlns:a16="http://schemas.microsoft.com/office/drawing/2014/main" id="{951FE632-C6A9-4434-A435-7F125A600434}"/>
+                <a16:creationId xmlns:a16="http://schemas.microsoft.com/office/drawing/2014/main" id="{AEED0FB4-A24C-46FC-A459-7713338C5EB1}"/>
               </a:ext>
             </a:extLst>
           </p:cNvPr>
@@ -3407,7 +3407,7 @@
           <p:cNvPr id="16" name="">
             <a:extLst xmlns:a="http://schemas.openxmlformats.org/drawingml/2006/main">
               <a:ext uri="{FF2B5EF4-FFF2-40B4-BE49-F238E27FC236}">
-                <a16:creationId xmlns:a16="http://schemas.microsoft.com/office/drawing/2014/main" id="{AA487B30-19F8-4B14-B85D-D98EC6733EC9}"/>
+                <a16:creationId xmlns:a16="http://schemas.microsoft.com/office/drawing/2014/main" id="{1E08BC14-1178-4CC4-ACD9-9AF81439C65B}"/>
               </a:ext>
             </a:extLst>
           </p:cNvPr>
@@ -3457,7 +3457,7 @@
           <p:cNvPr id="17" name="">
             <a:extLst xmlns:a="http://schemas.openxmlformats.org/drawingml/2006/main">
               <a:ext uri="{FF2B5EF4-FFF2-40B4-BE49-F238E27FC236}">
-                <a16:creationId xmlns:a16="http://schemas.microsoft.com/office/drawing/2014/main" id="{40F454F4-CDCE-497D-AA01-F5E51D1ABA02}"/>
+                <a16:creationId xmlns:a16="http://schemas.microsoft.com/office/drawing/2014/main" id="{F5552EFF-4F57-4AAE-8188-E30D358949AC}"/>
               </a:ext>
             </a:extLst>
           </p:cNvPr>
@@ -3507,7 +3507,7 @@
           <p:cNvPr id="18" name="">
             <a:extLst xmlns:a="http://schemas.openxmlformats.org/drawingml/2006/main">
               <a:ext uri="{FF2B5EF4-FFF2-40B4-BE49-F238E27FC236}">
-                <a16:creationId xmlns:a16="http://schemas.microsoft.com/office/drawing/2014/main" id="{2139CCC6-36E4-4352-A281-1742D43D84E4}"/>
+                <a16:creationId xmlns:a16="http://schemas.microsoft.com/office/drawing/2014/main" id="{C71C4655-F397-4625-A26B-6B0FDC54BDAA}"/>
               </a:ext>
             </a:extLst>
           </p:cNvPr>
@@ -3557,7 +3557,7 @@
           <p:cNvPr id="19" name="">
             <a:extLst xmlns:a="http://schemas.openxmlformats.org/drawingml/2006/main">
               <a:ext uri="{FF2B5EF4-FFF2-40B4-BE49-F238E27FC236}">
-                <a16:creationId xmlns:a16="http://schemas.microsoft.com/office/drawing/2014/main" id="{012A5A41-1073-4D83-9D4E-62D184016880}"/>
+                <a16:creationId xmlns:a16="http://schemas.microsoft.com/office/drawing/2014/main" id="{E6FDE977-2E9D-4EE0-AD66-72CFFFAC6613}"/>
               </a:ext>
             </a:extLst>
           </p:cNvPr>
@@ -3592,7 +3592,7 @@
           <p:cNvPr id="20" name="">
             <a:extLst xmlns:a="http://schemas.openxmlformats.org/drawingml/2006/main">
               <a:ext uri="{FF2B5EF4-FFF2-40B4-BE49-F238E27FC236}">
-                <a16:creationId xmlns:a16="http://schemas.microsoft.com/office/drawing/2014/main" id="{0CEB6B3B-0853-4D2F-9C42-4DA9E6E310E7}"/>
+                <a16:creationId xmlns:a16="http://schemas.microsoft.com/office/drawing/2014/main" id="{4F3B27D5-D41C-4A1C-9974-A78D010FDC86}"/>
               </a:ext>
             </a:extLst>
           </p:cNvPr>
@@ -3642,7 +3642,7 @@
           <p:cNvPr id="21" name="">
             <a:extLst xmlns:a="http://schemas.openxmlformats.org/drawingml/2006/main">
               <a:ext uri="{FF2B5EF4-FFF2-40B4-BE49-F238E27FC236}">
-                <a16:creationId xmlns:a16="http://schemas.microsoft.com/office/drawing/2014/main" id="{03820BBA-C80B-437B-B2CC-9B9E69D60DCF}"/>
+                <a16:creationId xmlns:a16="http://schemas.microsoft.com/office/drawing/2014/main" id="{F1135B5C-2BAF-4985-B0AB-473ACDA42DA7}"/>
               </a:ext>
             </a:extLst>
           </p:cNvPr>
@@ -3692,7 +3692,7 @@
           <p:cNvPr id="22" name="">
             <a:extLst xmlns:a="http://schemas.openxmlformats.org/drawingml/2006/main">
               <a:ext uri="{FF2B5EF4-FFF2-40B4-BE49-F238E27FC236}">
-                <a16:creationId xmlns:a16="http://schemas.microsoft.com/office/drawing/2014/main" id="{D1758A19-9891-4DAA-9E01-2BD8E97DB3CF}"/>
+                <a16:creationId xmlns:a16="http://schemas.microsoft.com/office/drawing/2014/main" id="{218B7957-182F-4E26-BBE4-188760DF4BAC}"/>
               </a:ext>
             </a:extLst>
           </p:cNvPr>
@@ -3742,7 +3742,7 @@
           <p:cNvPr id="23" name="">
             <a:extLst xmlns:a="http://schemas.openxmlformats.org/drawingml/2006/main">
               <a:ext uri="{FF2B5EF4-FFF2-40B4-BE49-F238E27FC236}">
-                <a16:creationId xmlns:a16="http://schemas.microsoft.com/office/drawing/2014/main" id="{F4092D96-EF20-4D3E-970A-4126FEE1CE21}"/>
+                <a16:creationId xmlns:a16="http://schemas.microsoft.com/office/drawing/2014/main" id="{7877AA7B-B3F1-4480-95B6-D1204278095A}"/>
               </a:ext>
             </a:extLst>
           </p:cNvPr>
@@ -3792,7 +3792,7 @@
           <p:cNvPr id="24" name="">
             <a:extLst xmlns:a="http://schemas.openxmlformats.org/drawingml/2006/main">
               <a:ext uri="{FF2B5EF4-FFF2-40B4-BE49-F238E27FC236}">
-                <a16:creationId xmlns:a16="http://schemas.microsoft.com/office/drawing/2014/main" id="{B81FC09D-48A7-4555-A61D-5016F03AC3D0}"/>
+                <a16:creationId xmlns:a16="http://schemas.microsoft.com/office/drawing/2014/main" id="{FBC40B0C-171D-4662-9B80-27735B826236}"/>
               </a:ext>
             </a:extLst>
           </p:cNvPr>
@@ -3840,7 +3840,7 @@
     </p:spTree>
     <p:extLst>
       <p:ext uri="{BB962C8B-B14F-4D97-AF65-F5344CB8AC3E}">
-        <p14:creationId xmlns:p14="http://schemas.microsoft.com/office/powerpoint/2010/main" val="1021574056"/>
+        <p14:creationId xmlns:p14="http://schemas.microsoft.com/office/powerpoint/2010/main" val="825134197"/>
       </p:ext>
     </p:extLst>
   </p:cSld>
@@ -3871,7 +3871,7 @@
           <p:cNvPr id="13" name="">
             <a:extLst xmlns:a="http://schemas.openxmlformats.org/drawingml/2006/main">
               <a:ext uri="{FF2B5EF4-FFF2-40B4-BE49-F238E27FC236}">
-                <a16:creationId xmlns:a16="http://schemas.microsoft.com/office/drawing/2014/main" id="{3AE24E54-EEC6-4792-BCF2-0FBA9A5226CF}"/>
+                <a16:creationId xmlns:a16="http://schemas.microsoft.com/office/drawing/2014/main" id="{565F348E-BCE5-46E4-AB04-CF0380FAE767}"/>
               </a:ext>
             </a:extLst>
           </p:cNvPr>
@@ -3921,7 +3921,7 @@
           <p:cNvPr id="2" name="">
             <a:extLst xmlns:a="http://schemas.openxmlformats.org/drawingml/2006/main">
               <a:ext uri="{FF2B5EF4-FFF2-40B4-BE49-F238E27FC236}">
-                <a16:creationId xmlns:a16="http://schemas.microsoft.com/office/drawing/2014/main" id="{E71A9FF1-0D14-47D4-8A18-2DC335F107FF}"/>
+                <a16:creationId xmlns:a16="http://schemas.microsoft.com/office/drawing/2014/main" id="{24180178-E7BF-48E2-B423-FED5F275E5B1}"/>
               </a:ext>
             </a:extLst>
           </p:cNvPr>
@@ -3971,7 +3971,7 @@
           <p:cNvPr id="3" name="">
             <a:extLst xmlns:a="http://schemas.openxmlformats.org/drawingml/2006/main">
               <a:ext uri="{FF2B5EF4-FFF2-40B4-BE49-F238E27FC236}">
-                <a16:creationId xmlns:a16="http://schemas.microsoft.com/office/drawing/2014/main" id="{8C22F8B7-FA15-4314-960D-7CC84B99544F}"/>
+                <a16:creationId xmlns:a16="http://schemas.microsoft.com/office/drawing/2014/main" id="{F439364C-CC2B-48A9-A56D-179AFDF1F630}"/>
               </a:ext>
             </a:extLst>
           </p:cNvPr>
@@ -4021,7 +4021,7 @@
           <p:cNvPr id="4" name="">
             <a:extLst xmlns:a="http://schemas.openxmlformats.org/drawingml/2006/main">
               <a:ext uri="{FF2B5EF4-FFF2-40B4-BE49-F238E27FC236}">
-                <a16:creationId xmlns:a16="http://schemas.microsoft.com/office/drawing/2014/main" id="{B935DC27-9F72-47AF-A0D0-8DA7A31B4F05}"/>
+                <a16:creationId xmlns:a16="http://schemas.microsoft.com/office/drawing/2014/main" id="{25161635-B755-4F01-8467-8C852669BCDC}"/>
               </a:ext>
             </a:extLst>
           </p:cNvPr>
@@ -4071,7 +4071,7 @@
           <p:cNvPr id="5" name="">
             <a:extLst xmlns:a="http://schemas.openxmlformats.org/drawingml/2006/main">
               <a:ext uri="{FF2B5EF4-FFF2-40B4-BE49-F238E27FC236}">
-                <a16:creationId xmlns:a16="http://schemas.microsoft.com/office/drawing/2014/main" id="{AE356243-7A2D-4257-A861-9F466165C3AA}"/>
+                <a16:creationId xmlns:a16="http://schemas.microsoft.com/office/drawing/2014/main" id="{B02CD8AD-5253-4AFF-A810-D510D5A0075A}"/>
               </a:ext>
             </a:extLst>
           </p:cNvPr>
@@ -4121,7 +4121,7 @@
           <p:cNvPr id="6" name="">
             <a:extLst xmlns:a="http://schemas.openxmlformats.org/drawingml/2006/main">
               <a:ext uri="{FF2B5EF4-FFF2-40B4-BE49-F238E27FC236}">
-                <a16:creationId xmlns:a16="http://schemas.microsoft.com/office/drawing/2014/main" id="{D09BA472-6DB6-4FB3-890C-0D2A3CFA647A}"/>
+                <a16:creationId xmlns:a16="http://schemas.microsoft.com/office/drawing/2014/main" id="{E6D29A90-9C24-4A07-A361-8B39AA3F285D}"/>
               </a:ext>
             </a:extLst>
           </p:cNvPr>
@@ -4188,7 +4188,7 @@
           <p:cNvPr id="7" name="">
             <a:extLst xmlns:a="http://schemas.openxmlformats.org/drawingml/2006/main">
               <a:ext uri="{FF2B5EF4-FFF2-40B4-BE49-F238E27FC236}">
-                <a16:creationId xmlns:a16="http://schemas.microsoft.com/office/drawing/2014/main" id="{5300F67B-948E-4AB5-9C76-DC2801D53CCD}"/>
+                <a16:creationId xmlns:a16="http://schemas.microsoft.com/office/drawing/2014/main" id="{7A531864-4D6D-4F49-AD37-5E6E6CCD3BB8}"/>
               </a:ext>
             </a:extLst>
           </p:cNvPr>
@@ -4223,7 +4223,7 @@
           <p:cNvPr id="8" name="">
             <a:extLst xmlns:a="http://schemas.openxmlformats.org/drawingml/2006/main">
               <a:ext uri="{FF2B5EF4-FFF2-40B4-BE49-F238E27FC236}">
-                <a16:creationId xmlns:a16="http://schemas.microsoft.com/office/drawing/2014/main" id="{D3A7EBBA-2EA2-4E17-82D9-E7CE1896DFBD}"/>
+                <a16:creationId xmlns:a16="http://schemas.microsoft.com/office/drawing/2014/main" id="{3EDAA928-AAC4-41B0-9F02-9AE5B656D8E8}"/>
               </a:ext>
             </a:extLst>
           </p:cNvPr>
@@ -4273,7 +4273,7 @@
           <p:cNvPr id="9" name="">
             <a:extLst xmlns:a="http://schemas.openxmlformats.org/drawingml/2006/main">
               <a:ext uri="{FF2B5EF4-FFF2-40B4-BE49-F238E27FC236}">
-                <a16:creationId xmlns:a16="http://schemas.microsoft.com/office/drawing/2014/main" id="{E40502D9-2334-47CD-826E-A9ABC7C5CF6B}"/>
+                <a16:creationId xmlns:a16="http://schemas.microsoft.com/office/drawing/2014/main" id="{1BD31623-3DA2-45E4-9DB2-6C29234E48FF}"/>
               </a:ext>
             </a:extLst>
           </p:cNvPr>
@@ -4323,7 +4323,7 @@
           <p:cNvPr id="10" name="">
             <a:extLst xmlns:a="http://schemas.openxmlformats.org/drawingml/2006/main">
               <a:ext uri="{FF2B5EF4-FFF2-40B4-BE49-F238E27FC236}">
-                <a16:creationId xmlns:a16="http://schemas.microsoft.com/office/drawing/2014/main" id="{2F5BDA1D-FF39-4E0B-8D35-473D5EAFD7EE}"/>
+                <a16:creationId xmlns:a16="http://schemas.microsoft.com/office/drawing/2014/main" id="{534B2C6F-5F22-4134-9AF9-0023BA14C031}"/>
               </a:ext>
             </a:extLst>
           </p:cNvPr>
@@ -4362,7 +4362,7 @@
           <p:nvPr/>
         </p:nvPicPr>
         <p:blipFill>
-          <a:blip xmlns:r="http://schemas.openxmlformats.org/officeDocument/2006/relationships" xmlns:a="http://schemas.openxmlformats.org/drawingml/2006/main" r:embed="R3da3a78e3ca14d7e"/>
+          <a:blip xmlns:r="http://schemas.openxmlformats.org/officeDocument/2006/relationships" xmlns:a="http://schemas.openxmlformats.org/drawingml/2006/main" r:embed="R3357348993da48ca"/>
           <a:stretch xmlns:a="http://schemas.openxmlformats.org/drawingml/2006/main"/>
         </p:blipFill>
         <p:spPr>
@@ -4382,7 +4382,7 @@
           <p:cNvPr id="12" name="">
             <a:extLst xmlns:a="http://schemas.openxmlformats.org/drawingml/2006/main">
               <a:ext uri="{FF2B5EF4-FFF2-40B4-BE49-F238E27FC236}">
-                <a16:creationId xmlns:a16="http://schemas.microsoft.com/office/drawing/2014/main" id="{1969C018-1A7F-4D38-9BB6-6F692A9009DD}"/>
+                <a16:creationId xmlns:a16="http://schemas.microsoft.com/office/drawing/2014/main" id="{54F614FC-93CB-4D6B-A451-EB89FE2289EE}"/>
               </a:ext>
             </a:extLst>
           </p:cNvPr>
@@ -4430,7 +4430,7 @@
     </p:spTree>
     <p:extLst>
       <p:ext uri="{BB962C8B-B14F-4D97-AF65-F5344CB8AC3E}">
-        <p14:creationId xmlns:p14="http://schemas.microsoft.com/office/powerpoint/2010/main" val="741113632"/>
+        <p14:creationId xmlns:p14="http://schemas.microsoft.com/office/powerpoint/2010/main" val="710541749"/>
       </p:ext>
     </p:extLst>
   </p:cSld>
@@ -4461,7 +4461,7 @@
           <p:cNvPr id="17" name="">
             <a:extLst xmlns:a="http://schemas.openxmlformats.org/drawingml/2006/main">
               <a:ext uri="{FF2B5EF4-FFF2-40B4-BE49-F238E27FC236}">
-                <a16:creationId xmlns:a16="http://schemas.microsoft.com/office/drawing/2014/main" id="{E3F5F057-E21B-4E83-92A9-9AA625CCB6B9}"/>
+                <a16:creationId xmlns:a16="http://schemas.microsoft.com/office/drawing/2014/main" id="{09531056-4466-4C34-88CD-0C1646D3524E}"/>
               </a:ext>
             </a:extLst>
           </p:cNvPr>
@@ -4511,7 +4511,7 @@
           <p:cNvPr id="2" name="">
             <a:extLst xmlns:a="http://schemas.openxmlformats.org/drawingml/2006/main">
               <a:ext uri="{FF2B5EF4-FFF2-40B4-BE49-F238E27FC236}">
-                <a16:creationId xmlns:a16="http://schemas.microsoft.com/office/drawing/2014/main" id="{2CEAF55D-F4ED-47E7-AFFF-2B61D0B8C5EE}"/>
+                <a16:creationId xmlns:a16="http://schemas.microsoft.com/office/drawing/2014/main" id="{66E6DC16-EC70-4B19-B9FB-D67204421C61}"/>
               </a:ext>
             </a:extLst>
           </p:cNvPr>
@@ -4551,7 +4551,7 @@
                   <a:srgbClr val="13251F"/>
                 </a:solidFill>
               </a:rPr>
-              <a:t>필요한 요약만 읽고, 선택할 때 실행됩니다</a:t>
+              <a:t>필요한 요약만 읽고, 한 번에 답합니다</a:t>
             </a:r>
           </a:p>
         </p:txBody>
@@ -4561,7 +4561,7 @@
           <p:cNvPr id="3" name="">
             <a:extLst xmlns:a="http://schemas.openxmlformats.org/drawingml/2006/main">
               <a:ext uri="{FF2B5EF4-FFF2-40B4-BE49-F238E27FC236}">
-                <a16:creationId xmlns:a16="http://schemas.microsoft.com/office/drawing/2014/main" id="{971C83A3-2570-40FE-A5AE-9C2EA3A983D3}"/>
+                <a16:creationId xmlns:a16="http://schemas.microsoft.com/office/drawing/2014/main" id="{98CEE64A-2CCE-4C55-9030-42916FF0E62C}"/>
               </a:ext>
             </a:extLst>
           </p:cNvPr>
@@ -4611,7 +4611,7 @@
           <p:cNvPr id="4" name="">
             <a:extLst xmlns:a="http://schemas.openxmlformats.org/drawingml/2006/main">
               <a:ext uri="{FF2B5EF4-FFF2-40B4-BE49-F238E27FC236}">
-                <a16:creationId xmlns:a16="http://schemas.microsoft.com/office/drawing/2014/main" id="{359B9BB4-E73C-455B-A6CE-3D90DD7E398C}"/>
+                <a16:creationId xmlns:a16="http://schemas.microsoft.com/office/drawing/2014/main" id="{B3161915-43D0-43FD-9EF3-B9710AAFD061}"/>
               </a:ext>
             </a:extLst>
           </p:cNvPr>
@@ -4646,7 +4646,7 @@
           <p:cNvPr id="5" name="">
             <a:extLst xmlns:a="http://schemas.openxmlformats.org/drawingml/2006/main">
               <a:ext uri="{FF2B5EF4-FFF2-40B4-BE49-F238E27FC236}">
-                <a16:creationId xmlns:a16="http://schemas.microsoft.com/office/drawing/2014/main" id="{4463F7C5-C26F-43DF-BF9E-4B0BEE176CE7}"/>
+                <a16:creationId xmlns:a16="http://schemas.microsoft.com/office/drawing/2014/main" id="{CCAFEE92-5119-4530-89C7-B4186F9F627A}"/>
               </a:ext>
             </a:extLst>
           </p:cNvPr>
@@ -4686,7 +4686,7 @@
                   <a:srgbClr val="13251F"/>
                 </a:solidFill>
               </a:rPr>
-              <a:t>브라우저</a:t>
+              <a:t>먼저 정리</a:t>
             </a:r>
           </a:p>
         </p:txBody>
@@ -4696,7 +4696,7 @@
           <p:cNvPr id="6" name="">
             <a:extLst xmlns:a="http://schemas.openxmlformats.org/drawingml/2006/main">
               <a:ext uri="{FF2B5EF4-FFF2-40B4-BE49-F238E27FC236}">
-                <a16:creationId xmlns:a16="http://schemas.microsoft.com/office/drawing/2014/main" id="{C9B2E4FA-05E6-4642-835C-23E563E75AED}"/>
+                <a16:creationId xmlns:a16="http://schemas.microsoft.com/office/drawing/2014/main" id="{A20699FB-F7AC-40E1-A8BC-4B74ACDC8242}"/>
               </a:ext>
             </a:extLst>
           </p:cNvPr>
@@ -4736,7 +4736,7 @@
                   <a:srgbClr val="13251F"/>
                 </a:solidFill>
               </a:rPr>
-              <a:t>결제처 통합·분류</a:t>
+              <a:t>결제처를 하나로 묶고</a:t>
             </a:r>
           </a:p>
           <a:p xmlns:a="http://schemas.openxmlformats.org/drawingml/2006/main">
@@ -4753,7 +4753,7 @@
                   <a:srgbClr val="13251F"/>
                 </a:solidFill>
               </a:rPr>
-              <a:t>주기·금액·신뢰도</a:t>
+              <a:t>반복 주기와 금액을 확인</a:t>
             </a:r>
           </a:p>
           <a:p xmlns:a="http://schemas.openxmlformats.org/drawingml/2006/main">
@@ -4770,7 +4770,7 @@
                   <a:srgbClr val="13251F"/>
                 </a:solidFill>
               </a:rPr>
-              <a:t>민감정보 제거</a:t>
+              <a:t>필요한 정보만 남깁니다</a:t>
             </a:r>
           </a:p>
         </p:txBody>
@@ -4780,7 +4780,7 @@
           <p:cNvPr id="7" name="">
             <a:extLst xmlns:a="http://schemas.openxmlformats.org/drawingml/2006/main">
               <a:ext uri="{FF2B5EF4-FFF2-40B4-BE49-F238E27FC236}">
-                <a16:creationId xmlns:a16="http://schemas.microsoft.com/office/drawing/2014/main" id="{AC5F2B49-D608-4493-8C41-E4E16BCE4365}"/>
+                <a16:creationId xmlns:a16="http://schemas.microsoft.com/office/drawing/2014/main" id="{352631D3-F146-4C54-8913-AA859F383659}"/>
               </a:ext>
             </a:extLst>
           </p:cNvPr>
@@ -4815,7 +4815,7 @@
           <p:cNvPr id="8" name="">
             <a:extLst xmlns:a="http://schemas.openxmlformats.org/drawingml/2006/main">
               <a:ext uri="{FF2B5EF4-FFF2-40B4-BE49-F238E27FC236}">
-                <a16:creationId xmlns:a16="http://schemas.microsoft.com/office/drawing/2014/main" id="{15B814A6-0B2B-462C-93B8-64572EB0ABB9}"/>
+                <a16:creationId xmlns:a16="http://schemas.microsoft.com/office/drawing/2014/main" id="{F81E1537-DDB0-483E-B0BF-0CDD514D4856}"/>
               </a:ext>
             </a:extLst>
           </p:cNvPr>
@@ -4855,7 +4855,7 @@
                   <a:srgbClr val="13251F"/>
                 </a:solidFill>
               </a:rPr>
-              <a:t>Vercel 함수</a:t>
+              <a:t>AI가 분석</a:t>
             </a:r>
           </a:p>
         </p:txBody>
@@ -4865,7 +4865,7 @@
           <p:cNvPr id="9" name="">
             <a:extLst xmlns:a="http://schemas.openxmlformats.org/drawingml/2006/main">
               <a:ext uri="{FF2B5EF4-FFF2-40B4-BE49-F238E27FC236}">
-                <a16:creationId xmlns:a16="http://schemas.microsoft.com/office/drawing/2014/main" id="{0A85D7C6-081B-48AA-BB7F-98A83218B665}"/>
+                <a16:creationId xmlns:a16="http://schemas.microsoft.com/office/drawing/2014/main" id="{DCD27339-6054-439F-A54E-BE6DA9EFDD93}"/>
               </a:ext>
             </a:extLst>
           </p:cNvPr>
@@ -4905,7 +4905,7 @@
                   <a:srgbClr val="13251F"/>
                 </a:solidFill>
               </a:rPr>
-              <a:t>Gemini API 호출</a:t>
+              <a:t>전체 후보를 한 번에 분석</a:t>
             </a:r>
           </a:p>
           <a:p xmlns:a="http://schemas.openxmlformats.org/drawingml/2006/main">
@@ -4922,7 +4922,7 @@
                   <a:srgbClr val="13251F"/>
                 </a:solidFill>
               </a:rPr>
-              <a:t>API 키 서버 보관</a:t>
+              <a:t>왜 구독 후보인지 설명</a:t>
             </a:r>
           </a:p>
           <a:p xmlns:a="http://schemas.openxmlformats.org/drawingml/2006/main">
@@ -4939,7 +4939,7 @@
                   <a:srgbClr val="13251F"/>
                 </a:solidFill>
               </a:rPr>
-              <a:t>요약값만 전달</a:t>
+              <a:t>우선순위와 절약액 제안</a:t>
             </a:r>
           </a:p>
         </p:txBody>
@@ -4949,7 +4949,7 @@
           <p:cNvPr id="10" name="">
             <a:extLst xmlns:a="http://schemas.openxmlformats.org/drawingml/2006/main">
               <a:ext uri="{FF2B5EF4-FFF2-40B4-BE49-F238E27FC236}">
-                <a16:creationId xmlns:a16="http://schemas.microsoft.com/office/drawing/2014/main" id="{53C1FC16-480C-4ABE-A1CD-DE5AA47D5ED5}"/>
+                <a16:creationId xmlns:a16="http://schemas.microsoft.com/office/drawing/2014/main" id="{9FEDF1FB-CC63-416E-BB30-3FE5E3867AF9}"/>
               </a:ext>
             </a:extLst>
           </p:cNvPr>
@@ -4984,7 +4984,7 @@
           <p:cNvPr id="11" name="">
             <a:extLst xmlns:a="http://schemas.openxmlformats.org/drawingml/2006/main">
               <a:ext uri="{FF2B5EF4-FFF2-40B4-BE49-F238E27FC236}">
-                <a16:creationId xmlns:a16="http://schemas.microsoft.com/office/drawing/2014/main" id="{DB2E6908-C145-472E-94BF-3A22CAC821C9}"/>
+                <a16:creationId xmlns:a16="http://schemas.microsoft.com/office/drawing/2014/main" id="{B0F350C8-8E60-4C35-8B97-7BA248B00A2B}"/>
               </a:ext>
             </a:extLst>
           </p:cNvPr>
@@ -5024,7 +5024,7 @@
                   <a:srgbClr val="FFFFFF"/>
                 </a:solidFill>
               </a:rPr>
-              <a:t>후보별 결과</a:t>
+              <a:t>사용자가 결정</a:t>
             </a:r>
           </a:p>
         </p:txBody>
@@ -5034,7 +5034,7 @@
           <p:cNvPr id="12" name="">
             <a:extLst xmlns:a="http://schemas.openxmlformats.org/drawingml/2006/main">
               <a:ext uri="{FF2B5EF4-FFF2-40B4-BE49-F238E27FC236}">
-                <a16:creationId xmlns:a16="http://schemas.microsoft.com/office/drawing/2014/main" id="{64CF7B8D-BA00-48FC-B47B-5AE0BE99811D}"/>
+                <a16:creationId xmlns:a16="http://schemas.microsoft.com/office/drawing/2014/main" id="{1BC216AD-DA1C-43ED-942D-915F5AA9C48D}"/>
               </a:ext>
             </a:extLst>
           </p:cNvPr>
@@ -5074,7 +5074,7 @@
                   <a:srgbClr val="FFFFFF"/>
                 </a:solidFill>
               </a:rPr>
-              <a:t>후보 설명·우선순위</a:t>
+              <a:t>유지·해지예정·모름 선택</a:t>
             </a:r>
           </a:p>
           <a:p xmlns:a="http://schemas.openxmlformats.org/drawingml/2006/main">
@@ -5091,7 +5091,7 @@
                   <a:srgbClr val="FFFFFF"/>
                 </a:solidFill>
               </a:rPr>
-              <a:t>월·1년 절약액</a:t>
+              <a:t>다음 확인 행동 확인</a:t>
             </a:r>
           </a:p>
           <a:p xmlns:a="http://schemas.openxmlformats.org/drawingml/2006/main">
@@ -5108,7 +5108,7 @@
                   <a:srgbClr val="FFFFFF"/>
                 </a:solidFill>
               </a:rPr>
-              <a:t>다음 행동·주의</a:t>
+              <a:t>참고 정보로 활용</a:t>
             </a:r>
           </a:p>
         </p:txBody>
@@ -5118,7 +5118,7 @@
           <p:cNvPr id="13" name="">
             <a:extLst xmlns:a="http://schemas.openxmlformats.org/drawingml/2006/main">
               <a:ext uri="{FF2B5EF4-FFF2-40B4-BE49-F238E27FC236}">
-                <a16:creationId xmlns:a16="http://schemas.microsoft.com/office/drawing/2014/main" id="{459D4F66-4106-40B1-89A0-CD85690870D3}"/>
+                <a16:creationId xmlns:a16="http://schemas.microsoft.com/office/drawing/2014/main" id="{BAEF7082-E1BE-4095-B8A8-8F62BACCDADE}"/>
               </a:ext>
             </a:extLst>
           </p:cNvPr>
@@ -5130,7 +5130,7 @@
         <p:spPr>
           <a:xfrm xmlns:a="http://schemas.openxmlformats.org/drawingml/2006/main">
             <a:off x="685800" y="5067300"/>
-            <a:ext cx="2857500" cy="285750"/>
+            <a:ext cx="3143250" cy="285750"/>
           </a:xfrm>
           <a:prstGeom xmlns:a="http://schemas.openxmlformats.org/drawingml/2006/main" prst="rect">
             <a:avLst/>
@@ -5158,7 +5158,7 @@
                   <a:srgbClr val="118060"/>
                 </a:solidFill>
               </a:rPr>
-              <a:t>원문·카드번호 전송 없음</a:t>
+              <a:t>원문·카드번호는 보내지 않음</a:t>
             </a:r>
           </a:p>
         </p:txBody>
@@ -5168,7 +5168,7 @@
           <p:cNvPr id="14" name="">
             <a:extLst xmlns:a="http://schemas.openxmlformats.org/drawingml/2006/main">
               <a:ext uri="{FF2B5EF4-FFF2-40B4-BE49-F238E27FC236}">
-                <a16:creationId xmlns:a16="http://schemas.microsoft.com/office/drawing/2014/main" id="{CCAB29F8-3839-4C0F-85A6-EF612E0AEE63}"/>
+                <a16:creationId xmlns:a16="http://schemas.microsoft.com/office/drawing/2014/main" id="{E5AE1654-D658-450D-AC9F-9551B32472A5}"/>
               </a:ext>
             </a:extLst>
           </p:cNvPr>
@@ -5208,7 +5208,7 @@
                   <a:srgbClr val="118060"/>
                 </a:solidFill>
               </a:rPr>
-              <a:t>AI 일괄 분석 하루 7회 · 사용량 표시</a:t>
+              <a:t>분석 버튼 한 번 · 하루 7회</a:t>
             </a:r>
           </a:p>
         </p:txBody>
@@ -5218,7 +5218,7 @@
           <p:cNvPr id="15" name="">
             <a:extLst xmlns:a="http://schemas.openxmlformats.org/drawingml/2006/main">
               <a:ext uri="{FF2B5EF4-FFF2-40B4-BE49-F238E27FC236}">
-                <a16:creationId xmlns:a16="http://schemas.microsoft.com/office/drawing/2014/main" id="{DB18EA21-A7D1-4980-A9E7-4A63BBEF7AB7}"/>
+                <a16:creationId xmlns:a16="http://schemas.microsoft.com/office/drawing/2014/main" id="{482ED429-7FF2-4522-A492-DEA7B5B2CC4F}"/>
               </a:ext>
             </a:extLst>
           </p:cNvPr>
@@ -5230,7 +5230,7 @@
         <p:spPr>
           <a:xfrm xmlns:a="http://schemas.openxmlformats.org/drawingml/2006/main">
             <a:off x="7658100" y="5067300"/>
-            <a:ext cx="3048000" cy="285750"/>
+            <a:ext cx="3333750" cy="285750"/>
           </a:xfrm>
           <a:prstGeom xmlns:a="http://schemas.openxmlformats.org/drawingml/2006/main" prst="rect">
             <a:avLst/>
@@ -5258,7 +5258,7 @@
                   <a:srgbClr val="118060"/>
                 </a:solidFill>
               </a:rPr>
-              <a:t>실패 시 로컬 자동 설명으로 계속</a:t>
+              <a:t>AI가 안 되면 기본 분석으로 계속</a:t>
             </a:r>
           </a:p>
         </p:txBody>
@@ -5268,7 +5268,7 @@
           <p:cNvPr id="16" name="">
             <a:extLst xmlns:a="http://schemas.openxmlformats.org/drawingml/2006/main">
               <a:ext uri="{FF2B5EF4-FFF2-40B4-BE49-F238E27FC236}">
-                <a16:creationId xmlns:a16="http://schemas.microsoft.com/office/drawing/2014/main" id="{0848CF01-F855-41C2-8DD6-1305F5F45694}"/>
+                <a16:creationId xmlns:a16="http://schemas.microsoft.com/office/drawing/2014/main" id="{2D5AA3D1-2810-45AF-8B4F-9E66F9A9FB4A}"/>
               </a:ext>
             </a:extLst>
           </p:cNvPr>
@@ -5316,7 +5316,7 @@
     </p:spTree>
     <p:extLst>
       <p:ext uri="{BB962C8B-B14F-4D97-AF65-F5344CB8AC3E}">
-        <p14:creationId xmlns:p14="http://schemas.microsoft.com/office/powerpoint/2010/main" val="920878667"/>
+        <p14:creationId xmlns:p14="http://schemas.microsoft.com/office/powerpoint/2010/main" val="664382841"/>
       </p:ext>
     </p:extLst>
   </p:cSld>
@@ -5347,7 +5347,7 @@
           <p:cNvPr id="13" name="">
             <a:extLst xmlns:a="http://schemas.openxmlformats.org/drawingml/2006/main">
               <a:ext uri="{FF2B5EF4-FFF2-40B4-BE49-F238E27FC236}">
-                <a16:creationId xmlns:a16="http://schemas.microsoft.com/office/drawing/2014/main" id="{A6E8BA05-0CDB-4D23-86C1-425EC01E2BC9}"/>
+                <a16:creationId xmlns:a16="http://schemas.microsoft.com/office/drawing/2014/main" id="{757B058E-734C-4E8D-BDBF-FBF9FBE2B99D}"/>
               </a:ext>
             </a:extLst>
           </p:cNvPr>
@@ -5397,7 +5397,7 @@
           <p:cNvPr id="2" name="">
             <a:extLst xmlns:a="http://schemas.openxmlformats.org/drawingml/2006/main">
               <a:ext uri="{FF2B5EF4-FFF2-40B4-BE49-F238E27FC236}">
-                <a16:creationId xmlns:a16="http://schemas.microsoft.com/office/drawing/2014/main" id="{90A6B022-D8F4-4647-BB32-4DE80285351F}"/>
+                <a16:creationId xmlns:a16="http://schemas.microsoft.com/office/drawing/2014/main" id="{FF531FBD-167A-48D0-9B2E-6E6CD64FC275}"/>
               </a:ext>
             </a:extLst>
           </p:cNvPr>
@@ -5447,7 +5447,7 @@
           <p:cNvPr id="3" name="">
             <a:extLst xmlns:a="http://schemas.openxmlformats.org/drawingml/2006/main">
               <a:ext uri="{FF2B5EF4-FFF2-40B4-BE49-F238E27FC236}">
-                <a16:creationId xmlns:a16="http://schemas.microsoft.com/office/drawing/2014/main" id="{7DFCF1A7-FFB8-4992-8045-3166BD147A3C}"/>
+                <a16:creationId xmlns:a16="http://schemas.microsoft.com/office/drawing/2014/main" id="{4990A1E4-5D5D-4638-8BE5-FB75E83DFEEC}"/>
               </a:ext>
             </a:extLst>
           </p:cNvPr>
@@ -5497,7 +5497,7 @@
           <p:cNvPr id="4" name="">
             <a:extLst xmlns:a="http://schemas.openxmlformats.org/drawingml/2006/main">
               <a:ext uri="{FF2B5EF4-FFF2-40B4-BE49-F238E27FC236}">
-                <a16:creationId xmlns:a16="http://schemas.microsoft.com/office/drawing/2014/main" id="{5066A03E-6442-4207-B2DD-2EA501880683}"/>
+                <a16:creationId xmlns:a16="http://schemas.microsoft.com/office/drawing/2014/main" id="{011863EC-EF96-4940-B154-6091EEFFE530}"/>
               </a:ext>
             </a:extLst>
           </p:cNvPr>
@@ -5532,7 +5532,7 @@
           <p:cNvPr id="5" name="">
             <a:extLst xmlns:a="http://schemas.openxmlformats.org/drawingml/2006/main">
               <a:ext uri="{FF2B5EF4-FFF2-40B4-BE49-F238E27FC236}">
-                <a16:creationId xmlns:a16="http://schemas.microsoft.com/office/drawing/2014/main" id="{4E46AC63-78D7-447D-87D0-848363AD5C3B}"/>
+                <a16:creationId xmlns:a16="http://schemas.microsoft.com/office/drawing/2014/main" id="{D78679EB-44A8-4174-BA12-0AF3975CA442}"/>
               </a:ext>
             </a:extLst>
           </p:cNvPr>
@@ -5582,7 +5582,7 @@
           <p:cNvPr id="6" name="">
             <a:extLst xmlns:a="http://schemas.openxmlformats.org/drawingml/2006/main">
               <a:ext uri="{FF2B5EF4-FFF2-40B4-BE49-F238E27FC236}">
-                <a16:creationId xmlns:a16="http://schemas.microsoft.com/office/drawing/2014/main" id="{2DC2E1B5-12EB-4A3F-9A02-F270F8205FEF}"/>
+                <a16:creationId xmlns:a16="http://schemas.microsoft.com/office/drawing/2014/main" id="{076DC696-903F-4BC8-A28E-30167F0F68F7}"/>
               </a:ext>
             </a:extLst>
           </p:cNvPr>
@@ -5683,7 +5683,7 @@
           <p:cNvPr id="7" name="">
             <a:extLst xmlns:a="http://schemas.openxmlformats.org/drawingml/2006/main">
               <a:ext uri="{FF2B5EF4-FFF2-40B4-BE49-F238E27FC236}">
-                <a16:creationId xmlns:a16="http://schemas.microsoft.com/office/drawing/2014/main" id="{ECBDB7A5-B1A8-45EB-8E37-9123471651C0}"/>
+                <a16:creationId xmlns:a16="http://schemas.microsoft.com/office/drawing/2014/main" id="{64F5E47B-C8A1-4728-9B04-BF9DDD04754D}"/>
               </a:ext>
             </a:extLst>
           </p:cNvPr>
@@ -5733,7 +5733,7 @@
           <p:cNvPr id="8" name="">
             <a:extLst xmlns:a="http://schemas.openxmlformats.org/drawingml/2006/main">
               <a:ext uri="{FF2B5EF4-FFF2-40B4-BE49-F238E27FC236}">
-                <a16:creationId xmlns:a16="http://schemas.microsoft.com/office/drawing/2014/main" id="{05FA36E3-6A48-4166-97C7-70CEFD18AF3F}"/>
+                <a16:creationId xmlns:a16="http://schemas.microsoft.com/office/drawing/2014/main" id="{A7039C5F-F355-4396-A200-624DEBCCDBA3}"/>
               </a:ext>
             </a:extLst>
           </p:cNvPr>
@@ -5783,7 +5783,7 @@
           <p:cNvPr id="9" name="">
             <a:extLst xmlns:a="http://schemas.openxmlformats.org/drawingml/2006/main">
               <a:ext uri="{FF2B5EF4-FFF2-40B4-BE49-F238E27FC236}">
-                <a16:creationId xmlns:a16="http://schemas.microsoft.com/office/drawing/2014/main" id="{00A9AD05-0383-4CBF-8257-A0F947B61B43}"/>
+                <a16:creationId xmlns:a16="http://schemas.microsoft.com/office/drawing/2014/main" id="{B8C62244-3823-42F3-9FA7-94F79EB3D2D8}"/>
               </a:ext>
             </a:extLst>
           </p:cNvPr>
@@ -5867,7 +5867,7 @@
           <p:cNvPr id="10" name="">
             <a:extLst xmlns:a="http://schemas.openxmlformats.org/drawingml/2006/main">
               <a:ext uri="{FF2B5EF4-FFF2-40B4-BE49-F238E27FC236}">
-                <a16:creationId xmlns:a16="http://schemas.microsoft.com/office/drawing/2014/main" id="{856C8A7D-4DB2-414B-903B-54B3D0589B20}"/>
+                <a16:creationId xmlns:a16="http://schemas.microsoft.com/office/drawing/2014/main" id="{C3EA22E5-0A96-4AD5-AA4B-302866910165}"/>
               </a:ext>
             </a:extLst>
           </p:cNvPr>
@@ -5902,7 +5902,7 @@
           <p:cNvPr id="11" name="">
             <a:extLst xmlns:a="http://schemas.openxmlformats.org/drawingml/2006/main">
               <a:ext uri="{FF2B5EF4-FFF2-40B4-BE49-F238E27FC236}">
-                <a16:creationId xmlns:a16="http://schemas.microsoft.com/office/drawing/2014/main" id="{0CDB3665-84C4-4E05-82E1-D6889206BF42}"/>
+                <a16:creationId xmlns:a16="http://schemas.microsoft.com/office/drawing/2014/main" id="{2DDBB93A-00D0-43E3-8050-2CD879808D27}"/>
               </a:ext>
             </a:extLst>
           </p:cNvPr>
@@ -5952,7 +5952,7 @@
           <p:cNvPr id="12" name="">
             <a:extLst xmlns:a="http://schemas.openxmlformats.org/drawingml/2006/main">
               <a:ext uri="{FF2B5EF4-FFF2-40B4-BE49-F238E27FC236}">
-                <a16:creationId xmlns:a16="http://schemas.microsoft.com/office/drawing/2014/main" id="{E6248D1E-4571-41C2-BAD3-CF1FDE16269F}"/>
+                <a16:creationId xmlns:a16="http://schemas.microsoft.com/office/drawing/2014/main" id="{2BD85DD9-0518-4DB8-8A57-050BE92F7486}"/>
               </a:ext>
             </a:extLst>
           </p:cNvPr>
@@ -6000,7 +6000,7 @@
     </p:spTree>
     <p:extLst>
       <p:ext uri="{BB962C8B-B14F-4D97-AF65-F5344CB8AC3E}">
-        <p14:creationId xmlns:p14="http://schemas.microsoft.com/office/powerpoint/2010/main" val="1338036393"/>
+        <p14:creationId xmlns:p14="http://schemas.microsoft.com/office/powerpoint/2010/main" val="201376515"/>
       </p:ext>
     </p:extLst>
   </p:cSld>
@@ -6031,7 +6031,7 @@
           <p:cNvPr id="8" name="">
             <a:extLst xmlns:a="http://schemas.openxmlformats.org/drawingml/2006/main">
               <a:ext uri="{FF2B5EF4-FFF2-40B4-BE49-F238E27FC236}">
-                <a16:creationId xmlns:a16="http://schemas.microsoft.com/office/drawing/2014/main" id="{A56F1C97-27DD-490A-998A-18D58CFA9367}"/>
+                <a16:creationId xmlns:a16="http://schemas.microsoft.com/office/drawing/2014/main" id="{BB6944A5-D28B-4D91-A8F5-54F445AD187F}"/>
               </a:ext>
             </a:extLst>
           </p:cNvPr>
@@ -6081,7 +6081,7 @@
           <p:cNvPr id="2" name="">
             <a:extLst xmlns:a="http://schemas.openxmlformats.org/drawingml/2006/main">
               <a:ext uri="{FF2B5EF4-FFF2-40B4-BE49-F238E27FC236}">
-                <a16:creationId xmlns:a16="http://schemas.microsoft.com/office/drawing/2014/main" id="{01A1E6EB-0BF6-4200-918A-94C50052E2C0}"/>
+                <a16:creationId xmlns:a16="http://schemas.microsoft.com/office/drawing/2014/main" id="{CFAB73F4-9EAC-4B74-8E16-47F4EACFA293}"/>
               </a:ext>
             </a:extLst>
           </p:cNvPr>
@@ -6148,7 +6148,7 @@
           <p:cNvPr id="3" name="">
             <a:extLst xmlns:a="http://schemas.openxmlformats.org/drawingml/2006/main">
               <a:ext uri="{FF2B5EF4-FFF2-40B4-BE49-F238E27FC236}">
-                <a16:creationId xmlns:a16="http://schemas.microsoft.com/office/drawing/2014/main" id="{9D565098-9F47-46A5-A4EE-5126C5C5E26B}"/>
+                <a16:creationId xmlns:a16="http://schemas.microsoft.com/office/drawing/2014/main" id="{DF6DCDBD-537F-44E5-A9A9-B8AD0F20565C}"/>
               </a:ext>
             </a:extLst>
           </p:cNvPr>
@@ -6183,7 +6183,7 @@
           <p:cNvPr id="4" name="">
             <a:extLst xmlns:a="http://schemas.openxmlformats.org/drawingml/2006/main">
               <a:ext uri="{FF2B5EF4-FFF2-40B4-BE49-F238E27FC236}">
-                <a16:creationId xmlns:a16="http://schemas.microsoft.com/office/drawing/2014/main" id="{68BA5EF4-69A0-4022-9E98-4DC17FC1B846}"/>
+                <a16:creationId xmlns:a16="http://schemas.microsoft.com/office/drawing/2014/main" id="{21129233-EE1C-4C07-9140-81FC618DE985}"/>
               </a:ext>
             </a:extLst>
           </p:cNvPr>
@@ -6233,7 +6233,7 @@
           <p:cNvPr id="5" name="">
             <a:extLst xmlns:a="http://schemas.openxmlformats.org/drawingml/2006/main">
               <a:ext uri="{FF2B5EF4-FFF2-40B4-BE49-F238E27FC236}">
-                <a16:creationId xmlns:a16="http://schemas.microsoft.com/office/drawing/2014/main" id="{FFD6E062-30E6-4F51-AA06-E78A0122EEE4}"/>
+                <a16:creationId xmlns:a16="http://schemas.microsoft.com/office/drawing/2014/main" id="{B5E6729C-F702-45C7-8CA8-52A555ADB33B}"/>
               </a:ext>
             </a:extLst>
           </p:cNvPr>
@@ -6283,7 +6283,7 @@
           <p:cNvPr id="6" name="">
             <a:extLst xmlns:a="http://schemas.openxmlformats.org/drawingml/2006/main">
               <a:ext uri="{FF2B5EF4-FFF2-40B4-BE49-F238E27FC236}">
-                <a16:creationId xmlns:a16="http://schemas.microsoft.com/office/drawing/2014/main" id="{53EC7D46-3D13-428E-95A1-65FA30A50CD4}"/>
+                <a16:creationId xmlns:a16="http://schemas.microsoft.com/office/drawing/2014/main" id="{051AC518-B57D-4B8C-9BF1-301E58655FD0}"/>
               </a:ext>
             </a:extLst>
           </p:cNvPr>
@@ -6333,7 +6333,7 @@
           <p:cNvPr id="7" name="">
             <a:extLst xmlns:a="http://schemas.openxmlformats.org/drawingml/2006/main">
               <a:ext uri="{FF2B5EF4-FFF2-40B4-BE49-F238E27FC236}">
-                <a16:creationId xmlns:a16="http://schemas.microsoft.com/office/drawing/2014/main" id="{677B91C9-4EC2-4210-BAF9-41D475683A0C}"/>
+                <a16:creationId xmlns:a16="http://schemas.microsoft.com/office/drawing/2014/main" id="{7A42378E-2330-4098-BD29-FB0D826CEAB4}"/>
               </a:ext>
             </a:extLst>
           </p:cNvPr>
@@ -6381,7 +6381,7 @@
     </p:spTree>
     <p:extLst>
       <p:ext uri="{BB962C8B-B14F-4D97-AF65-F5344CB8AC3E}">
-        <p14:creationId xmlns:p14="http://schemas.microsoft.com/office/powerpoint/2010/main" val="1279958890"/>
+        <p14:creationId xmlns:p14="http://schemas.microsoft.com/office/powerpoint/2010/main" val="1786071683"/>
       </p:ext>
     </p:extLst>
   </p:cSld>

</xml_diff>